<commit_message>
Rebuild Lecture-1-What-is-ML with richer content (36 slides)
Expanded from 25 to 36 slides with deeper coverage: EDA (class imbalance,
statistics, data leakage), the digits dataset, features vs labels, and
what the model actually sees. Content now matches the full lesson depth.
</commit_message>
<xml_diff>
--- a/stage1_classic_ml/01_what_is_ml/Lecture-1-What-is-ML.pptx
+++ b/stage1_classic_ml/01_what_is_ml/Lecture-1-What-is-ML.pptx
@@ -36,6 +36,17 @@
     <p:sldId id="278" r:id="rId34"/>
     <p:sldId id="279" r:id="rId35"/>
     <p:sldId id="280" r:id="rId36"/>
+    <p:sldId id="281" r:id="rId37"/>
+    <p:sldId id="282" r:id="rId38"/>
+    <p:sldId id="283" r:id="rId39"/>
+    <p:sldId id="284" r:id="rId40"/>
+    <p:sldId id="285" r:id="rId41"/>
+    <p:sldId id="286" r:id="rId42"/>
+    <p:sldId id="287" r:id="rId43"/>
+    <p:sldId id="288" r:id="rId44"/>
+    <p:sldId id="289" r:id="rId45"/>
+    <p:sldId id="290" r:id="rId46"/>
+    <p:sldId id="291" r:id="rId47"/>
   </p:sldIdLst>
   <p:sldSz cx="12188825" cy="6858000"/>
   <p:notesSz cx="7010400" cy="9296400"/>
@@ -8420,7 +8431,7 @@
           <a:lstStyle/>
           <a:p>
             <a:r>
-              <a:t>The Learning Loop</a:t>
+              <a:t>Reinforcement Learning — Trial and Error</a:t>
             </a:r>
           </a:p>
         </p:txBody>
@@ -8442,49 +8453,43 @@
           <a:p>
             <a:pPr/>
             <a:r>
-              <a:t>1.  Model makes a prediction on a training sample</a:t>
-            </a:r>
-          </a:p>
-          <a:p>
-            <a:pPr/>
-            <a:r>
-              <a:t>2.  Compare prediction to the correct label — the difference is the loss</a:t>
-            </a:r>
-          </a:p>
-          <a:p>
-            <a:pPr/>
-            <a:r>
-              <a:t>3.  Model adjusts its internal weights slightly to reduce the loss</a:t>
-            </a:r>
-          </a:p>
-          <a:p>
-            <a:pPr/>
-            <a:r>
-              <a:t>4.  Repeat for every sample, thousands of times (epochs)</a:t>
-            </a:r>
-          </a:p>
-          <a:p>
-            <a:pPr/>
-            <a:r>
-              <a:t>After enough repetitions:</a:t>
+              <a:t>The model learns by interacting with an environment</a:t>
+            </a:r>
+          </a:p>
+          <a:p>
+            <a:pPr/>
+            <a:r>
+              <a:t>Receives rewards for correct decisions, penalties for bad ones</a:t>
+            </a:r>
+          </a:p>
+          <a:p>
+            <a:pPr/>
+            <a:r>
+              <a:t>Over time, it develops a strategy that maximises total reward</a:t>
+            </a:r>
+          </a:p>
+          <a:p>
+            <a:pPr/>
+            <a:r>
+              <a:t>Less common in day-to-day security, but growing:</a:t>
             </a:r>
           </a:p>
           <a:p>
             <a:pPr lvl="1"/>
             <a:r>
-              <a:t>Epoch 1:   Loss = 0.92   (mostly guessing)</a:t>
+              <a:t>Automated penetration testing agents</a:t>
             </a:r>
           </a:p>
           <a:p>
             <a:pPr lvl="1"/>
             <a:r>
-              <a:t>Epoch 10:  Loss = 0.41   (learning patterns)</a:t>
-            </a:r>
-          </a:p>
-          <a:p>
-            <a:pPr lvl="1"/>
-            <a:r>
-              <a:t>Epoch 50:  Loss = 0.08   (reliable predictions)</a:t>
+              <a:t>Adaptive threat response systems</a:t>
+            </a:r>
+          </a:p>
+          <a:p>
+            <a:pPr/>
+            <a:r>
+              <a:t>Not covered in this curriculum — but you should know it exists</a:t>
             </a:r>
           </a:p>
         </p:txBody>
@@ -8509,12 +8514,12 @@
       <p:grpSpPr/>
       <p:sp>
         <p:nvSpPr>
-          <p:cNvPr id="2" name="Title 1"/>
+          <p:cNvPr id="2" name="Text Placeholder 1"/>
           <p:cNvSpPr>
             <a:spLocks noGrp="1"/>
           </p:cNvSpPr>
           <p:nvPr>
-            <p:ph type="title"/>
+            <p:ph type="body" idx="13" sz="quarter"/>
           </p:nvPr>
         </p:nvSpPr>
         <p:spPr/>
@@ -8523,19 +8528,24 @@
           <a:lstStyle/>
           <a:p>
             <a:r>
-              <a:t>Key Terms: Weights and Loss</a:t>
-            </a:r>
-          </a:p>
-        </p:txBody>
-      </p:sp>
-      <p:sp>
-        <p:nvSpPr>
-          <p:cNvPr id="3" name="Content Placeholder 2"/>
+              <a:t>How a Model</a:t>
+            </a:r>
+          </a:p>
+          <a:p>
+            <a:r>
+              <a:t>Actually Learns</a:t>
+            </a:r>
+          </a:p>
+        </p:txBody>
+      </p:sp>
+      <p:sp>
+        <p:nvSpPr>
+          <p:cNvPr id="3" name="Text Placeholder 2"/>
           <p:cNvSpPr>
             <a:spLocks noGrp="1"/>
           </p:cNvSpPr>
           <p:nvPr>
-            <p:ph idx="1"/>
+            <p:ph type="body" idx="16" sz="quarter"/>
           </p:nvPr>
         </p:nvSpPr>
         <p:spPr/>
@@ -8543,45 +8553,8 @@
           <a:bodyPr/>
           <a:lstStyle/>
           <a:p>
-            <a:pPr/>
-            <a:r>
-              <a:t>Weights — the numbers inside the model</a:t>
-            </a:r>
-          </a:p>
-          <a:p>
-            <a:pPr lvl="1"/>
-            <a:r>
-              <a:t>Adjusted during training to minimise loss</a:t>
-            </a:r>
-          </a:p>
-          <a:p>
-            <a:pPr lvl="1"/>
-            <a:r>
-              <a:t>Encode learned patterns like: 'many links + young domain → spam'</a:t>
-            </a:r>
-          </a:p>
-          <a:p>
-            <a:pPr/>
-            <a:r>
-              <a:t>Loss — how wrong the model's predictions are</a:t>
-            </a:r>
-          </a:p>
-          <a:p>
-            <a:pPr lvl="1"/>
-            <a:r>
-              <a:t>Training = finding weights that minimise loss</a:t>
-            </a:r>
-          </a:p>
-          <a:p>
-            <a:pPr/>
-            <a:r>
-              <a:t>You don't write any of this — the ML library handles it</a:t>
-            </a:r>
-          </a:p>
-          <a:p>
-            <a:pPr lvl="1"/>
-            <a:r>
-              <a:t>Understanding it helps you debug when things go wrong</a:t>
+            <a:r>
+              <a:t>03</a:t>
             </a:r>
           </a:p>
         </p:txBody>
@@ -8606,12 +8579,12 @@
       <p:grpSpPr/>
       <p:sp>
         <p:nvSpPr>
-          <p:cNvPr id="2" name="Text Placeholder 1"/>
+          <p:cNvPr id="2" name="Title 1"/>
           <p:cNvSpPr>
             <a:spLocks noGrp="1"/>
           </p:cNvSpPr>
           <p:nvPr>
-            <p:ph type="body" idx="13" sz="quarter"/>
+            <p:ph type="title"/>
           </p:nvPr>
         </p:nvSpPr>
         <p:spPr/>
@@ -8620,19 +8593,19 @@
           <a:lstStyle/>
           <a:p>
             <a:r>
-              <a:t>The ML Workflow</a:t>
-            </a:r>
-          </a:p>
-        </p:txBody>
-      </p:sp>
-      <p:sp>
-        <p:nvSpPr>
-          <p:cNvPr id="3" name="Text Placeholder 2"/>
+              <a:t>The Learning Loop — What Happens Inside model.fit()</a:t>
+            </a:r>
+          </a:p>
+        </p:txBody>
+      </p:sp>
+      <p:sp>
+        <p:nvSpPr>
+          <p:cNvPr id="3" name="Content Placeholder 2"/>
           <p:cNvSpPr>
             <a:spLocks noGrp="1"/>
           </p:cNvSpPr>
           <p:nvPr>
-            <p:ph type="body" idx="16" sz="quarter"/>
+            <p:ph idx="1"/>
           </p:nvPr>
         </p:nvSpPr>
         <p:spPr/>
@@ -8640,8 +8613,45 @@
           <a:bodyPr/>
           <a:lstStyle/>
           <a:p>
-            <a:r>
-              <a:t>04</a:t>
+            <a:pPr/>
+            <a:r>
+              <a:t>1.  The model makes a prediction on a training sample</a:t>
+            </a:r>
+          </a:p>
+          <a:p>
+            <a:pPr/>
+            <a:r>
+              <a:t>2.  Compare prediction to the correct label</a:t>
+            </a:r>
+          </a:p>
+          <a:p>
+            <a:pPr lvl="1"/>
+            <a:r>
+              <a:t>     The difference is called the loss</a:t>
+            </a:r>
+          </a:p>
+          <a:p>
+            <a:pPr/>
+            <a:r>
+              <a:t>3.  The model adjusts its internal numbers (weights) to reduce the loss</a:t>
+            </a:r>
+          </a:p>
+          <a:p>
+            <a:pPr/>
+            <a:r>
+              <a:t>4.  Repeat for every sample — one full pass = one epoch</a:t>
+            </a:r>
+          </a:p>
+          <a:p>
+            <a:pPr/>
+            <a:r>
+              <a:t>After enough epochs, the weights settle into values that</a:t>
+            </a:r>
+          </a:p>
+          <a:p>
+            <a:pPr/>
+            <a:r>
+              <a:t>produce correct predictions on data the model has never seen</a:t>
             </a:r>
           </a:p>
         </p:txBody>
@@ -8680,7 +8690,7 @@
           <a:lstStyle/>
           <a:p>
             <a:r>
-              <a:t>The ML Workflow — Every Project Follows This Loop</a:t>
+              <a:t>Watching the Loss Drop</a:t>
             </a:r>
           </a:p>
         </p:txBody>
@@ -8702,49 +8712,55 @@
           <a:p>
             <a:pPr/>
             <a:r>
-              <a:t>1.  Get data</a:t>
-            </a:r>
-          </a:p>
-          <a:p>
-            <a:pPr/>
-            <a:r>
-              <a:t>2.  Clean and prepare it</a:t>
-            </a:r>
-          </a:p>
-          <a:p>
-            <a:pPr/>
-            <a:r>
-              <a:t>3.  Explore the data (EDA)</a:t>
-            </a:r>
-          </a:p>
-          <a:p>
-            <a:pPr/>
-            <a:r>
-              <a:t>4.  Split into training set and test set</a:t>
-            </a:r>
-          </a:p>
-          <a:p>
-            <a:pPr/>
-            <a:r>
-              <a:t>5.  Train the model on the training set</a:t>
-            </a:r>
-          </a:p>
-          <a:p>
-            <a:pPr/>
-            <a:r>
-              <a:t>6.  Evaluate on the test set</a:t>
-            </a:r>
-          </a:p>
-          <a:p>
-            <a:pPr/>
-            <a:r>
-              <a:t>7.  Tune → repeat from step 5</a:t>
-            </a:r>
-          </a:p>
-          <a:p>
-            <a:pPr/>
-            <a:r>
-              <a:t>8.  Deploy / use</a:t>
+              <a:t>Epoch 1:    Loss = 0.92   (model is mostly guessing)</a:t>
+            </a:r>
+          </a:p>
+          <a:p>
+            <a:pPr/>
+            <a:r>
+              <a:t>Epoch 10:   Loss = 0.41   (model is learning patterns)</a:t>
+            </a:r>
+          </a:p>
+          <a:p>
+            <a:pPr/>
+            <a:r>
+              <a:t>Epoch 50:   Loss = 0.08   (model is now reliable)</a:t>
+            </a:r>
+          </a:p>
+          <a:p>
+            <a:pPr/>
+            <a:r>
+              <a:t>Loss is a single number measuring "how wrong are we?"</a:t>
+            </a:r>
+          </a:p>
+          <a:p>
+            <a:pPr/>
+            <a:r>
+              <a:t>Training = finding the weights that minimise this number</a:t>
+            </a:r>
+          </a:p>
+          <a:p>
+            <a:pPr/>
+            <a:r>
+              <a:t>Weights — the numbers inside the model, adjusted during training</a:t>
+            </a:r>
+          </a:p>
+          <a:p>
+            <a:pPr/>
+            <a:r>
+              <a:t>They encode learned patterns like:</a:t>
+            </a:r>
+          </a:p>
+          <a:p>
+            <a:pPr lvl="1"/>
+            <a:r>
+              <a:t>"emails with many links + young sender domain → spam"</a:t>
+            </a:r>
+          </a:p>
+          <a:p>
+            <a:pPr/>
+            <a:r>
+              <a:t>You don't write any of this — the ML library handles it</a:t>
             </a:r>
           </a:p>
         </p:txBody>
@@ -8769,12 +8785,12 @@
       <p:grpSpPr/>
       <p:sp>
         <p:nvSpPr>
-          <p:cNvPr id="2" name="Title 1"/>
+          <p:cNvPr id="2" name="Text Placeholder 1"/>
           <p:cNvSpPr>
             <a:spLocks noGrp="1"/>
           </p:cNvSpPr>
           <p:nvPr>
-            <p:ph type="title"/>
+            <p:ph type="body" idx="13" sz="quarter"/>
           </p:nvPr>
         </p:nvSpPr>
         <p:spPr/>
@@ -8783,19 +8799,19 @@
           <a:lstStyle/>
           <a:p>
             <a:r>
-              <a:t>Why the Train / Test Split Matters</a:t>
-            </a:r>
-          </a:p>
-        </p:txBody>
-      </p:sp>
-      <p:sp>
-        <p:nvSpPr>
-          <p:cNvPr id="3" name="Content Placeholder 2"/>
+              <a:t>The ML Workflow</a:t>
+            </a:r>
+          </a:p>
+        </p:txBody>
+      </p:sp>
+      <p:sp>
+        <p:nvSpPr>
+          <p:cNvPr id="3" name="Text Placeholder 2"/>
           <p:cNvSpPr>
             <a:spLocks noGrp="1"/>
           </p:cNvSpPr>
           <p:nvPr>
-            <p:ph idx="1"/>
+            <p:ph type="body" idx="16" sz="quarter"/>
           </p:nvPr>
         </p:nvSpPr>
         <p:spPr/>
@@ -8803,45 +8819,8 @@
           <a:bodyPr/>
           <a:lstStyle/>
           <a:p>
-            <a:pPr/>
-            <a:r>
-              <a:t>If you evaluate on the same data you trained on:</a:t>
-            </a:r>
-          </a:p>
-          <a:p>
-            <a:pPr lvl="1"/>
-            <a:r>
-              <a:t>You are measuring memorisation, not generalisation</a:t>
-            </a:r>
-          </a:p>
-          <a:p>
-            <a:pPr lvl="1"/>
-            <a:r>
-              <a:t>A model can score 100% by memorising every example</a:t>
-            </a:r>
-          </a:p>
-          <a:p>
-            <a:pPr/>
-            <a:r>
-              <a:t>The test set is data the model has never seen</a:t>
-            </a:r>
-          </a:p>
-          <a:p>
-            <a:pPr lvl="1"/>
-            <a:r>
-              <a:t>It gives an honest measure of real-world performance</a:t>
-            </a:r>
-          </a:p>
-          <a:p>
-            <a:pPr/>
-            <a:r>
-              <a:t>This is the most important rule in ML:</a:t>
-            </a:r>
-          </a:p>
-          <a:p>
-            <a:pPr lvl="1"/>
-            <a:r>
-              <a:t>Never evaluate on training data</a:t>
+            <a:r>
+              <a:t>04</a:t>
             </a:r>
           </a:p>
         </p:txBody>
@@ -8866,12 +8845,12 @@
       <p:grpSpPr/>
       <p:sp>
         <p:nvSpPr>
-          <p:cNvPr id="2" name="Text Placeholder 1"/>
+          <p:cNvPr id="2" name="Title 1"/>
           <p:cNvSpPr>
             <a:spLocks noGrp="1"/>
           </p:cNvSpPr>
           <p:nvPr>
-            <p:ph type="body" idx="13" sz="quarter"/>
+            <p:ph type="title"/>
           </p:nvPr>
         </p:nvSpPr>
         <p:spPr/>
@@ -8880,24 +8859,19 @@
           <a:lstStyle/>
           <a:p>
             <a:r>
-              <a:t>Exploratory Data</a:t>
-            </a:r>
-          </a:p>
-          <a:p>
-            <a:r>
-              <a:t>Analysis (EDA)</a:t>
-            </a:r>
-          </a:p>
-        </p:txBody>
-      </p:sp>
-      <p:sp>
-        <p:nvSpPr>
-          <p:cNvPr id="3" name="Text Placeholder 2"/>
+              <a:t>The ML Workflow — Every Project Follows This Loop</a:t>
+            </a:r>
+          </a:p>
+        </p:txBody>
+      </p:sp>
+      <p:sp>
+        <p:nvSpPr>
+          <p:cNvPr id="3" name="Content Placeholder 2"/>
           <p:cNvSpPr>
             <a:spLocks noGrp="1"/>
           </p:cNvSpPr>
           <p:nvPr>
-            <p:ph type="body" idx="16" sz="quarter"/>
+            <p:ph idx="1"/>
           </p:nvPr>
         </p:nvSpPr>
         <p:spPr/>
@@ -8905,8 +8879,57 @@
           <a:bodyPr/>
           <a:lstStyle/>
           <a:p>
-            <a:r>
-              <a:t>05</a:t>
+            <a:pPr/>
+            <a:r>
+              <a:t>1.  Get data</a:t>
+            </a:r>
+          </a:p>
+          <a:p>
+            <a:pPr/>
+            <a:r>
+              <a:t>2.  Clean and prepare it</a:t>
+            </a:r>
+          </a:p>
+          <a:p>
+            <a:pPr/>
+            <a:r>
+              <a:t>3.  Explore the data (EDA) — what you are about to learn</a:t>
+            </a:r>
+          </a:p>
+          <a:p>
+            <a:pPr/>
+            <a:r>
+              <a:t>4.  Split into training set and test set</a:t>
+            </a:r>
+          </a:p>
+          <a:p>
+            <a:pPr/>
+            <a:r>
+              <a:t>5.  Train the model on the training set</a:t>
+            </a:r>
+          </a:p>
+          <a:p>
+            <a:pPr/>
+            <a:r>
+              <a:t>6.  Evaluate on the test set</a:t>
+            </a:r>
+          </a:p>
+          <a:p>
+            <a:pPr/>
+            <a:r>
+              <a:t>7.  Tune → repeat from step 5</a:t>
+            </a:r>
+          </a:p>
+          <a:p>
+            <a:pPr/>
+            <a:r>
+              <a:t>8.  Deploy / use</a:t>
+            </a:r>
+          </a:p>
+          <a:p>
+            <a:pPr/>
+            <a:r>
+              <a:t>This loop applies to every ML project you will ever build</a:t>
             </a:r>
           </a:p>
         </p:txBody>
@@ -8945,7 +8968,7 @@
           <a:lstStyle/>
           <a:p>
             <a:r>
-              <a:t>EDA — Examine Your Data Before Training</a:t>
+              <a:t>Why the Train / Test Split Matters</a:t>
             </a:r>
           </a:p>
         </p:txBody>
@@ -8967,43 +8990,49 @@
           <a:p>
             <a:pPr/>
             <a:r>
-              <a:t>Skipping EDA is the #1 reason ML projects fail silently</a:t>
+              <a:t>If you evaluate on the same data you trained on:</a:t>
             </a:r>
           </a:p>
           <a:p>
             <a:pPr lvl="1"/>
             <a:r>
-              <a:t>Model trains without errors, looks reasonable, fails in production</a:t>
-            </a:r>
-          </a:p>
-          <a:p>
-            <a:pPr/>
-            <a:r>
-              <a:t>What you are looking for:</a:t>
+              <a:t>You are measuring memorisation, not generalisation</a:t>
             </a:r>
           </a:p>
           <a:p>
             <a:pPr lvl="1"/>
             <a:r>
-              <a:t>Class balance — how many examples of each class?</a:t>
+              <a:t>A model can score 100% by memorising every example</a:t>
             </a:r>
           </a:p>
           <a:p>
             <a:pPr lvl="1"/>
             <a:r>
-              <a:t>Missing values — gaps in log data, truncated fields</a:t>
+              <a:t>It has learned nothing useful about unseen data</a:t>
+            </a:r>
+          </a:p>
+          <a:p>
+            <a:pPr/>
+            <a:r>
+              <a:t>The test set is data the model has never seen during training</a:t>
             </a:r>
           </a:p>
           <a:p>
             <a:pPr lvl="1"/>
             <a:r>
-              <a:t>Feature distributions — outliers, unexpected ranges</a:t>
+              <a:t>It gives an honest measure of real-world performance</a:t>
+            </a:r>
+          </a:p>
+          <a:p>
+            <a:pPr/>
+            <a:r>
+              <a:t>This is the single most important rule in ML:</a:t>
             </a:r>
           </a:p>
           <a:p>
             <a:pPr lvl="1"/>
             <a:r>
-              <a:t>Data leakage — features that reveal the label</a:t>
+              <a:t>Never evaluate on training data</a:t>
             </a:r>
           </a:p>
         </p:txBody>
@@ -9028,12 +9057,12 @@
       <p:grpSpPr/>
       <p:sp>
         <p:nvSpPr>
-          <p:cNvPr id="2" name="Title 1"/>
+          <p:cNvPr id="2" name="Text Placeholder 1"/>
           <p:cNvSpPr>
             <a:spLocks noGrp="1"/>
           </p:cNvSpPr>
           <p:nvPr>
-            <p:ph type="title"/>
+            <p:ph type="body" idx="13" sz="quarter"/>
           </p:nvPr>
         </p:nvSpPr>
         <p:spPr/>
@@ -9042,19 +9071,24 @@
           <a:lstStyle/>
           <a:p>
             <a:r>
-              <a:t>The Class Imbalance Problem</a:t>
-            </a:r>
-          </a:p>
-        </p:txBody>
-      </p:sp>
-      <p:sp>
-        <p:nvSpPr>
-          <p:cNvPr id="3" name="Content Placeholder 2"/>
+              <a:t>Exploratory Data</a:t>
+            </a:r>
+          </a:p>
+          <a:p>
+            <a:r>
+              <a:t>Analysis (EDA)</a:t>
+            </a:r>
+          </a:p>
+        </p:txBody>
+      </p:sp>
+      <p:sp>
+        <p:nvSpPr>
+          <p:cNvPr id="3" name="Text Placeholder 2"/>
           <p:cNvSpPr>
             <a:spLocks noGrp="1"/>
           </p:cNvSpPr>
           <p:nvPr>
-            <p:ph idx="1"/>
+            <p:ph type="body" idx="16" sz="quarter"/>
           </p:nvPr>
         </p:nvSpPr>
         <p:spPr/>
@@ -9062,51 +9096,8 @@
           <a:bodyPr/>
           <a:lstStyle/>
           <a:p>
-            <a:pPr/>
-            <a:r>
-              <a:t>Typical security dataset:</a:t>
-            </a:r>
-          </a:p>
-          <a:p>
-            <a:pPr lvl="1"/>
-            <a:r>
-              <a:t>Normal traffic:   950,000 connections  (95%)</a:t>
-            </a:r>
-          </a:p>
-          <a:p>
-            <a:pPr lvl="1"/>
-            <a:r>
-              <a:t>Attack traffic:     50,000 connections    (5%)</a:t>
-            </a:r>
-          </a:p>
-          <a:p>
-            <a:pPr/>
-            <a:r>
-              <a:t>A model can achieve 95% accuracy by predicting 'normal' for everything</a:t>
-            </a:r>
-          </a:p>
-          <a:p>
-            <a:pPr lvl="1"/>
-            <a:r>
-              <a:t>It catches zero attacks — but looks great on paper</a:t>
-            </a:r>
-          </a:p>
-          <a:p>
-            <a:pPr/>
-            <a:r>
-              <a:t>This is everywhere in security:</a:t>
-            </a:r>
-          </a:p>
-          <a:p>
-            <a:pPr lvl="1"/>
-            <a:r>
-              <a:t>Malware vs benign files, phishing vs legitimate URLs</a:t>
-            </a:r>
-          </a:p>
-          <a:p>
-            <a:pPr/>
-            <a:r>
-              <a:t>You will learn metrics that handle this in Lesson 1.5</a:t>
+            <a:r>
+              <a:t>05</a:t>
             </a:r>
           </a:p>
         </p:txBody>
@@ -9131,12 +9122,12 @@
       <p:grpSpPr/>
       <p:sp>
         <p:nvSpPr>
-          <p:cNvPr id="2" name="Text Placeholder 1"/>
+          <p:cNvPr id="2" name="Title 1"/>
           <p:cNvSpPr>
             <a:spLocks noGrp="1"/>
           </p:cNvSpPr>
           <p:nvPr>
-            <p:ph type="body" idx="13" sz="quarter"/>
+            <p:ph type="title"/>
           </p:nvPr>
         </p:nvSpPr>
         <p:spPr/>
@@ -9145,24 +9136,19 @@
           <a:lstStyle/>
           <a:p>
             <a:r>
-              <a:t>Vocabulary &amp;</a:t>
-            </a:r>
-          </a:p>
-          <a:p>
-            <a:r>
-              <a:t>Tools</a:t>
-            </a:r>
-          </a:p>
-        </p:txBody>
-      </p:sp>
-      <p:sp>
-        <p:nvSpPr>
-          <p:cNvPr id="3" name="Text Placeholder 2"/>
+              <a:t>EDA — Examine Your Data Before Training Anything</a:t>
+            </a:r>
+          </a:p>
+        </p:txBody>
+      </p:sp>
+      <p:sp>
+        <p:nvSpPr>
+          <p:cNvPr id="3" name="Content Placeholder 2"/>
           <p:cNvSpPr>
             <a:spLocks noGrp="1"/>
           </p:cNvSpPr>
           <p:nvPr>
-            <p:ph type="body" idx="16" sz="quarter"/>
+            <p:ph idx="1"/>
           </p:nvPr>
         </p:nvSpPr>
         <p:spPr/>
@@ -9170,8 +9156,57 @@
           <a:bodyPr/>
           <a:lstStyle/>
           <a:p>
-            <a:r>
-              <a:t>06</a:t>
+            <a:pPr/>
+            <a:r>
+              <a:t>Skipping EDA is the #1 reason ML projects fail silently</a:t>
+            </a:r>
+          </a:p>
+          <a:p>
+            <a:pPr/>
+            <a:r>
+              <a:t>The model trains without errors, produces reasonable numbers...</a:t>
+            </a:r>
+          </a:p>
+          <a:p>
+            <a:pPr/>
+            <a:r>
+              <a:t>...then performs terribly in production</a:t>
+            </a:r>
+          </a:p>
+          <a:p>
+            <a:pPr/>
+            <a:r>
+              <a:t>Because a problem in the data was never caught</a:t>
+            </a:r>
+          </a:p>
+          <a:p>
+            <a:pPr/>
+            <a:r>
+              <a:t>What you are looking for:</a:t>
+            </a:r>
+          </a:p>
+          <a:p>
+            <a:pPr lvl="1"/>
+            <a:r>
+              <a:t>Class balance — how many examples of each class?</a:t>
+            </a:r>
+          </a:p>
+          <a:p>
+            <a:pPr lvl="1"/>
+            <a:r>
+              <a:t>Missing values — gaps in log data, sensors that went offline</a:t>
+            </a:r>
+          </a:p>
+          <a:p>
+            <a:pPr lvl="1"/>
+            <a:r>
+              <a:t>Feature distributions — outliers, unexpected ranges</a:t>
+            </a:r>
+          </a:p>
+          <a:p>
+            <a:pPr lvl="1"/>
+            <a:r>
+              <a:t>Data leakage — features that accidentally reveal the label</a:t>
             </a:r>
           </a:p>
         </p:txBody>
@@ -9210,7 +9245,7 @@
           <a:lstStyle/>
           <a:p>
             <a:r>
-              <a:t>Key Vocabulary</a:t>
+              <a:t>The Class Imbalance Problem</a:t>
             </a:r>
           </a:p>
         </p:txBody>
@@ -9232,49 +9267,61 @@
           <a:p>
             <a:pPr/>
             <a:r>
-              <a:t>Feature — one measurable input (URL length, bytes sent, port number)</a:t>
-            </a:r>
-          </a:p>
-          <a:p>
-            <a:pPr/>
-            <a:r>
-              <a:t>Label / Target — the answer the model predicts (phishing=1, legit=0)</a:t>
-            </a:r>
-          </a:p>
-          <a:p>
-            <a:pPr/>
-            <a:r>
-              <a:t>Sample — one row of data (one URL, one connection, one log entry)</a:t>
-            </a:r>
-          </a:p>
-          <a:p>
-            <a:pPr/>
-            <a:r>
-              <a:t>Training set — the data the model learns from</a:t>
-            </a:r>
-          </a:p>
-          <a:p>
-            <a:pPr/>
-            <a:r>
-              <a:t>Test set — held-back data to evaluate the model honestly</a:t>
-            </a:r>
-          </a:p>
-          <a:p>
-            <a:pPr/>
-            <a:r>
-              <a:t>Loss — how wrong the predictions are (training minimises this)</a:t>
-            </a:r>
-          </a:p>
-          <a:p>
-            <a:pPr/>
-            <a:r>
-              <a:t>Epoch — one full pass through the training data</a:t>
-            </a:r>
-          </a:p>
-          <a:p>
-            <a:pPr/>
-            <a:r>
-              <a:t>Overfitting — model memorised training data but fails on new data</a:t>
+              <a:t>Typical security dataset:</a:t>
+            </a:r>
+          </a:p>
+          <a:p>
+            <a:pPr lvl="1"/>
+            <a:r>
+              <a:t>Normal traffic:   950,000 connections   (95%)</a:t>
+            </a:r>
+          </a:p>
+          <a:p>
+            <a:pPr lvl="1"/>
+            <a:r>
+              <a:t>Attack traffic:     50,000 connections     (5%)</a:t>
+            </a:r>
+          </a:p>
+          <a:p>
+            <a:pPr/>
+            <a:r>
+              <a:t>A model that always predicts "normal":</a:t>
+            </a:r>
+          </a:p>
+          <a:p>
+            <a:pPr lvl="1"/>
+            <a:r>
+              <a:t>Accuracy = 95%</a:t>
+            </a:r>
+          </a:p>
+          <a:p>
+            <a:pPr lvl="1"/>
+            <a:r>
+              <a:t>Attacks caught = 0</a:t>
+            </a:r>
+          </a:p>
+          <a:p>
+            <a:pPr/>
+            <a:r>
+              <a:t>This is the naive accuracy trap — a score you must beat</a:t>
+            </a:r>
+          </a:p>
+          <a:p>
+            <a:pPr/>
+            <a:r>
+              <a:t>It is everywhere in security:</a:t>
+            </a:r>
+          </a:p>
+          <a:p>
+            <a:pPr lvl="1"/>
+            <a:r>
+              <a:t>Network intrusion: 99% normal, 1% attack</a:t>
+            </a:r>
+          </a:p>
+          <a:p>
+            <a:pPr lvl="1"/>
+            <a:r>
+              <a:t>Fraud detection:   99.8% legitimate, 0.2% fraud</a:t>
             </a:r>
           </a:p>
         </p:txBody>
@@ -9320,43 +9367,49 @@
           <a:p>
             <a:pPr/>
             <a:r>
-              <a:t>The three types of ML</a:t>
-            </a:r>
-          </a:p>
-          <a:p>
-            <a:pPr/>
-            <a:r>
-              <a:t>How a model actually learns</a:t>
-            </a:r>
-          </a:p>
-          <a:p>
-            <a:pPr/>
-            <a:r>
-              <a:t>The ML workflow</a:t>
-            </a:r>
-          </a:p>
-          <a:p>
-            <a:pPr/>
-            <a:r>
-              <a:t>Exploratory Data Analysis (EDA)</a:t>
-            </a:r>
-          </a:p>
-          <a:p>
-            <a:pPr/>
-            <a:r>
-              <a:t>Key vocabulary</a:t>
-            </a:r>
-          </a:p>
-          <a:p>
-            <a:pPr/>
-            <a:r>
-              <a:t>Tools and libraries</a:t>
-            </a:r>
-          </a:p>
-          <a:p>
-            <a:pPr/>
-            <a:r>
-              <a:t>Workshop: 5 hands-on exercises</a:t>
+              <a:t>The three types of ML — supervised, unsupervised, reinforcement</a:t>
+            </a:r>
+          </a:p>
+          <a:p>
+            <a:pPr/>
+            <a:r>
+              <a:t>How a model actually learns — weights, loss, epochs</a:t>
+            </a:r>
+          </a:p>
+          <a:p>
+            <a:pPr/>
+            <a:r>
+              <a:t>The ML workflow — the 8-step loop every project follows</a:t>
+            </a:r>
+          </a:p>
+          <a:p>
+            <a:pPr/>
+            <a:r>
+              <a:t>Exploratory Data Analysis (EDA) — why skipping it kills projects</a:t>
+            </a:r>
+          </a:p>
+          <a:p>
+            <a:pPr/>
+            <a:r>
+              <a:t>The dataset: 1,797 handwritten digits, 64 pixel features each</a:t>
+            </a:r>
+          </a:p>
+          <a:p>
+            <a:pPr/>
+            <a:r>
+              <a:t>Features vs labels — the fundamental split</a:t>
+            </a:r>
+          </a:p>
+          <a:p>
+            <a:pPr/>
+            <a:r>
+              <a:t>Key vocabulary and Python tools</a:t>
+            </a:r>
+          </a:p>
+          <a:p>
+            <a:pPr/>
+            <a:r>
+              <a:t>Workshop overview — 5 hands-on exercises</a:t>
             </a:r>
           </a:p>
         </p:txBody>
@@ -9416,7 +9469,7 @@
           <a:lstStyle/>
           <a:p>
             <a:r>
-              <a:t>Python Libraries You Will Use</a:t>
+              <a:t>Statistics Before Modelling</a:t>
             </a:r>
           </a:p>
         </p:txBody>
@@ -9438,43 +9491,55 @@
           <a:p>
             <a:pPr/>
             <a:r>
-              <a:t>NumPy (np) — fast numerical arrays, foundation of all ML in Python</a:t>
-            </a:r>
-          </a:p>
-          <a:p>
-            <a:pPr/>
-            <a:r>
-              <a:t>pandas (pd) — DataFrames for tabular data, like a spreadsheet in code</a:t>
-            </a:r>
-          </a:p>
-          <a:p>
-            <a:pPr/>
-            <a:r>
-              <a:t>Matplotlib (plt) — plotting and visualisation</a:t>
-            </a:r>
-          </a:p>
-          <a:p>
-            <a:pPr/>
-            <a:r>
-              <a:t>scikit-learn (sklearn) — ML algorithms, datasets, evaluation tools</a:t>
-            </a:r>
-          </a:p>
-          <a:p>
-            <a:pPr/>
-            <a:r>
-              <a:t>These four libraries appear in every lesson</a:t>
-            </a:r>
-          </a:p>
-          <a:p>
-            <a:pPr/>
-            <a:r>
-              <a:t>All are installed via pip:</a:t>
+              <a:t>df.describe() summarises every column in one call:</a:t>
             </a:r>
           </a:p>
           <a:p>
             <a:pPr lvl="1"/>
             <a:r>
-              <a:t>pip install pandas scikit-learn matplotlib seaborn numpy</a:t>
+              <a:t>count — how many non-null values (are there gaps?)</a:t>
+            </a:r>
+          </a:p>
+          <a:p>
+            <a:pPr lvl="1"/>
+            <a:r>
+              <a:t>mean, std — average and spread (is the feature useful?)</a:t>
+            </a:r>
+          </a:p>
+          <a:p>
+            <a:pPr lvl="1"/>
+            <a:r>
+              <a:t>min, max — are there impossible values? outliers?</a:t>
+            </a:r>
+          </a:p>
+          <a:p>
+            <a:pPr/>
+            <a:r>
+              <a:t>What the statistics catch:</a:t>
+            </a:r>
+          </a:p>
+          <a:p>
+            <a:pPr lvl="1"/>
+            <a:r>
+              <a:t>Zero-variance features (std = 0) → carries no information → remove it</a:t>
+            </a:r>
+          </a:p>
+          <a:p>
+            <a:pPr lvl="1"/>
+            <a:r>
+              <a:t>Wildly different scales → algorithms like KNN will break</a:t>
+            </a:r>
+          </a:p>
+          <a:p>
+            <a:pPr lvl="1"/>
+            <a:r>
+              <a:t>Missing values → NaN propagation → silent wrong predictions</a:t>
+            </a:r>
+          </a:p>
+          <a:p>
+            <a:pPr/>
+            <a:r>
+              <a:t>In security data, all of these are common</a:t>
             </a:r>
           </a:p>
         </p:txBody>
@@ -9499,12 +9564,12 @@
       <p:grpSpPr/>
       <p:sp>
         <p:nvSpPr>
-          <p:cNvPr id="2" name="Text Placeholder 1"/>
+          <p:cNvPr id="2" name="Title 1"/>
           <p:cNvSpPr>
             <a:spLocks noGrp="1"/>
           </p:cNvSpPr>
           <p:nvPr>
-            <p:ph type="body" idx="13" sz="quarter"/>
+            <p:ph type="title"/>
           </p:nvPr>
         </p:nvSpPr>
         <p:spPr/>
@@ -9513,24 +9578,19 @@
           <a:lstStyle/>
           <a:p>
             <a:r>
-              <a:t>Workshop</a:t>
-            </a:r>
-          </a:p>
-          <a:p>
-            <a:r>
-              <a:t>5 Hands-On Exercises</a:t>
-            </a:r>
-          </a:p>
-        </p:txBody>
-      </p:sp>
-      <p:sp>
-        <p:nvSpPr>
-          <p:cNvPr id="3" name="Text Placeholder 2"/>
+              <a:t>Data Leakage — The Subtle Killer</a:t>
+            </a:r>
+          </a:p>
+        </p:txBody>
+      </p:sp>
+      <p:sp>
+        <p:nvSpPr>
+          <p:cNvPr id="3" name="Content Placeholder 2"/>
           <p:cNvSpPr>
             <a:spLocks noGrp="1"/>
           </p:cNvSpPr>
           <p:nvPr>
-            <p:ph type="body" idx="16" sz="quarter"/>
+            <p:ph idx="1"/>
           </p:nvPr>
         </p:nvSpPr>
         <p:spPr/>
@@ -9538,8 +9598,51 @@
           <a:bodyPr/>
           <a:lstStyle/>
           <a:p>
-            <a:r>
-              <a:t>07</a:t>
+            <a:pPr/>
+            <a:r>
+              <a:t>Sometimes a feature contains information about the label</a:t>
+            </a:r>
+          </a:p>
+          <a:p>
+            <a:pPr/>
+            <a:r>
+              <a:t>that would not be available at prediction time</a:t>
+            </a:r>
+          </a:p>
+          <a:p>
+            <a:pPr/>
+            <a:r>
+              <a:t>Example: a column "was_flagged_by_ids"</a:t>
+            </a:r>
+          </a:p>
+          <a:p>
+            <a:pPr lvl="1"/>
+            <a:r>
+              <a:t>Makes the model look perfect during training</a:t>
+            </a:r>
+          </a:p>
+          <a:p>
+            <a:pPr lvl="1"/>
+            <a:r>
+              <a:t>But this column would never exist on live traffic</a:t>
+            </a:r>
+          </a:p>
+          <a:p>
+            <a:pPr/>
+            <a:r>
+              <a:t>The model learned a shortcut, not the real pattern</a:t>
+            </a:r>
+          </a:p>
+          <a:p>
+            <a:pPr/>
+            <a:r>
+              <a:t>Always ask: "Would I have this feature at prediction time?"</a:t>
+            </a:r>
+          </a:p>
+          <a:p>
+            <a:pPr/>
+            <a:r>
+              <a:t>If the answer is no, remove it before training</a:t>
             </a:r>
           </a:p>
         </p:txBody>
@@ -9564,12 +9667,12 @@
       <p:grpSpPr/>
       <p:sp>
         <p:nvSpPr>
-          <p:cNvPr id="2" name="Title 1"/>
+          <p:cNvPr id="2" name="Text Placeholder 1"/>
           <p:cNvSpPr>
             <a:spLocks noGrp="1"/>
           </p:cNvSpPr>
           <p:nvPr>
-            <p:ph type="title"/>
+            <p:ph type="body" idx="13" sz="quarter"/>
           </p:nvPr>
         </p:nvSpPr>
         <p:spPr/>
@@ -9578,19 +9681,24 @@
           <a:lstStyle/>
           <a:p>
             <a:r>
-              <a:t>Workshop — Exploratory Data Analysis</a:t>
-            </a:r>
-          </a:p>
-        </p:txBody>
-      </p:sp>
-      <p:sp>
-        <p:nvSpPr>
-          <p:cNvPr id="3" name="Content Placeholder 2"/>
+              <a:t>The Dataset:</a:t>
+            </a:r>
+          </a:p>
+          <a:p>
+            <a:r>
+              <a:t>Handwritten Digits</a:t>
+            </a:r>
+          </a:p>
+        </p:txBody>
+      </p:sp>
+      <p:sp>
+        <p:nvSpPr>
+          <p:cNvPr id="3" name="Text Placeholder 2"/>
           <p:cNvSpPr>
             <a:spLocks noGrp="1"/>
           </p:cNvSpPr>
           <p:nvPr>
-            <p:ph idx="1"/>
+            <p:ph type="body" idx="16" sz="quarter"/>
           </p:nvPr>
         </p:nvSpPr>
         <p:spPr/>
@@ -9598,51 +9706,8 @@
           <a:bodyPr/>
           <a:lstStyle/>
           <a:p>
-            <a:pPr/>
-            <a:r>
-              <a:t>Exercise 1: Loading a dataset — Bunch objects, DataFrames, features vs labels</a:t>
-            </a:r>
-          </a:p>
-          <a:p>
-            <a:pPr/>
-            <a:r>
-              <a:t>Exercise 2: Shape and statistics — .describe(), missing values, zero-variance</a:t>
-            </a:r>
-          </a:p>
-          <a:p>
-            <a:pPr/>
-            <a:r>
-              <a:t>Exercise 3: Class balance — the naive accuracy trap, imbalance ratio</a:t>
-            </a:r>
-          </a:p>
-          <a:p>
-            <a:pPr/>
-            <a:r>
-              <a:t>Exercise 4: Visualising data — image grids, average prototypes</a:t>
-            </a:r>
-          </a:p>
-          <a:p>
-            <a:pPr/>
-            <a:r>
-              <a:t>Exercise 5: What the model sees — number grids, correlations, security analogy</a:t>
-            </a:r>
-          </a:p>
-          <a:p>
-            <a:pPr/>
-            <a:r>
-              <a:t>Each exercise has:</a:t>
-            </a:r>
-          </a:p>
-          <a:p>
-            <a:pPr lvl="1"/>
-            <a:r>
-              <a:t>lecture.md — concept explanation (read first)</a:t>
-            </a:r>
-          </a:p>
-          <a:p>
-            <a:pPr lvl="1"/>
-            <a:r>
-              <a:t>handson.md — step-by-step lab instructions</a:t>
+            <a:r>
+              <a:t>06</a:t>
             </a:r>
           </a:p>
         </p:txBody>
@@ -9681,7 +9746,7 @@
           <a:lstStyle/>
           <a:p>
             <a:r>
-              <a:t>Workshop Workflow</a:t>
+              <a:t>The Digits Dataset — What You Will Work With</a:t>
             </a:r>
           </a:p>
         </p:txBody>
@@ -9703,49 +9768,49 @@
           <a:p>
             <a:pPr/>
             <a:r>
-              <a:t>For each exercise:</a:t>
-            </a:r>
-          </a:p>
-          <a:p>
-            <a:pPr lvl="1"/>
-            <a:r>
-              <a:t>1.  Read the lecture — understand the concept and methods</a:t>
-            </a:r>
-          </a:p>
-          <a:p>
-            <a:pPr lvl="1"/>
-            <a:r>
-              <a:t>2.  Follow the handson — build your script step by step</a:t>
-            </a:r>
-          </a:p>
-          <a:p>
-            <a:pPr lvl="1"/>
-            <a:r>
-              <a:t>3.  Run your script and verify output matches expected results</a:t>
-            </a:r>
-          </a:p>
-          <a:p>
-            <a:pPr lvl="1"/>
-            <a:r>
-              <a:t>4.  Compare against the solution file when done</a:t>
-            </a:r>
-          </a:p>
-          <a:p>
-            <a:pPr/>
-            <a:r>
-              <a:t>Tips:</a:t>
-            </a:r>
-          </a:p>
-          <a:p>
-            <a:pPr lvl="1"/>
-            <a:r>
-              <a:t>Stuck? Re-read the lecture for that exercise</a:t>
-            </a:r>
-          </a:p>
-          <a:p>
-            <a:pPr lvl="1"/>
-            <a:r>
-              <a:t>Output doesn't match? Check variable names (case-sensitive)</a:t>
+              <a:t>UCI Optical Recognition of Handwritten Digits</a:t>
+            </a:r>
+          </a:p>
+          <a:p>
+            <a:pPr/>
+            <a:r>
+              <a:t>Ships inside scikit-learn — no download needed</a:t>
+            </a:r>
+          </a:p>
+          <a:p>
+            <a:pPr/>
+            <a:r>
+              <a:t>1,797 images of handwritten digits (0–9)</a:t>
+            </a:r>
+          </a:p>
+          <a:p>
+            <a:pPr/>
+            <a:r>
+              <a:t>Each image: 8×8 pixels, brightness values 0 (white) to 16 (full ink)</a:t>
+            </a:r>
+          </a:p>
+          <a:p>
+            <a:pPr/>
+            <a:r>
+              <a:t>Each image is flattened to 64 numbers → one row in the dataset</a:t>
+            </a:r>
+          </a:p>
+          <a:p>
+            <a:pPr/>
+            <a:r>
+              <a:t>64 features (pixel values) + 1 label (digit 0–9) per sample</a:t>
+            </a:r>
+          </a:p>
+          <a:p>
+            <a:pPr/>
+            <a:r>
+              <a:t>Balanced: ~180 samples per class — no imbalance problem here</a:t>
+            </a:r>
+          </a:p>
+          <a:p>
+            <a:pPr/>
+            <a:r>
+              <a:t>A classic benchmark — simple enough to learn on, complex enough to be real</a:t>
             </a:r>
           </a:p>
         </p:txBody>
@@ -9770,65 +9835,7 @@
       <p:grpSpPr/>
       <p:sp>
         <p:nvSpPr>
-          <p:cNvPr id="2" name="Text Placeholder 1"/>
-          <p:cNvSpPr>
-            <a:spLocks noGrp="1"/>
-          </p:cNvSpPr>
-          <p:nvPr>
-            <p:ph type="body" idx="12" sz="quarter"/>
-          </p:nvPr>
-        </p:nvSpPr>
-        <p:spPr/>
-        <p:txBody>
-          <a:bodyPr/>
-          <a:lstStyle/>
-          <a:p>
-            <a:pPr/>
-            <a:r>
-              <a:t>ML lets the computer find patterns from labelled examples — no hand-crafted rules</a:t>
-            </a:r>
-          </a:p>
-          <a:p>
-            <a:pPr/>
-            <a:r>
-              <a:t>Supervised learning is the most common type in security</a:t>
-            </a:r>
-          </a:p>
-          <a:p>
-            <a:pPr/>
-            <a:r>
-              <a:t>Training = adjusting weights to minimise loss over many epochs</a:t>
-            </a:r>
-          </a:p>
-          <a:p>
-            <a:pPr/>
-            <a:r>
-              <a:t>Every ML project follows the same workflow: data → EDA → split → train → evaluate</a:t>
-            </a:r>
-          </a:p>
-          <a:p>
-            <a:pPr/>
-            <a:r>
-              <a:t>Never evaluate on training data — always use a held-out test set</a:t>
-            </a:r>
-          </a:p>
-          <a:p>
-            <a:pPr/>
-            <a:r>
-              <a:t>EDA catches silent failures: class imbalance, missing values, data leakage</a:t>
-            </a:r>
-          </a:p>
-          <a:p>
-            <a:pPr/>
-            <a:r>
-              <a:t>Next: Lesson 1.2 — Linear Regression</a:t>
-            </a:r>
-          </a:p>
-        </p:txBody>
-      </p:sp>
-      <p:sp>
-        <p:nvSpPr>
-          <p:cNvPr id="3" name="Title 2"/>
+          <p:cNvPr id="2" name="Title 1"/>
           <p:cNvSpPr>
             <a:spLocks noGrp="1"/>
           </p:cNvSpPr>
@@ -9842,7 +9849,77 @@
           <a:lstStyle/>
           <a:p>
             <a:r>
-              <a:t>Summary</a:t>
+              <a:t>What the Model Actually Sees</a:t>
+            </a:r>
+          </a:p>
+        </p:txBody>
+      </p:sp>
+      <p:sp>
+        <p:nvSpPr>
+          <p:cNvPr id="3" name="Content Placeholder 2"/>
+          <p:cNvSpPr>
+            <a:spLocks noGrp="1"/>
+          </p:cNvSpPr>
+          <p:nvPr>
+            <p:ph idx="1"/>
+          </p:nvPr>
+        </p:nvSpPr>
+        <p:spPr/>
+        <p:txBody>
+          <a:bodyPr/>
+          <a:lstStyle/>
+          <a:p>
+            <a:pPr/>
+            <a:r>
+              <a:t>A human sees a shape — a "0", a "7", a "3"</a:t>
+            </a:r>
+          </a:p>
+          <a:p>
+            <a:pPr/>
+            <a:r>
+              <a:t>The model never sees an image</a:t>
+            </a:r>
+          </a:p>
+          <a:p>
+            <a:pPr/>
+            <a:r>
+              <a:t>It receives a flat row of 64 numbers:</a:t>
+            </a:r>
+          </a:p>
+          <a:p>
+            <a:pPr lvl="1"/>
+            <a:r>
+              <a:t>[0, 0, 5, 13, 9, 1, 0, 0, 0, 0, 13, 15, 10, 15, 5, 0, ...]</a:t>
+            </a:r>
+          </a:p>
+          <a:p>
+            <a:pPr/>
+            <a:r>
+              <a:t>This is the most important shift in ML thinking:</a:t>
+            </a:r>
+          </a:p>
+          <a:p>
+            <a:pPr lvl="1"/>
+            <a:r>
+              <a:t>Everything is numbers — images, text, logs, packets</a:t>
+            </a:r>
+          </a:p>
+          <a:p>
+            <a:pPr lvl="1"/>
+            <a:r>
+              <a:t>Raw data → extract numerical features → feed to model</a:t>
+            </a:r>
+          </a:p>
+          <a:p>
+            <a:pPr/>
+            <a:r>
+              <a:t>The same structure applies to every security use case:</a:t>
+            </a:r>
+          </a:p>
+          <a:p>
+            <a:pPr lvl="1"/>
+            <a:r>
+              <a:t>URL features, packet headers, log fields, file metadata</a:t>
             </a:r>
           </a:p>
         </p:txBody>
@@ -9881,7 +9958,7 @@
           <a:lstStyle/>
           <a:p>
             <a:r>
-              <a:t>Next → Lesson 1.2: Linear Regression</a:t>
+              <a:t>Features vs Labels</a:t>
             </a:r>
           </a:p>
         </p:txBody>
@@ -9893,7 +9970,7 @@
             <a:spLocks noGrp="1"/>
           </p:cNvSpPr>
           <p:nvPr>
-            <p:ph type="body" idx="14" sz="quarter"/>
+            <p:ph type="body" idx="16" sz="quarter"/>
           </p:nvPr>
         </p:nvSpPr>
         <p:spPr/>
@@ -9902,7 +9979,375 @@
           <a:lstStyle/>
           <a:p>
             <a:r>
-              <a:t>What is Machine Learning?</a:t>
+              <a:t>07</a:t>
+            </a:r>
+          </a:p>
+        </p:txBody>
+      </p:sp>
+    </p:spTree>
+  </p:cSld>
+  <p:clrMapOvr>
+    <a:masterClrMapping/>
+  </p:clrMapOvr>
+</p:sld>
+</file>
+
+<file path=ppt/slides/slide26.xml><?xml version="1.0" encoding="utf-8"?>
+<p:sld xmlns:a="http://schemas.openxmlformats.org/drawingml/2006/main" xmlns:p="http://schemas.openxmlformats.org/presentationml/2006/main" xmlns:r="http://schemas.openxmlformats.org/officeDocument/2006/relationships">
+  <p:cSld>
+    <p:spTree>
+      <p:nvGrpSpPr>
+        <p:cNvPr id="1" name=""/>
+        <p:cNvGrpSpPr/>
+        <p:nvPr/>
+      </p:nvGrpSpPr>
+      <p:grpSpPr/>
+      <p:sp>
+        <p:nvSpPr>
+          <p:cNvPr id="2" name="Title 1"/>
+          <p:cNvSpPr>
+            <a:spLocks noGrp="1"/>
+          </p:cNvSpPr>
+          <p:nvPr>
+            <p:ph type="title"/>
+          </p:nvPr>
+        </p:nvSpPr>
+        <p:spPr/>
+        <p:txBody>
+          <a:bodyPr/>
+          <a:lstStyle/>
+          <a:p>
+            <a:r>
+              <a:t>Features (X) and Labels (y) — The Fundamental Split</a:t>
+            </a:r>
+          </a:p>
+        </p:txBody>
+      </p:sp>
+      <p:sp>
+        <p:nvSpPr>
+          <p:cNvPr id="3" name="Content Placeholder 2"/>
+          <p:cNvSpPr>
+            <a:spLocks noGrp="1"/>
+          </p:cNvSpPr>
+          <p:nvPr>
+            <p:ph idx="1"/>
+          </p:nvPr>
+        </p:nvSpPr>
+        <p:spPr/>
+        <p:txBody>
+          <a:bodyPr/>
+          <a:lstStyle/>
+          <a:p>
+            <a:pPr/>
+            <a:r>
+              <a:t>Every supervised ML problem has exactly two things:</a:t>
+            </a:r>
+          </a:p>
+          <a:p>
+            <a:pPr lvl="1"/>
+            <a:r>
+              <a:t>Features (X) — what you measure about each sample (the inputs)</a:t>
+            </a:r>
+          </a:p>
+          <a:p>
+            <a:pPr lvl="1"/>
+            <a:r>
+              <a:t>Labels (y) — the correct answer for each sample (what to predict)</a:t>
+            </a:r>
+          </a:p>
+          <a:p>
+            <a:pPr/>
+            <a:r>
+              <a:t>The structure is always the same — only the domain changes:</a:t>
+            </a:r>
+          </a:p>
+          <a:p>
+            <a:pPr lvl="1"/>
+            <a:r>
+              <a:t>Digit recognition:   64 pixel values  →  digit 0–9</a:t>
+            </a:r>
+          </a:p>
+          <a:p>
+            <a:pPr lvl="1"/>
+            <a:r>
+              <a:t>Phishing detection:  URL length, # dots, has @  →  phishing 0/1</a:t>
+            </a:r>
+          </a:p>
+          <a:p>
+            <a:pPr lvl="1"/>
+            <a:r>
+              <a:t>Network intrusion:   bytes sent, duration, SYN flags  →  malicious 0/1</a:t>
+            </a:r>
+          </a:p>
+          <a:p>
+            <a:pPr lvl="1"/>
+            <a:r>
+              <a:t>Malware classification:  file size, entropy, imports  →  family name</a:t>
+            </a:r>
+          </a:p>
+        </p:txBody>
+      </p:sp>
+    </p:spTree>
+  </p:cSld>
+  <p:clrMapOvr>
+    <a:masterClrMapping/>
+  </p:clrMapOvr>
+</p:sld>
+</file>
+
+<file path=ppt/slides/slide27.xml><?xml version="1.0" encoding="utf-8"?>
+<p:sld xmlns:a="http://schemas.openxmlformats.org/drawingml/2006/main" xmlns:p="http://schemas.openxmlformats.org/presentationml/2006/main" xmlns:r="http://schemas.openxmlformats.org/officeDocument/2006/relationships">
+  <p:cSld>
+    <p:spTree>
+      <p:nvGrpSpPr>
+        <p:cNvPr id="1" name=""/>
+        <p:cNvGrpSpPr/>
+        <p:nvPr/>
+      </p:nvGrpSpPr>
+      <p:grpSpPr/>
+      <p:sp>
+        <p:nvSpPr>
+          <p:cNvPr id="2" name="Title 1"/>
+          <p:cNvSpPr>
+            <a:spLocks noGrp="1"/>
+          </p:cNvSpPr>
+          <p:nvPr>
+            <p:ph type="title"/>
+          </p:nvPr>
+        </p:nvSpPr>
+        <p:spPr/>
+        <p:txBody>
+          <a:bodyPr/>
+          <a:lstStyle/>
+          <a:p>
+            <a:r>
+              <a:t>The Pattern: Raw Data → Features → Model → Prediction</a:t>
+            </a:r>
+          </a:p>
+        </p:txBody>
+      </p:sp>
+      <p:sp>
+        <p:nvSpPr>
+          <p:cNvPr id="3" name="Content Placeholder 2"/>
+          <p:cNvSpPr>
+            <a:spLocks noGrp="1"/>
+          </p:cNvSpPr>
+          <p:nvPr>
+            <p:ph idx="1"/>
+          </p:nvPr>
+        </p:nvSpPr>
+        <p:spPr/>
+        <p:txBody>
+          <a:bodyPr/>
+          <a:lstStyle/>
+          <a:p>
+            <a:pPr/>
+            <a:r>
+              <a:t>Step 1: Start with raw data (logs, images, URLs, packets)</a:t>
+            </a:r>
+          </a:p>
+          <a:p>
+            <a:pPr/>
+            <a:r>
+              <a:t>Step 2: Extract features (X) — turn raw data into numbers</a:t>
+            </a:r>
+          </a:p>
+          <a:p>
+            <a:pPr/>
+            <a:r>
+              <a:t>Step 3: Identify labels (y) — what are you predicting?</a:t>
+            </a:r>
+          </a:p>
+          <a:p>
+            <a:pPr/>
+            <a:r>
+              <a:t>Step 4: model.fit(X, y) — the model finds the pattern</a:t>
+            </a:r>
+          </a:p>
+          <a:p>
+            <a:pPr/>
+            <a:r>
+              <a:t>Step 5: model.predict(X_new) — apply the pattern to new data</a:t>
+            </a:r>
+          </a:p>
+          <a:p>
+            <a:pPr/>
+            <a:r>
+              <a:t>This 5-step pattern applies to every ML project</a:t>
+            </a:r>
+          </a:p>
+          <a:p>
+            <a:pPr/>
+            <a:r>
+              <a:t>In the workshop, you will do all 5 on the digits dataset</a:t>
+            </a:r>
+          </a:p>
+        </p:txBody>
+      </p:sp>
+    </p:spTree>
+  </p:cSld>
+  <p:clrMapOvr>
+    <a:masterClrMapping/>
+  </p:clrMapOvr>
+</p:sld>
+</file>
+
+<file path=ppt/slides/slide28.xml><?xml version="1.0" encoding="utf-8"?>
+<p:sld xmlns:a="http://schemas.openxmlformats.org/drawingml/2006/main" xmlns:p="http://schemas.openxmlformats.org/presentationml/2006/main" xmlns:r="http://schemas.openxmlformats.org/officeDocument/2006/relationships">
+  <p:cSld>
+    <p:spTree>
+      <p:nvGrpSpPr>
+        <p:cNvPr id="1" name=""/>
+        <p:cNvGrpSpPr/>
+        <p:nvPr/>
+      </p:nvGrpSpPr>
+      <p:grpSpPr/>
+      <p:sp>
+        <p:nvSpPr>
+          <p:cNvPr id="2" name="Text Placeholder 1"/>
+          <p:cNvSpPr>
+            <a:spLocks noGrp="1"/>
+          </p:cNvSpPr>
+          <p:nvPr>
+            <p:ph type="body" idx="13" sz="quarter"/>
+          </p:nvPr>
+        </p:nvSpPr>
+        <p:spPr/>
+        <p:txBody>
+          <a:bodyPr/>
+          <a:lstStyle/>
+          <a:p>
+            <a:r>
+              <a:t>Vocabulary &amp;</a:t>
+            </a:r>
+          </a:p>
+          <a:p>
+            <a:r>
+              <a:t>Python Tools</a:t>
+            </a:r>
+          </a:p>
+        </p:txBody>
+      </p:sp>
+      <p:sp>
+        <p:nvSpPr>
+          <p:cNvPr id="3" name="Text Placeholder 2"/>
+          <p:cNvSpPr>
+            <a:spLocks noGrp="1"/>
+          </p:cNvSpPr>
+          <p:nvPr>
+            <p:ph type="body" idx="16" sz="quarter"/>
+          </p:nvPr>
+        </p:nvSpPr>
+        <p:spPr/>
+        <p:txBody>
+          <a:bodyPr/>
+          <a:lstStyle/>
+          <a:p>
+            <a:r>
+              <a:t>08</a:t>
+            </a:r>
+          </a:p>
+        </p:txBody>
+      </p:sp>
+    </p:spTree>
+  </p:cSld>
+  <p:clrMapOvr>
+    <a:masterClrMapping/>
+  </p:clrMapOvr>
+</p:sld>
+</file>
+
+<file path=ppt/slides/slide29.xml><?xml version="1.0" encoding="utf-8"?>
+<p:sld xmlns:a="http://schemas.openxmlformats.org/drawingml/2006/main" xmlns:p="http://schemas.openxmlformats.org/presentationml/2006/main" xmlns:r="http://schemas.openxmlformats.org/officeDocument/2006/relationships">
+  <p:cSld>
+    <p:spTree>
+      <p:nvGrpSpPr>
+        <p:cNvPr id="1" name=""/>
+        <p:cNvGrpSpPr/>
+        <p:nvPr/>
+      </p:nvGrpSpPr>
+      <p:grpSpPr/>
+      <p:sp>
+        <p:nvSpPr>
+          <p:cNvPr id="2" name="Title 1"/>
+          <p:cNvSpPr>
+            <a:spLocks noGrp="1"/>
+          </p:cNvSpPr>
+          <p:nvPr>
+            <p:ph type="title"/>
+          </p:nvPr>
+        </p:nvSpPr>
+        <p:spPr/>
+        <p:txBody>
+          <a:bodyPr/>
+          <a:lstStyle/>
+          <a:p>
+            <a:r>
+              <a:t>Key Vocabulary</a:t>
+            </a:r>
+          </a:p>
+        </p:txBody>
+      </p:sp>
+      <p:sp>
+        <p:nvSpPr>
+          <p:cNvPr id="3" name="Content Placeholder 2"/>
+          <p:cNvSpPr>
+            <a:spLocks noGrp="1"/>
+          </p:cNvSpPr>
+          <p:nvPr>
+            <p:ph idx="1"/>
+          </p:nvPr>
+        </p:nvSpPr>
+        <p:spPr/>
+        <p:txBody>
+          <a:bodyPr/>
+          <a:lstStyle/>
+          <a:p>
+            <a:pPr/>
+            <a:r>
+              <a:t>Feature — one measurable input (URL length, bytes sent, pixel brightness)</a:t>
+            </a:r>
+          </a:p>
+          <a:p>
+            <a:pPr/>
+            <a:r>
+              <a:t>Label / Target — the answer the model predicts (phishing=1, legit=0)</a:t>
+            </a:r>
+          </a:p>
+          <a:p>
+            <a:pPr/>
+            <a:r>
+              <a:t>Sample — one row of data (one URL, one connection, one image)</a:t>
+            </a:r>
+          </a:p>
+          <a:p>
+            <a:pPr/>
+            <a:r>
+              <a:t>Training set — the data the model learns from</a:t>
+            </a:r>
+          </a:p>
+          <a:p>
+            <a:pPr/>
+            <a:r>
+              <a:t>Test set — held-back data to evaluate the model honestly</a:t>
+            </a:r>
+          </a:p>
+          <a:p>
+            <a:pPr/>
+            <a:r>
+              <a:t>Weights — the numbers inside the model, adjusted during training</a:t>
+            </a:r>
+          </a:p>
+          <a:p>
+            <a:pPr/>
+            <a:r>
+              <a:t>Loss — how wrong the predictions are; training minimises this</a:t>
+            </a:r>
+          </a:p>
+          <a:p>
+            <a:pPr/>
+            <a:r>
+              <a:t>Epoch — one full pass through the training data</a:t>
             </a:r>
           </a:p>
         </p:txBody>
@@ -9980,6 +10425,664 @@
 </p:sld>
 </file>
 
+<file path=ppt/slides/slide30.xml><?xml version="1.0" encoding="utf-8"?>
+<p:sld xmlns:a="http://schemas.openxmlformats.org/drawingml/2006/main" xmlns:p="http://schemas.openxmlformats.org/presentationml/2006/main" xmlns:r="http://schemas.openxmlformats.org/officeDocument/2006/relationships">
+  <p:cSld>
+    <p:spTree>
+      <p:nvGrpSpPr>
+        <p:cNvPr id="1" name=""/>
+        <p:cNvGrpSpPr/>
+        <p:nvPr/>
+      </p:nvGrpSpPr>
+      <p:grpSpPr/>
+      <p:sp>
+        <p:nvSpPr>
+          <p:cNvPr id="2" name="Title 1"/>
+          <p:cNvSpPr>
+            <a:spLocks noGrp="1"/>
+          </p:cNvSpPr>
+          <p:nvPr>
+            <p:ph type="title"/>
+          </p:nvPr>
+        </p:nvSpPr>
+        <p:spPr/>
+        <p:txBody>
+          <a:bodyPr/>
+          <a:lstStyle/>
+          <a:p>
+            <a:r>
+              <a:t>More Key Terms</a:t>
+            </a:r>
+          </a:p>
+        </p:txBody>
+      </p:sp>
+      <p:sp>
+        <p:nvSpPr>
+          <p:cNvPr id="3" name="Content Placeholder 2"/>
+          <p:cNvSpPr>
+            <a:spLocks noGrp="1"/>
+          </p:cNvSpPr>
+          <p:nvPr>
+            <p:ph idx="1"/>
+          </p:nvPr>
+        </p:nvSpPr>
+        <p:spPr/>
+        <p:txBody>
+          <a:bodyPr/>
+          <a:lstStyle/>
+          <a:p>
+            <a:pPr/>
+            <a:r>
+              <a:t>Model — the mathematical function learned from training data</a:t>
+            </a:r>
+          </a:p>
+          <a:p>
+            <a:pPr/>
+            <a:r>
+              <a:t>Overfitting — model memorised training data but fails on new data</a:t>
+            </a:r>
+          </a:p>
+          <a:p>
+            <a:pPr/>
+            <a:r>
+              <a:t>Underfitting — model is too simple to capture the real pattern</a:t>
+            </a:r>
+          </a:p>
+          <a:p>
+            <a:pPr/>
+            <a:r>
+              <a:t>Class imbalance — one label is far more common than others</a:t>
+            </a:r>
+          </a:p>
+          <a:p>
+            <a:pPr lvl="1"/>
+            <a:r>
+              <a:t>In security: 99% benign, 1% attack is typical</a:t>
+            </a:r>
+          </a:p>
+          <a:p>
+            <a:pPr/>
+            <a:r>
+              <a:t>EDA — Exploratory Data Analysis — inspecting data before modelling</a:t>
+            </a:r>
+          </a:p>
+          <a:p>
+            <a:pPr/>
+            <a:r>
+              <a:t>Bunch — scikit-learn's container: .data (X), .target (y), .DESCR</a:t>
+            </a:r>
+          </a:p>
+          <a:p>
+            <a:pPr/>
+            <a:r>
+              <a:t>DataFrame — pandas table with named columns and easy filtering</a:t>
+            </a:r>
+          </a:p>
+        </p:txBody>
+      </p:sp>
+    </p:spTree>
+  </p:cSld>
+  <p:clrMapOvr>
+    <a:masterClrMapping/>
+  </p:clrMapOvr>
+</p:sld>
+</file>
+
+<file path=ppt/slides/slide31.xml><?xml version="1.0" encoding="utf-8"?>
+<p:sld xmlns:a="http://schemas.openxmlformats.org/drawingml/2006/main" xmlns:p="http://schemas.openxmlformats.org/presentationml/2006/main" xmlns:r="http://schemas.openxmlformats.org/officeDocument/2006/relationships">
+  <p:cSld>
+    <p:spTree>
+      <p:nvGrpSpPr>
+        <p:cNvPr id="1" name=""/>
+        <p:cNvGrpSpPr/>
+        <p:nvPr/>
+      </p:nvGrpSpPr>
+      <p:grpSpPr/>
+      <p:sp>
+        <p:nvSpPr>
+          <p:cNvPr id="2" name="Title 1"/>
+          <p:cNvSpPr>
+            <a:spLocks noGrp="1"/>
+          </p:cNvSpPr>
+          <p:nvPr>
+            <p:ph type="title"/>
+          </p:nvPr>
+        </p:nvSpPr>
+        <p:spPr/>
+        <p:txBody>
+          <a:bodyPr/>
+          <a:lstStyle/>
+          <a:p>
+            <a:r>
+              <a:t>Python Libraries You Will Use in Every Lesson</a:t>
+            </a:r>
+          </a:p>
+        </p:txBody>
+      </p:sp>
+      <p:sp>
+        <p:nvSpPr>
+          <p:cNvPr id="3" name="Content Placeholder 2"/>
+          <p:cNvSpPr>
+            <a:spLocks noGrp="1"/>
+          </p:cNvSpPr>
+          <p:nvPr>
+            <p:ph idx="1"/>
+          </p:nvPr>
+        </p:nvSpPr>
+        <p:spPr/>
+        <p:txBody>
+          <a:bodyPr/>
+          <a:lstStyle/>
+          <a:p>
+            <a:pPr/>
+            <a:r>
+              <a:t>NumPy (import numpy as np)</a:t>
+            </a:r>
+          </a:p>
+          <a:p>
+            <a:pPr lvl="1"/>
+            <a:r>
+              <a:t>Fast numerical arrays — the foundation of all ML in Python</a:t>
+            </a:r>
+          </a:p>
+          <a:p>
+            <a:pPr lvl="1"/>
+            <a:r>
+              <a:t>ndarray: 1D = list of numbers, 2D = table, 3D = stack of tables</a:t>
+            </a:r>
+          </a:p>
+          <a:p>
+            <a:pPr/>
+            <a:r>
+              <a:t>pandas (import pandas as pd)</a:t>
+            </a:r>
+          </a:p>
+          <a:p>
+            <a:pPr lvl="1"/>
+            <a:r>
+              <a:t>DataFrames for tabular data — .head(), .describe(), .value_counts()</a:t>
+            </a:r>
+          </a:p>
+          <a:p>
+            <a:pPr lvl="1"/>
+            <a:r>
+              <a:t>Named columns, easy filtering, consistent interface with sklearn</a:t>
+            </a:r>
+          </a:p>
+          <a:p>
+            <a:pPr/>
+            <a:r>
+              <a:t>Matplotlib (import matplotlib.pyplot as plt)</a:t>
+            </a:r>
+          </a:p>
+          <a:p>
+            <a:pPr lvl="1"/>
+            <a:r>
+              <a:t>Plotting: scatter, line, bar, image grids, heatmaps</a:t>
+            </a:r>
+          </a:p>
+          <a:p>
+            <a:pPr/>
+            <a:r>
+              <a:t>scikit-learn (import sklearn)</a:t>
+            </a:r>
+          </a:p>
+          <a:p>
+            <a:pPr lvl="1"/>
+            <a:r>
+              <a:t>ML algorithms, built-in datasets, evaluation metrics, preprocessing</a:t>
+            </a:r>
+          </a:p>
+        </p:txBody>
+      </p:sp>
+    </p:spTree>
+  </p:cSld>
+  <p:clrMapOvr>
+    <a:masterClrMapping/>
+  </p:clrMapOvr>
+</p:sld>
+</file>
+
+<file path=ppt/slides/slide32.xml><?xml version="1.0" encoding="utf-8"?>
+<p:sld xmlns:a="http://schemas.openxmlformats.org/drawingml/2006/main" xmlns:p="http://schemas.openxmlformats.org/presentationml/2006/main" xmlns:r="http://schemas.openxmlformats.org/officeDocument/2006/relationships">
+  <p:cSld>
+    <p:spTree>
+      <p:nvGrpSpPr>
+        <p:cNvPr id="1" name=""/>
+        <p:cNvGrpSpPr/>
+        <p:nvPr/>
+      </p:nvGrpSpPr>
+      <p:grpSpPr/>
+      <p:sp>
+        <p:nvSpPr>
+          <p:cNvPr id="2" name="Text Placeholder 1"/>
+          <p:cNvSpPr>
+            <a:spLocks noGrp="1"/>
+          </p:cNvSpPr>
+          <p:nvPr>
+            <p:ph type="body" idx="13" sz="quarter"/>
+          </p:nvPr>
+        </p:nvSpPr>
+        <p:spPr/>
+        <p:txBody>
+          <a:bodyPr/>
+          <a:lstStyle/>
+          <a:p>
+            <a:r>
+              <a:t>Workshop</a:t>
+            </a:r>
+          </a:p>
+          <a:p>
+            <a:r>
+              <a:t>5 Hands-On Exercises</a:t>
+            </a:r>
+          </a:p>
+        </p:txBody>
+      </p:sp>
+      <p:sp>
+        <p:nvSpPr>
+          <p:cNvPr id="3" name="Text Placeholder 2"/>
+          <p:cNvSpPr>
+            <a:spLocks noGrp="1"/>
+          </p:cNvSpPr>
+          <p:nvPr>
+            <p:ph type="body" idx="16" sz="quarter"/>
+          </p:nvPr>
+        </p:nvSpPr>
+        <p:spPr/>
+        <p:txBody>
+          <a:bodyPr/>
+          <a:lstStyle/>
+          <a:p>
+            <a:r>
+              <a:t>09</a:t>
+            </a:r>
+          </a:p>
+        </p:txBody>
+      </p:sp>
+    </p:spTree>
+  </p:cSld>
+  <p:clrMapOvr>
+    <a:masterClrMapping/>
+  </p:clrMapOvr>
+</p:sld>
+</file>
+
+<file path=ppt/slides/slide33.xml><?xml version="1.0" encoding="utf-8"?>
+<p:sld xmlns:a="http://schemas.openxmlformats.org/drawingml/2006/main" xmlns:p="http://schemas.openxmlformats.org/presentationml/2006/main" xmlns:r="http://schemas.openxmlformats.org/officeDocument/2006/relationships">
+  <p:cSld>
+    <p:spTree>
+      <p:nvGrpSpPr>
+        <p:cNvPr id="1" name=""/>
+        <p:cNvGrpSpPr/>
+        <p:nvPr/>
+      </p:nvGrpSpPr>
+      <p:grpSpPr/>
+      <p:sp>
+        <p:nvSpPr>
+          <p:cNvPr id="2" name="Title 1"/>
+          <p:cNvSpPr>
+            <a:spLocks noGrp="1"/>
+          </p:cNvSpPr>
+          <p:nvPr>
+            <p:ph type="title"/>
+          </p:nvPr>
+        </p:nvSpPr>
+        <p:spPr/>
+        <p:txBody>
+          <a:bodyPr/>
+          <a:lstStyle/>
+          <a:p>
+            <a:r>
+              <a:t>Workshop — Full EDA on the Digits Dataset</a:t>
+            </a:r>
+          </a:p>
+        </p:txBody>
+      </p:sp>
+      <p:sp>
+        <p:nvSpPr>
+          <p:cNvPr id="3" name="Content Placeholder 2"/>
+          <p:cNvSpPr>
+            <a:spLocks noGrp="1"/>
+          </p:cNvSpPr>
+          <p:nvPr>
+            <p:ph idx="1"/>
+          </p:nvPr>
+        </p:nvSpPr>
+        <p:spPr/>
+        <p:txBody>
+          <a:bodyPr/>
+          <a:lstStyle/>
+          <a:p>
+            <a:pPr/>
+            <a:r>
+              <a:t>Before training any model, you must understand your data</a:t>
+            </a:r>
+          </a:p>
+          <a:p>
+            <a:pPr/>
+            <a:r>
+              <a:t>This workshop walks through the full EDA sequence</a:t>
+            </a:r>
+          </a:p>
+          <a:p>
+            <a:pPr/>
+            <a:r>
+              <a:t>The same sequence you will run at the start of every ML project</a:t>
+            </a:r>
+          </a:p>
+          <a:p>
+            <a:pPr/>
+            <a:r>
+              <a:t>Exercise 1: Load the dataset — Bunch, DataFrame, features vs labels</a:t>
+            </a:r>
+          </a:p>
+          <a:p>
+            <a:pPr/>
+            <a:r>
+              <a:t>Exercise 2: Shape and statistics — .describe(), missing values, zero-variance</a:t>
+            </a:r>
+          </a:p>
+          <a:p>
+            <a:pPr/>
+            <a:r>
+              <a:t>Exercise 3: Class balance — the naive accuracy trap, imbalance ratio</a:t>
+            </a:r>
+          </a:p>
+          <a:p>
+            <a:pPr/>
+            <a:r>
+              <a:t>Exercise 4: Visualise — image grids, average prototypes per class</a:t>
+            </a:r>
+          </a:p>
+          <a:p>
+            <a:pPr/>
+            <a:r>
+              <a:t>Exercise 5: What the model sees — number grids, correlations, security analogy</a:t>
+            </a:r>
+          </a:p>
+        </p:txBody>
+      </p:sp>
+    </p:spTree>
+  </p:cSld>
+  <p:clrMapOvr>
+    <a:masterClrMapping/>
+  </p:clrMapOvr>
+</p:sld>
+</file>
+
+<file path=ppt/slides/slide34.xml><?xml version="1.0" encoding="utf-8"?>
+<p:sld xmlns:a="http://schemas.openxmlformats.org/drawingml/2006/main" xmlns:p="http://schemas.openxmlformats.org/presentationml/2006/main" xmlns:r="http://schemas.openxmlformats.org/officeDocument/2006/relationships">
+  <p:cSld>
+    <p:spTree>
+      <p:nvGrpSpPr>
+        <p:cNvPr id="1" name=""/>
+        <p:cNvGrpSpPr/>
+        <p:nvPr/>
+      </p:nvGrpSpPr>
+      <p:grpSpPr/>
+      <p:sp>
+        <p:nvSpPr>
+          <p:cNvPr id="2" name="Title 1"/>
+          <p:cNvSpPr>
+            <a:spLocks noGrp="1"/>
+          </p:cNvSpPr>
+          <p:nvPr>
+            <p:ph type="title"/>
+          </p:nvPr>
+        </p:nvSpPr>
+        <p:spPr/>
+        <p:txBody>
+          <a:bodyPr/>
+          <a:lstStyle/>
+          <a:p>
+            <a:r>
+              <a:t>Workshop Structure</a:t>
+            </a:r>
+          </a:p>
+        </p:txBody>
+      </p:sp>
+      <p:sp>
+        <p:nvSpPr>
+          <p:cNvPr id="3" name="Content Placeholder 2"/>
+          <p:cNvSpPr>
+            <a:spLocks noGrp="1"/>
+          </p:cNvSpPr>
+          <p:nvPr>
+            <p:ph idx="1"/>
+          </p:nvPr>
+        </p:nvSpPr>
+        <p:spPr/>
+        <p:txBody>
+          <a:bodyPr/>
+          <a:lstStyle/>
+          <a:p>
+            <a:pPr/>
+            <a:r>
+              <a:t>Each exercise folder contains three files:</a:t>
+            </a:r>
+          </a:p>
+          <a:p>
+            <a:pPr lvl="1"/>
+            <a:r>
+              <a:t>lecture.md — concept explanation (read first)</a:t>
+            </a:r>
+          </a:p>
+          <a:p>
+            <a:pPr lvl="1"/>
+            <a:r>
+              <a:t>handson.md — step-by-step lab instructions</a:t>
+            </a:r>
+          </a:p>
+          <a:p>
+            <a:pPr lvl="1"/>
+            <a:r>
+              <a:t>solution_*.py — reference implementation (open last)</a:t>
+            </a:r>
+          </a:p>
+          <a:p>
+            <a:pPr/>
+            <a:r>
+              <a:t>Workflow for each exercise:</a:t>
+            </a:r>
+          </a:p>
+          <a:p>
+            <a:pPr lvl="1"/>
+            <a:r>
+              <a:t>1.  Read the lecture — understand the concept and methods</a:t>
+            </a:r>
+          </a:p>
+          <a:p>
+            <a:pPr lvl="1"/>
+            <a:r>
+              <a:t>2.  Follow the handson — build your script step by step</a:t>
+            </a:r>
+          </a:p>
+          <a:p>
+            <a:pPr lvl="1"/>
+            <a:r>
+              <a:t>3.  Run your script and verify output matches expected results</a:t>
+            </a:r>
+          </a:p>
+          <a:p>
+            <a:pPr lvl="1"/>
+            <a:r>
+              <a:t>4.  Compare against the solution when done</a:t>
+            </a:r>
+          </a:p>
+        </p:txBody>
+      </p:sp>
+    </p:spTree>
+  </p:cSld>
+  <p:clrMapOvr>
+    <a:masterClrMapping/>
+  </p:clrMapOvr>
+</p:sld>
+</file>
+
+<file path=ppt/slides/slide35.xml><?xml version="1.0" encoding="utf-8"?>
+<p:sld xmlns:a="http://schemas.openxmlformats.org/drawingml/2006/main" xmlns:p="http://schemas.openxmlformats.org/presentationml/2006/main" xmlns:r="http://schemas.openxmlformats.org/officeDocument/2006/relationships">
+  <p:cSld>
+    <p:spTree>
+      <p:nvGrpSpPr>
+        <p:cNvPr id="1" name=""/>
+        <p:cNvGrpSpPr/>
+        <p:nvPr/>
+      </p:nvGrpSpPr>
+      <p:grpSpPr/>
+      <p:sp>
+        <p:nvSpPr>
+          <p:cNvPr id="2" name="Text Placeholder 1"/>
+          <p:cNvSpPr>
+            <a:spLocks noGrp="1"/>
+          </p:cNvSpPr>
+          <p:nvPr>
+            <p:ph type="body" idx="12" sz="quarter"/>
+          </p:nvPr>
+        </p:nvSpPr>
+        <p:spPr/>
+        <p:txBody>
+          <a:bodyPr/>
+          <a:lstStyle/>
+          <a:p>
+            <a:pPr/>
+            <a:r>
+              <a:t>ML finds patterns from labelled examples — no hand-crafted rules</a:t>
+            </a:r>
+          </a:p>
+          <a:p>
+            <a:pPr/>
+            <a:r>
+              <a:t>Supervised learning: features (X) → label (y). Most common in security</a:t>
+            </a:r>
+          </a:p>
+          <a:p>
+            <a:pPr/>
+            <a:r>
+              <a:t>Training = adjusting weights to minimise loss over many epochs</a:t>
+            </a:r>
+          </a:p>
+          <a:p>
+            <a:pPr/>
+            <a:r>
+              <a:t>Every ML project: data → EDA → split → train → evaluate → tune → deploy</a:t>
+            </a:r>
+          </a:p>
+          <a:p>
+            <a:pPr/>
+            <a:r>
+              <a:t>Never evaluate on training data — always use a held-out test set</a:t>
+            </a:r>
+          </a:p>
+          <a:p>
+            <a:pPr/>
+            <a:r>
+              <a:t>EDA catches silent failures: class imbalance, missing values, leakage</a:t>
+            </a:r>
+          </a:p>
+          <a:p>
+            <a:pPr/>
+            <a:r>
+              <a:t>Everything is numbers — images, text, logs all become feature rows</a:t>
+            </a:r>
+          </a:p>
+          <a:p>
+            <a:pPr/>
+            <a:r>
+              <a:t>Next: 5 exercises to do the full EDA yourself on the digits dataset</a:t>
+            </a:r>
+          </a:p>
+        </p:txBody>
+      </p:sp>
+      <p:sp>
+        <p:nvSpPr>
+          <p:cNvPr id="3" name="Title 2"/>
+          <p:cNvSpPr>
+            <a:spLocks noGrp="1"/>
+          </p:cNvSpPr>
+          <p:nvPr>
+            <p:ph type="title"/>
+          </p:nvPr>
+        </p:nvSpPr>
+        <p:spPr/>
+        <p:txBody>
+          <a:bodyPr/>
+          <a:lstStyle/>
+          <a:p>
+            <a:r>
+              <a:t>Summary</a:t>
+            </a:r>
+          </a:p>
+        </p:txBody>
+      </p:sp>
+    </p:spTree>
+  </p:cSld>
+  <p:clrMapOvr>
+    <a:masterClrMapping/>
+  </p:clrMapOvr>
+</p:sld>
+</file>
+
+<file path=ppt/slides/slide36.xml><?xml version="1.0" encoding="utf-8"?>
+<p:sld xmlns:a="http://schemas.openxmlformats.org/drawingml/2006/main" xmlns:p="http://schemas.openxmlformats.org/presentationml/2006/main" xmlns:r="http://schemas.openxmlformats.org/officeDocument/2006/relationships">
+  <p:cSld>
+    <p:spTree>
+      <p:nvGrpSpPr>
+        <p:cNvPr id="1" name=""/>
+        <p:cNvGrpSpPr/>
+        <p:nvPr/>
+      </p:nvGrpSpPr>
+      <p:grpSpPr/>
+      <p:sp>
+        <p:nvSpPr>
+          <p:cNvPr id="2" name="Text Placeholder 1"/>
+          <p:cNvSpPr>
+            <a:spLocks noGrp="1"/>
+          </p:cNvSpPr>
+          <p:nvPr>
+            <p:ph type="body" idx="13" sz="quarter"/>
+          </p:nvPr>
+        </p:nvSpPr>
+        <p:spPr/>
+        <p:txBody>
+          <a:bodyPr/>
+          <a:lstStyle/>
+          <a:p>
+            <a:r>
+              <a:t>Next → Lesson 1.2: Linear Regression</a:t>
+            </a:r>
+          </a:p>
+        </p:txBody>
+      </p:sp>
+      <p:sp>
+        <p:nvSpPr>
+          <p:cNvPr id="3" name="Text Placeholder 2"/>
+          <p:cNvSpPr>
+            <a:spLocks noGrp="1"/>
+          </p:cNvSpPr>
+          <p:nvPr>
+            <p:ph type="body" idx="14" sz="quarter"/>
+          </p:nvPr>
+        </p:nvSpPr>
+        <p:spPr/>
+        <p:txBody>
+          <a:bodyPr/>
+          <a:lstStyle/>
+          <a:p>
+            <a:r>
+              <a:t>What is Machine Learning?</a:t>
+            </a:r>
+          </a:p>
+        </p:txBody>
+      </p:sp>
+    </p:spTree>
+  </p:cSld>
+  <p:clrMapOvr>
+    <a:masterClrMapping/>
+  </p:clrMapOvr>
+</p:sld>
+</file>
+
 <file path=ppt/slides/slide4.xml><?xml version="1.0" encoding="utf-8"?>
 <p:sld xmlns:a="http://schemas.openxmlformats.org/drawingml/2006/main" xmlns:p="http://schemas.openxmlformats.org/presentationml/2006/main" xmlns:r="http://schemas.openxmlformats.org/officeDocument/2006/relationships">
   <p:cSld>
@@ -10028,7 +11131,7 @@
           <a:p>
             <a:pPr/>
             <a:r>
-              <a:t>You hand-craft explicit rules the computer follows</a:t>
+              <a:t>You hand-craft explicit rules:</a:t>
             </a:r>
           </a:p>
           <a:p>
@@ -10052,19 +11155,31 @@
           <a:p>
             <a:pPr/>
             <a:r>
-              <a:t>Problem: attackers learn your rules and work around them</a:t>
+              <a:t>The computer applies your rules to every email</a:t>
+            </a:r>
+          </a:p>
+          <a:p>
+            <a:pPr/>
+            <a:r>
+              <a:t>The problem:</a:t>
             </a:r>
           </a:p>
           <a:p>
             <a:pPr lvl="1"/>
             <a:r>
+              <a:t>Attackers learn your rules and work around them</a:t>
+            </a:r>
+          </a:p>
+          <a:p>
+            <a:pPr lvl="1"/>
+            <a:r>
               <a:t>Change one word → bypass the filter</a:t>
             </a:r>
           </a:p>
           <a:p>
             <a:pPr lvl="1"/>
             <a:r>
-              <a:t>Rules don't scale to millions of patterns</a:t>
+              <a:t>Rules don't scale to millions of evolving patterns</a:t>
             </a:r>
           </a:p>
         </p:txBody>
@@ -10125,43 +11240,55 @@
           <a:p>
             <a:pPr/>
             <a:r>
-              <a:t>You provide thousands of labelled examples</a:t>
+              <a:t>You provide thousands of labelled examples:</a:t>
             </a:r>
           </a:p>
           <a:p>
             <a:pPr lvl="1"/>
             <a:r>
-              <a:t>10,000 emails tagged as spam or legitimate</a:t>
-            </a:r>
-          </a:p>
-          <a:p>
-            <a:pPr/>
-            <a:r>
-              <a:t>The computer finds statistical patterns across all examples</a:t>
-            </a:r>
-          </a:p>
-          <a:p>
-            <a:pPr/>
-            <a:r>
-              <a:t>Result: a model that generalises to data it has never seen</a:t>
-            </a:r>
-          </a:p>
-          <a:p>
-            <a:pPr/>
-            <a:r>
-              <a:t>Why it works for security:</a:t>
+              <a:t>10,000 emails, each tagged as spam or legitimate</a:t>
+            </a:r>
+          </a:p>
+          <a:p>
+            <a:pPr/>
+            <a:r>
+              <a:t>Each email described by measurable properties:</a:t>
             </a:r>
           </a:p>
           <a:p>
             <a:pPr lvl="1"/>
             <a:r>
-              <a:t>Attackers constantly change tactics, but statistical patterns persist</a:t>
+              <a:t>word_count=42, num_links=8, has_attachment=1, domain_age=3</a:t>
+            </a:r>
+          </a:p>
+          <a:p>
+            <a:pPr/>
+            <a:r>
+              <a:t>model.fit(emails, labels)  — the model finds patterns</a:t>
+            </a:r>
+          </a:p>
+          <a:p>
+            <a:pPr/>
+            <a:r>
+              <a:t>model.predict(new_email)   — applies those patterns to new data</a:t>
+            </a:r>
+          </a:p>
+          <a:p>
+            <a:pPr/>
+            <a:r>
+              <a:t>The patterns are combinations of dozens of subtle signals</a:t>
             </a:r>
           </a:p>
           <a:p>
             <a:pPr lvl="1"/>
             <a:r>
-              <a:t>ML detects subtle combinations no human would write as rules</a:t>
+              <a:t>No human would think to write them as rules</a:t>
+            </a:r>
+          </a:p>
+          <a:p>
+            <a:pPr/>
+            <a:r>
+              <a:t>This is why ML outperforms hand-crafted rules on complex problems</a:t>
             </a:r>
           </a:p>
         </p:txBody>
@@ -10186,12 +11313,12 @@
       <p:grpSpPr/>
       <p:sp>
         <p:nvSpPr>
-          <p:cNvPr id="2" name="Text Placeholder 1"/>
+          <p:cNvPr id="2" name="Title 1"/>
           <p:cNvSpPr>
             <a:spLocks noGrp="1"/>
           </p:cNvSpPr>
           <p:nvPr>
-            <p:ph type="body" idx="13" sz="quarter"/>
+            <p:ph type="title"/>
           </p:nvPr>
         </p:nvSpPr>
         <p:spPr/>
@@ -10200,24 +11327,19 @@
           <a:lstStyle/>
           <a:p>
             <a:r>
-              <a:t>The Three Types of</a:t>
-            </a:r>
-          </a:p>
-          <a:p>
-            <a:r>
-              <a:t>Machine Learning</a:t>
-            </a:r>
-          </a:p>
-        </p:txBody>
-      </p:sp>
-      <p:sp>
-        <p:nvSpPr>
-          <p:cNvPr id="3" name="Text Placeholder 2"/>
+              <a:t>Why This Matters for Security</a:t>
+            </a:r>
+          </a:p>
+        </p:txBody>
+      </p:sp>
+      <p:sp>
+        <p:nvSpPr>
+          <p:cNvPr id="3" name="Content Placeholder 2"/>
           <p:cNvSpPr>
             <a:spLocks noGrp="1"/>
           </p:cNvSpPr>
           <p:nvPr>
-            <p:ph type="body" idx="16" sz="quarter"/>
+            <p:ph idx="1"/>
           </p:nvPr>
         </p:nvSpPr>
         <p:spPr/>
@@ -10225,8 +11347,51 @@
           <a:bodyPr/>
           <a:lstStyle/>
           <a:p>
-            <a:r>
-              <a:t>02</a:t>
+            <a:pPr/>
+            <a:r>
+              <a:t>Attackers constantly change their tactics</a:t>
+            </a:r>
+          </a:p>
+          <a:p>
+            <a:pPr/>
+            <a:r>
+              <a:t>But their statistical patterns persist across campaigns</a:t>
+            </a:r>
+          </a:p>
+          <a:p>
+            <a:pPr/>
+            <a:r>
+              <a:t>ML detects those persistent patterns automatically</a:t>
+            </a:r>
+          </a:p>
+          <a:p>
+            <a:pPr/>
+            <a:r>
+              <a:t>Already deployed in production security tooling:</a:t>
+            </a:r>
+          </a:p>
+          <a:p>
+            <a:pPr lvl="1"/>
+            <a:r>
+              <a:t>Email filters — Gmail blocks 99.9% of spam with ML</a:t>
+            </a:r>
+          </a:p>
+          <a:p>
+            <a:pPr lvl="1"/>
+            <a:r>
+              <a:t>Endpoint detection — behavioural analysis of process activity</a:t>
+            </a:r>
+          </a:p>
+          <a:p>
+            <a:pPr lvl="1"/>
+            <a:r>
+              <a:t>SIEM correlation — anomaly scoring across log sources</a:t>
+            </a:r>
+          </a:p>
+          <a:p>
+            <a:pPr lvl="1"/>
+            <a:r>
+              <a:t>Network intrusion detection — traffic classification at wire speed</a:t>
             </a:r>
           </a:p>
         </p:txBody>
@@ -10251,12 +11416,12 @@
       <p:grpSpPr/>
       <p:sp>
         <p:nvSpPr>
-          <p:cNvPr id="2" name="Title 1"/>
+          <p:cNvPr id="2" name="Text Placeholder 1"/>
           <p:cNvSpPr>
             <a:spLocks noGrp="1"/>
           </p:cNvSpPr>
           <p:nvPr>
-            <p:ph type="title"/>
+            <p:ph type="body" idx="13" sz="quarter"/>
           </p:nvPr>
         </p:nvSpPr>
         <p:spPr/>
@@ -10265,19 +11430,24 @@
           <a:lstStyle/>
           <a:p>
             <a:r>
-              <a:t>Supervised Learning</a:t>
-            </a:r>
-          </a:p>
-        </p:txBody>
-      </p:sp>
-      <p:sp>
-        <p:nvSpPr>
-          <p:cNvPr id="3" name="Content Placeholder 2"/>
+              <a:t>The Three Types of</a:t>
+            </a:r>
+          </a:p>
+          <a:p>
+            <a:r>
+              <a:t>Machine Learning</a:t>
+            </a:r>
+          </a:p>
+        </p:txBody>
+      </p:sp>
+      <p:sp>
+        <p:nvSpPr>
+          <p:cNvPr id="3" name="Text Placeholder 2"/>
           <p:cNvSpPr>
             <a:spLocks noGrp="1"/>
           </p:cNvSpPr>
           <p:nvPr>
-            <p:ph idx="1"/>
+            <p:ph type="body" idx="16" sz="quarter"/>
           </p:nvPr>
         </p:nvSpPr>
         <p:spPr/>
@@ -10285,51 +11455,8 @@
           <a:bodyPr/>
           <a:lstStyle/>
           <a:p>
-            <a:pPr/>
-            <a:r>
-              <a:t>Every sample has a correct answer (label) attached</a:t>
-            </a:r>
-          </a:p>
-          <a:p>
-            <a:pPr/>
-            <a:r>
-              <a:t>The model learns the mapping: input features → label</a:t>
-            </a:r>
-          </a:p>
-          <a:p>
-            <a:pPr/>
-            <a:r>
-              <a:t>Example:</a:t>
-            </a:r>
-          </a:p>
-          <a:p>
-            <a:pPr lvl="1"/>
-            <a:r>
-              <a:t>[url_length=92, num_dots=5, has_at_symbol=1]  →  phishing</a:t>
-            </a:r>
-          </a:p>
-          <a:p>
-            <a:pPr lvl="1"/>
-            <a:r>
-              <a:t>[url_length=14, num_dots=1, has_at_symbol=0]  →  legitimate</a:t>
-            </a:r>
-          </a:p>
-          <a:p>
-            <a:pPr/>
-            <a:r>
-              <a:t>Most widely used type in security</a:t>
-            </a:r>
-          </a:p>
-          <a:p>
-            <a:pPr lvl="1"/>
-            <a:r>
-              <a:t>Phishing detector, malware classifier, intrusion detector</a:t>
-            </a:r>
-          </a:p>
-          <a:p>
-            <a:pPr/>
-            <a:r>
-              <a:t>Focus of Stages 1 and 2 in this curriculum</a:t>
+            <a:r>
+              <a:t>02</a:t>
             </a:r>
           </a:p>
         </p:txBody>
@@ -10368,7 +11495,7 @@
           <a:lstStyle/>
           <a:p>
             <a:r>
-              <a:t>Unsupervised &amp; Reinforcement Learning</a:t>
+              <a:t>Supervised Learning — Labelled Examples</a:t>
             </a:r>
           </a:p>
         </p:txBody>
@@ -10390,49 +11517,55 @@
           <a:p>
             <a:pPr/>
             <a:r>
-              <a:t>Unsupervised Learning — no labels needed</a:t>
+              <a:t>Every sample has a correct answer (label) attached</a:t>
+            </a:r>
+          </a:p>
+          <a:p>
+            <a:pPr/>
+            <a:r>
+              <a:t>The model learns the mapping: input features → label</a:t>
+            </a:r>
+          </a:p>
+          <a:p>
+            <a:pPr/>
+            <a:r>
+              <a:t>Input:  [url_length=92, num_dots=5, has_at=1]  →  phishing</a:t>
+            </a:r>
+          </a:p>
+          <a:p>
+            <a:pPr/>
+            <a:r>
+              <a:t>Input:  [url_length=14, num_dots=1, has_at=0]  →  legitimate</a:t>
+            </a:r>
+          </a:p>
+          <a:p>
+            <a:pPr/>
+            <a:r>
+              <a:t>The most widely used type in security:</a:t>
             </a:r>
           </a:p>
           <a:p>
             <a:pPr lvl="1"/>
             <a:r>
-              <a:t>The algorithm finds structure in the data on its own</a:t>
+              <a:t>Phishing URL classifier</a:t>
             </a:r>
           </a:p>
           <a:p>
             <a:pPr lvl="1"/>
             <a:r>
-              <a:t>"This connection looks different from all the others"</a:t>
+              <a:t>Malware vs benign file classifier</a:t>
             </a:r>
           </a:p>
           <a:p>
             <a:pPr lvl="1"/>
             <a:r>
-              <a:t>Security: anomaly detection, user behaviour clustering</a:t>
-            </a:r>
-          </a:p>
-          <a:p>
-            <a:pPr lvl="1"/>
-            <a:r>
-              <a:t>Covered in Stage 2</a:t>
-            </a:r>
-          </a:p>
-          <a:p>
-            <a:pPr/>
-            <a:r>
-              <a:t>Reinforcement Learning — trial and error</a:t>
-            </a:r>
-          </a:p>
-          <a:p>
-            <a:pPr lvl="1"/>
-            <a:r>
-              <a:t>Agent receives rewards for correct decisions, penalties for bad ones</a:t>
-            </a:r>
-          </a:p>
-          <a:p>
-            <a:pPr lvl="1"/>
-            <a:r>
-              <a:t>Security: automated penetration testing, adaptive response</a:t>
+              <a:t>Network intrusion detector</a:t>
+            </a:r>
+          </a:p>
+          <a:p>
+            <a:pPr/>
+            <a:r>
+              <a:t>Focus of Stages 1 and 2 in this curriculum</a:t>
             </a:r>
           </a:p>
         </p:txBody>
@@ -10457,12 +11590,12 @@
       <p:grpSpPr/>
       <p:sp>
         <p:nvSpPr>
-          <p:cNvPr id="2" name="Text Placeholder 1"/>
+          <p:cNvPr id="2" name="Title 1"/>
           <p:cNvSpPr>
             <a:spLocks noGrp="1"/>
           </p:cNvSpPr>
           <p:nvPr>
-            <p:ph type="body" idx="13" sz="quarter"/>
+            <p:ph type="title"/>
           </p:nvPr>
         </p:nvSpPr>
         <p:spPr/>
@@ -10471,24 +11604,19 @@
           <a:lstStyle/>
           <a:p>
             <a:r>
-              <a:t>How a Model</a:t>
-            </a:r>
-          </a:p>
-          <a:p>
-            <a:r>
-              <a:t>Actually Learns</a:t>
-            </a:r>
-          </a:p>
-        </p:txBody>
-      </p:sp>
-      <p:sp>
-        <p:nvSpPr>
-          <p:cNvPr id="3" name="Text Placeholder 2"/>
+              <a:t>Unsupervised Learning — No Labels Needed</a:t>
+            </a:r>
+          </a:p>
+        </p:txBody>
+      </p:sp>
+      <p:sp>
+        <p:nvSpPr>
+          <p:cNvPr id="3" name="Content Placeholder 2"/>
           <p:cNvSpPr>
             <a:spLocks noGrp="1"/>
           </p:cNvSpPr>
           <p:nvPr>
-            <p:ph type="body" idx="16" sz="quarter"/>
+            <p:ph idx="1"/>
           </p:nvPr>
         </p:nvSpPr>
         <p:spPr/>
@@ -10496,8 +11624,57 @@
           <a:bodyPr/>
           <a:lstStyle/>
           <a:p>
-            <a:r>
-              <a:t>03</a:t>
+            <a:pPr/>
+            <a:r>
+              <a:t>No labels — the algorithm finds structure in the data on its own</a:t>
+            </a:r>
+          </a:p>
+          <a:p>
+            <a:pPr/>
+            <a:r>
+              <a:t>Input:  [bytes_sent, duration, unique_ports]   (no label)</a:t>
+            </a:r>
+          </a:p>
+          <a:p>
+            <a:pPr/>
+            <a:r>
+              <a:t>Output: "this connection looks different from all the others"</a:t>
+            </a:r>
+          </a:p>
+          <a:p>
+            <a:pPr/>
+            <a:r>
+              <a:t>You don't need to know what an attack looks like</a:t>
+            </a:r>
+          </a:p>
+          <a:p>
+            <a:pPr/>
+            <a:r>
+              <a:t>You just need to know when something deviates from normal</a:t>
+            </a:r>
+          </a:p>
+          <a:p>
+            <a:pPr/>
+            <a:r>
+              <a:t>Security applications:</a:t>
+            </a:r>
+          </a:p>
+          <a:p>
+            <a:pPr lvl="1"/>
+            <a:r>
+              <a:t>Anomaly detection in network traffic</a:t>
+            </a:r>
+          </a:p>
+          <a:p>
+            <a:pPr lvl="1"/>
+            <a:r>
+              <a:t>Clustering user behaviour to find insider threats</a:t>
+            </a:r>
+          </a:p>
+          <a:p>
+            <a:pPr/>
+            <a:r>
+              <a:t>Covered in Stage 2, Lesson 2.3</a:t>
             </a:r>
           </a:p>
         </p:txBody>

</xml_diff>

<commit_message>
Rebuild Lecture-1 with charts, diagrams, and visual layouts
12 embedded images: training loop diagram, loss curve chart, class
imbalance comparison, ML workflow flowchart, train/test split visual,
digit grid, pixel number grid, average prototypes, three ML types cards,
features-vs-labels table, EDA checklist, Python tools cards. Uses 2-Column,
Bullets+Pull Quote, and Title Only layouts alongside standard bullets.
</commit_message>
<xml_diff>
--- a/stage1_classic_ml/01_what_is_ml/Lecture-1-What-is-ML.pptx
+++ b/stage1_classic_ml/01_what_is_ml/Lecture-1-What-is-ML.pptx
@@ -43,10 +43,6 @@
     <p:sldId id="285" r:id="rId41"/>
     <p:sldId id="286" r:id="rId42"/>
     <p:sldId id="287" r:id="rId43"/>
-    <p:sldId id="288" r:id="rId44"/>
-    <p:sldId id="289" r:id="rId45"/>
-    <p:sldId id="290" r:id="rId46"/>
-    <p:sldId id="291" r:id="rId47"/>
   </p:sldIdLst>
   <p:sldSz cx="12188825" cy="6858000"/>
   <p:notesSz cx="7010400" cy="9296400"/>
@@ -8431,69 +8427,35 @@
           <a:lstStyle/>
           <a:p>
             <a:r>
-              <a:t>Reinforcement Learning — Trial and Error</a:t>
-            </a:r>
-          </a:p>
-        </p:txBody>
-      </p:sp>
-      <p:sp>
-        <p:nvSpPr>
-          <p:cNvPr id="3" name="Content Placeholder 2"/>
-          <p:cNvSpPr>
-            <a:spLocks noGrp="1"/>
-          </p:cNvSpPr>
-          <p:nvPr>
-            <p:ph idx="1"/>
-          </p:nvPr>
-        </p:nvSpPr>
-        <p:spPr/>
-        <p:txBody>
-          <a:bodyPr/>
-          <a:lstStyle/>
-          <a:p>
-            <a:pPr/>
-            <a:r>
-              <a:t>The model learns by interacting with an environment</a:t>
-            </a:r>
-          </a:p>
-          <a:p>
-            <a:pPr/>
-            <a:r>
-              <a:t>Receives rewards for correct decisions, penalties for bad ones</a:t>
-            </a:r>
-          </a:p>
-          <a:p>
-            <a:pPr/>
-            <a:r>
-              <a:t>Over time, it develops a strategy that maximises total reward</a:t>
-            </a:r>
-          </a:p>
-          <a:p>
-            <a:pPr/>
-            <a:r>
-              <a:t>Less common in day-to-day security, but growing:</a:t>
-            </a:r>
-          </a:p>
-          <a:p>
-            <a:pPr lvl="1"/>
-            <a:r>
-              <a:t>Automated penetration testing agents</a:t>
-            </a:r>
-          </a:p>
-          <a:p>
-            <a:pPr lvl="1"/>
-            <a:r>
-              <a:t>Adaptive threat response systems</a:t>
-            </a:r>
-          </a:p>
-          <a:p>
-            <a:pPr/>
-            <a:r>
-              <a:t>Not covered in this curriculum — but you should know it exists</a:t>
-            </a:r>
-          </a:p>
-        </p:txBody>
-      </p:sp>
+              <a:t>Watching the Loss Drop Over Training</a:t>
+            </a:r>
+          </a:p>
+        </p:txBody>
+      </p:sp>
+      <p:pic>
+        <p:nvPicPr>
+          <p:cNvPr id="3" name="Picture 2" descr="loss_curve.png"/>
+          <p:cNvPicPr>
+            <a:picLocks noChangeAspect="1"/>
+          </p:cNvPicPr>
+          <p:nvPr/>
+        </p:nvPicPr>
+        <p:blipFill>
+          <a:blip r:embed="rId2"/>
+          <a:stretch>
+            <a:fillRect/>
+          </a:stretch>
+        </p:blipFill>
+        <p:spPr>
+          <a:xfrm>
+            <a:off x="1828800" y="1371600"/>
+            <a:ext cx="8229600" cy="4065447"/>
+          </a:xfrm>
+          <a:prstGeom prst="rect">
+            <a:avLst/>
+          </a:prstGeom>
+        </p:spPr>
+      </p:pic>
     </p:spTree>
   </p:cSld>
   <p:clrMapOvr>
@@ -8519,23 +8481,14 @@
             <a:spLocks noGrp="1"/>
           </p:cNvSpPr>
           <p:nvPr>
-            <p:ph type="body" idx="13" sz="quarter"/>
+            <p:ph type="body" idx="14" sz="quarter"/>
           </p:nvPr>
         </p:nvSpPr>
         <p:spPr/>
         <p:txBody>
           <a:bodyPr/>
           <a:lstStyle/>
-          <a:p>
-            <a:r>
-              <a:t>How a Model</a:t>
-            </a:r>
-          </a:p>
-          <a:p>
-            <a:r>
-              <a:t>Actually Learns</a:t>
-            </a:r>
-          </a:p>
+          <a:p/>
         </p:txBody>
       </p:sp>
       <p:sp>
@@ -8545,6 +8498,58 @@
             <a:spLocks noGrp="1"/>
           </p:cNvSpPr>
           <p:nvPr>
+            <p:ph type="body" idx="15" sz="quarter"/>
+          </p:nvPr>
+        </p:nvSpPr>
+        <p:spPr/>
+        <p:txBody>
+          <a:bodyPr/>
+          <a:lstStyle/>
+          <a:p>
+            <a:r>
+              <a:t>The patterns are combinations of</a:t>
+            </a:r>
+          </a:p>
+          <a:p>
+            <a:r>
+              <a:t>dozens of subtle signals that</a:t>
+            </a:r>
+          </a:p>
+          <a:p>
+            <a:r>
+              <a:t>no human would write as rules.</a:t>
+            </a:r>
+          </a:p>
+        </p:txBody>
+      </p:sp>
+      <p:sp>
+        <p:nvSpPr>
+          <p:cNvPr id="4" name="Title 3"/>
+          <p:cNvSpPr>
+            <a:spLocks noGrp="1"/>
+          </p:cNvSpPr>
+          <p:nvPr>
+            <p:ph type="title"/>
+          </p:nvPr>
+        </p:nvSpPr>
+        <p:spPr/>
+        <p:txBody>
+          <a:bodyPr/>
+          <a:lstStyle/>
+          <a:p>
+            <a:r>
+              <a:t>Weights and Loss — What the Model Learns</a:t>
+            </a:r>
+          </a:p>
+        </p:txBody>
+      </p:sp>
+      <p:sp>
+        <p:nvSpPr>
+          <p:cNvPr id="5" name="Text Placeholder 4"/>
+          <p:cNvSpPr>
+            <a:spLocks noGrp="1"/>
+          </p:cNvSpPr>
+          <p:nvPr>
             <p:ph type="body" idx="16" sz="quarter"/>
           </p:nvPr>
         </p:nvSpPr>
@@ -8553,8 +8558,39 @@
           <a:bodyPr/>
           <a:lstStyle/>
           <a:p>
-            <a:r>
-              <a:t>03</a:t>
+            <a:pPr/>
+            <a:r>
+              <a:t>Weights — numbers inside the model</a:t>
+            </a:r>
+          </a:p>
+          <a:p>
+            <a:pPr lvl="1"/>
+            <a:r>
+              <a:t>Adjusted during training to minimise loss</a:t>
+            </a:r>
+          </a:p>
+          <a:p>
+            <a:pPr/>
+            <a:r>
+              <a:t>Loss — how wrong the predictions are</a:t>
+            </a:r>
+          </a:p>
+          <a:p>
+            <a:pPr lvl="1"/>
+            <a:r>
+              <a:t>Training = finding weights that minimise loss</a:t>
+            </a:r>
+          </a:p>
+          <a:p>
+            <a:pPr/>
+            <a:r>
+              <a:t>You don't write any of this</a:t>
+            </a:r>
+          </a:p>
+          <a:p>
+            <a:pPr lvl="1"/>
+            <a:r>
+              <a:t>The ML library handles it automatically</a:t>
             </a:r>
           </a:p>
         </p:txBody>
@@ -8579,12 +8615,12 @@
       <p:grpSpPr/>
       <p:sp>
         <p:nvSpPr>
-          <p:cNvPr id="2" name="Title 1"/>
+          <p:cNvPr id="2" name="Text Placeholder 1"/>
           <p:cNvSpPr>
             <a:spLocks noGrp="1"/>
           </p:cNvSpPr>
           <p:nvPr>
-            <p:ph type="title"/>
+            <p:ph type="body" idx="13" sz="quarter"/>
           </p:nvPr>
         </p:nvSpPr>
         <p:spPr/>
@@ -8593,19 +8629,19 @@
           <a:lstStyle/>
           <a:p>
             <a:r>
-              <a:t>The Learning Loop — What Happens Inside model.fit()</a:t>
-            </a:r>
-          </a:p>
-        </p:txBody>
-      </p:sp>
-      <p:sp>
-        <p:nvSpPr>
-          <p:cNvPr id="3" name="Content Placeholder 2"/>
+              <a:t>The ML Workflow</a:t>
+            </a:r>
+          </a:p>
+        </p:txBody>
+      </p:sp>
+      <p:sp>
+        <p:nvSpPr>
+          <p:cNvPr id="3" name="Text Placeholder 2"/>
           <p:cNvSpPr>
             <a:spLocks noGrp="1"/>
           </p:cNvSpPr>
           <p:nvPr>
-            <p:ph idx="1"/>
+            <p:ph type="body" idx="16" sz="quarter"/>
           </p:nvPr>
         </p:nvSpPr>
         <p:spPr/>
@@ -8613,45 +8649,8 @@
           <a:bodyPr/>
           <a:lstStyle/>
           <a:p>
-            <a:pPr/>
-            <a:r>
-              <a:t>1.  The model makes a prediction on a training sample</a:t>
-            </a:r>
-          </a:p>
-          <a:p>
-            <a:pPr/>
-            <a:r>
-              <a:t>2.  Compare prediction to the correct label</a:t>
-            </a:r>
-          </a:p>
-          <a:p>
-            <a:pPr lvl="1"/>
-            <a:r>
-              <a:t>     The difference is called the loss</a:t>
-            </a:r>
-          </a:p>
-          <a:p>
-            <a:pPr/>
-            <a:r>
-              <a:t>3.  The model adjusts its internal numbers (weights) to reduce the loss</a:t>
-            </a:r>
-          </a:p>
-          <a:p>
-            <a:pPr/>
-            <a:r>
-              <a:t>4.  Repeat for every sample — one full pass = one epoch</a:t>
-            </a:r>
-          </a:p>
-          <a:p>
-            <a:pPr/>
-            <a:r>
-              <a:t>After enough epochs, the weights settle into values that</a:t>
-            </a:r>
-          </a:p>
-          <a:p>
-            <a:pPr/>
-            <a:r>
-              <a:t>produce correct predictions on data the model has never seen</a:t>
+            <a:r>
+              <a:t>04</a:t>
             </a:r>
           </a:p>
         </p:txBody>
@@ -8690,81 +8689,35 @@
           <a:lstStyle/>
           <a:p>
             <a:r>
-              <a:t>Watching the Loss Drop</a:t>
-            </a:r>
-          </a:p>
-        </p:txBody>
-      </p:sp>
-      <p:sp>
-        <p:nvSpPr>
-          <p:cNvPr id="3" name="Content Placeholder 2"/>
-          <p:cNvSpPr>
-            <a:spLocks noGrp="1"/>
-          </p:cNvSpPr>
-          <p:nvPr>
-            <p:ph idx="1"/>
-          </p:nvPr>
-        </p:nvSpPr>
-        <p:spPr/>
-        <p:txBody>
-          <a:bodyPr/>
-          <a:lstStyle/>
-          <a:p>
-            <a:pPr/>
-            <a:r>
-              <a:t>Epoch 1:    Loss = 0.92   (model is mostly guessing)</a:t>
-            </a:r>
-          </a:p>
-          <a:p>
-            <a:pPr/>
-            <a:r>
-              <a:t>Epoch 10:   Loss = 0.41   (model is learning patterns)</a:t>
-            </a:r>
-          </a:p>
-          <a:p>
-            <a:pPr/>
-            <a:r>
-              <a:t>Epoch 50:   Loss = 0.08   (model is now reliable)</a:t>
-            </a:r>
-          </a:p>
-          <a:p>
-            <a:pPr/>
-            <a:r>
-              <a:t>Loss is a single number measuring "how wrong are we?"</a:t>
-            </a:r>
-          </a:p>
-          <a:p>
-            <a:pPr/>
-            <a:r>
-              <a:t>Training = finding the weights that minimise this number</a:t>
-            </a:r>
-          </a:p>
-          <a:p>
-            <a:pPr/>
-            <a:r>
-              <a:t>Weights — the numbers inside the model, adjusted during training</a:t>
-            </a:r>
-          </a:p>
-          <a:p>
-            <a:pPr/>
-            <a:r>
-              <a:t>They encode learned patterns like:</a:t>
-            </a:r>
-          </a:p>
-          <a:p>
-            <a:pPr lvl="1"/>
-            <a:r>
-              <a:t>"emails with many links + young sender domain → spam"</a:t>
-            </a:r>
-          </a:p>
-          <a:p>
-            <a:pPr/>
-            <a:r>
-              <a:t>You don't write any of this — the ML library handles it</a:t>
-            </a:r>
-          </a:p>
-        </p:txBody>
-      </p:sp>
+              <a:t>Every Project Follows This Loop</a:t>
+            </a:r>
+          </a:p>
+        </p:txBody>
+      </p:sp>
+      <p:pic>
+        <p:nvPicPr>
+          <p:cNvPr id="3" name="Picture 2" descr="ml_workflow.png"/>
+          <p:cNvPicPr>
+            <a:picLocks noChangeAspect="1"/>
+          </p:cNvPicPr>
+          <p:nvPr/>
+        </p:nvPicPr>
+        <p:blipFill>
+          <a:blip r:embed="rId2"/>
+          <a:stretch>
+            <a:fillRect/>
+          </a:stretch>
+        </p:blipFill>
+        <p:spPr>
+          <a:xfrm>
+            <a:off x="457200" y="1371600"/>
+            <a:ext cx="11247120" cy="4675273"/>
+          </a:xfrm>
+          <a:prstGeom prst="rect">
+            <a:avLst/>
+          </a:prstGeom>
+        </p:spPr>
+      </p:pic>
     </p:spTree>
   </p:cSld>
   <p:clrMapOvr>
@@ -8785,12 +8738,12 @@
       <p:grpSpPr/>
       <p:sp>
         <p:nvSpPr>
-          <p:cNvPr id="2" name="Text Placeholder 1"/>
+          <p:cNvPr id="2" name="Title 1"/>
           <p:cNvSpPr>
             <a:spLocks noGrp="1"/>
           </p:cNvSpPr>
           <p:nvPr>
-            <p:ph type="body" idx="13" sz="quarter"/>
+            <p:ph type="title"/>
           </p:nvPr>
         </p:nvSpPr>
         <p:spPr/>
@@ -8799,32 +8752,35 @@
           <a:lstStyle/>
           <a:p>
             <a:r>
-              <a:t>The ML Workflow</a:t>
-            </a:r>
-          </a:p>
-        </p:txBody>
-      </p:sp>
-      <p:sp>
-        <p:nvSpPr>
-          <p:cNvPr id="3" name="Text Placeholder 2"/>
-          <p:cNvSpPr>
-            <a:spLocks noGrp="1"/>
-          </p:cNvSpPr>
-          <p:nvPr>
-            <p:ph type="body" idx="16" sz="quarter"/>
-          </p:nvPr>
-        </p:nvSpPr>
-        <p:spPr/>
-        <p:txBody>
-          <a:bodyPr/>
-          <a:lstStyle/>
-          <a:p>
-            <a:r>
-              <a:t>04</a:t>
-            </a:r>
-          </a:p>
-        </p:txBody>
-      </p:sp>
+              <a:t>The Train / Test Split</a:t>
+            </a:r>
+          </a:p>
+        </p:txBody>
+      </p:sp>
+      <p:pic>
+        <p:nvPicPr>
+          <p:cNvPr id="3" name="Picture 2" descr="train_test_split.png"/>
+          <p:cNvPicPr>
+            <a:picLocks noChangeAspect="1"/>
+          </p:cNvPicPr>
+          <p:nvPr/>
+        </p:nvPicPr>
+        <p:blipFill>
+          <a:blip r:embed="rId2"/>
+          <a:stretch>
+            <a:fillRect/>
+          </a:stretch>
+        </p:blipFill>
+        <p:spPr>
+          <a:xfrm>
+            <a:off x="1371600" y="1188720"/>
+            <a:ext cx="9418320" cy="3310682"/>
+          </a:xfrm>
+          <a:prstGeom prst="rect">
+            <a:avLst/>
+          </a:prstGeom>
+        </p:spPr>
+      </p:pic>
     </p:spTree>
   </p:cSld>
   <p:clrMapOvr>
@@ -8845,12 +8801,12 @@
       <p:grpSpPr/>
       <p:sp>
         <p:nvSpPr>
-          <p:cNvPr id="2" name="Title 1"/>
+          <p:cNvPr id="2" name="Text Placeholder 1"/>
           <p:cNvSpPr>
             <a:spLocks noGrp="1"/>
           </p:cNvSpPr>
           <p:nvPr>
-            <p:ph type="title"/>
+            <p:ph type="body" idx="13" sz="quarter"/>
           </p:nvPr>
         </p:nvSpPr>
         <p:spPr/>
@@ -8859,19 +8815,24 @@
           <a:lstStyle/>
           <a:p>
             <a:r>
-              <a:t>The ML Workflow — Every Project Follows This Loop</a:t>
-            </a:r>
-          </a:p>
-        </p:txBody>
-      </p:sp>
-      <p:sp>
-        <p:nvSpPr>
-          <p:cNvPr id="3" name="Content Placeholder 2"/>
+              <a:t>Exploratory Data</a:t>
+            </a:r>
+          </a:p>
+          <a:p>
+            <a:r>
+              <a:t>Analysis (EDA)</a:t>
+            </a:r>
+          </a:p>
+        </p:txBody>
+      </p:sp>
+      <p:sp>
+        <p:nvSpPr>
+          <p:cNvPr id="3" name="Text Placeholder 2"/>
           <p:cNvSpPr>
             <a:spLocks noGrp="1"/>
           </p:cNvSpPr>
           <p:nvPr>
-            <p:ph idx="1"/>
+            <p:ph type="body" idx="16" sz="quarter"/>
           </p:nvPr>
         </p:nvSpPr>
         <p:spPr/>
@@ -8879,57 +8840,8 @@
           <a:bodyPr/>
           <a:lstStyle/>
           <a:p>
-            <a:pPr/>
-            <a:r>
-              <a:t>1.  Get data</a:t>
-            </a:r>
-          </a:p>
-          <a:p>
-            <a:pPr/>
-            <a:r>
-              <a:t>2.  Clean and prepare it</a:t>
-            </a:r>
-          </a:p>
-          <a:p>
-            <a:pPr/>
-            <a:r>
-              <a:t>3.  Explore the data (EDA) — what you are about to learn</a:t>
-            </a:r>
-          </a:p>
-          <a:p>
-            <a:pPr/>
-            <a:r>
-              <a:t>4.  Split into training set and test set</a:t>
-            </a:r>
-          </a:p>
-          <a:p>
-            <a:pPr/>
-            <a:r>
-              <a:t>5.  Train the model on the training set</a:t>
-            </a:r>
-          </a:p>
-          <a:p>
-            <a:pPr/>
-            <a:r>
-              <a:t>6.  Evaluate on the test set</a:t>
-            </a:r>
-          </a:p>
-          <a:p>
-            <a:pPr/>
-            <a:r>
-              <a:t>7.  Tune → repeat from step 5</a:t>
-            </a:r>
-          </a:p>
-          <a:p>
-            <a:pPr/>
-            <a:r>
-              <a:t>8.  Deploy / use</a:t>
-            </a:r>
-          </a:p>
-          <a:p>
-            <a:pPr/>
-            <a:r>
-              <a:t>This loop applies to every ML project you will ever build</a:t>
+            <a:r>
+              <a:t>05</a:t>
             </a:r>
           </a:p>
         </p:txBody>
@@ -8968,75 +8880,35 @@
           <a:lstStyle/>
           <a:p>
             <a:r>
-              <a:t>Why the Train / Test Split Matters</a:t>
-            </a:r>
-          </a:p>
-        </p:txBody>
-      </p:sp>
-      <p:sp>
-        <p:nvSpPr>
-          <p:cNvPr id="3" name="Content Placeholder 2"/>
-          <p:cNvSpPr>
-            <a:spLocks noGrp="1"/>
-          </p:cNvSpPr>
-          <p:nvPr>
-            <p:ph idx="1"/>
-          </p:nvPr>
-        </p:nvSpPr>
-        <p:spPr/>
-        <p:txBody>
-          <a:bodyPr/>
-          <a:lstStyle/>
-          <a:p>
-            <a:pPr/>
-            <a:r>
-              <a:t>If you evaluate on the same data you trained on:</a:t>
-            </a:r>
-          </a:p>
-          <a:p>
-            <a:pPr lvl="1"/>
-            <a:r>
-              <a:t>You are measuring memorisation, not generalisation</a:t>
-            </a:r>
-          </a:p>
-          <a:p>
-            <a:pPr lvl="1"/>
-            <a:r>
-              <a:t>A model can score 100% by memorising every example</a:t>
-            </a:r>
-          </a:p>
-          <a:p>
-            <a:pPr lvl="1"/>
-            <a:r>
-              <a:t>It has learned nothing useful about unseen data</a:t>
-            </a:r>
-          </a:p>
-          <a:p>
-            <a:pPr/>
-            <a:r>
-              <a:t>The test set is data the model has never seen during training</a:t>
-            </a:r>
-          </a:p>
-          <a:p>
-            <a:pPr lvl="1"/>
-            <a:r>
-              <a:t>It gives an honest measure of real-world performance</a:t>
-            </a:r>
-          </a:p>
-          <a:p>
-            <a:pPr/>
-            <a:r>
-              <a:t>This is the single most important rule in ML:</a:t>
-            </a:r>
-          </a:p>
-          <a:p>
-            <a:pPr lvl="1"/>
-            <a:r>
-              <a:t>Never evaluate on training data</a:t>
-            </a:r>
-          </a:p>
-        </p:txBody>
-      </p:sp>
+              <a:t>EDA — Examine Your Data Before Training Anything</a:t>
+            </a:r>
+          </a:p>
+        </p:txBody>
+      </p:sp>
+      <p:pic>
+        <p:nvPicPr>
+          <p:cNvPr id="3" name="Picture 2" descr="eda_checklist.png"/>
+          <p:cNvPicPr>
+            <a:picLocks noChangeAspect="1"/>
+          </p:cNvPicPr>
+          <p:nvPr/>
+        </p:nvPicPr>
+        <p:blipFill>
+          <a:blip r:embed="rId2"/>
+          <a:stretch>
+            <a:fillRect/>
+          </a:stretch>
+        </p:blipFill>
+        <p:spPr>
+          <a:xfrm>
+            <a:off x="1371600" y="1188720"/>
+            <a:ext cx="9418320" cy="4705989"/>
+          </a:xfrm>
+          <a:prstGeom prst="rect">
+            <a:avLst/>
+          </a:prstGeom>
+        </p:spPr>
+      </p:pic>
     </p:spTree>
   </p:cSld>
   <p:clrMapOvr>
@@ -9057,12 +8929,12 @@
       <p:grpSpPr/>
       <p:sp>
         <p:nvSpPr>
-          <p:cNvPr id="2" name="Text Placeholder 1"/>
+          <p:cNvPr id="2" name="Title 1"/>
           <p:cNvSpPr>
             <a:spLocks noGrp="1"/>
           </p:cNvSpPr>
           <p:nvPr>
-            <p:ph type="body" idx="13" sz="quarter"/>
+            <p:ph type="title"/>
           </p:nvPr>
         </p:nvSpPr>
         <p:spPr/>
@@ -9071,37 +8943,35 @@
           <a:lstStyle/>
           <a:p>
             <a:r>
-              <a:t>Exploratory Data</a:t>
-            </a:r>
-          </a:p>
-          <a:p>
-            <a:r>
-              <a:t>Analysis (EDA)</a:t>
-            </a:r>
-          </a:p>
-        </p:txBody>
-      </p:sp>
-      <p:sp>
-        <p:nvSpPr>
-          <p:cNvPr id="3" name="Text Placeholder 2"/>
-          <p:cNvSpPr>
-            <a:spLocks noGrp="1"/>
-          </p:cNvSpPr>
-          <p:nvPr>
-            <p:ph type="body" idx="16" sz="quarter"/>
-          </p:nvPr>
-        </p:nvSpPr>
-        <p:spPr/>
-        <p:txBody>
-          <a:bodyPr/>
-          <a:lstStyle/>
-          <a:p>
-            <a:r>
-              <a:t>05</a:t>
-            </a:r>
-          </a:p>
-        </p:txBody>
-      </p:sp>
+              <a:t>The Class Imbalance Problem</a:t>
+            </a:r>
+          </a:p>
+        </p:txBody>
+      </p:sp>
+      <p:pic>
+        <p:nvPicPr>
+          <p:cNvPr id="3" name="Picture 2" descr="class_imbalance.png"/>
+          <p:cNvPicPr>
+            <a:picLocks noChangeAspect="1"/>
+          </p:cNvPicPr>
+          <p:nvPr/>
+        </p:nvPicPr>
+        <p:blipFill>
+          <a:blip r:embed="rId2"/>
+          <a:stretch>
+            <a:fillRect/>
+          </a:stretch>
+        </p:blipFill>
+        <p:spPr>
+          <a:xfrm>
+            <a:off x="1097280" y="1371600"/>
+            <a:ext cx="10058400" cy="4045561"/>
+          </a:xfrm>
+          <a:prstGeom prst="rect">
+            <a:avLst/>
+          </a:prstGeom>
+        </p:spPr>
+      </p:pic>
     </p:spTree>
   </p:cSld>
   <p:clrMapOvr>
@@ -9122,7 +8992,60 @@
       <p:grpSpPr/>
       <p:sp>
         <p:nvSpPr>
-          <p:cNvPr id="2" name="Title 1"/>
+          <p:cNvPr id="2" name="Text Placeholder 1"/>
+          <p:cNvSpPr>
+            <a:spLocks noGrp="1"/>
+          </p:cNvSpPr>
+          <p:nvPr>
+            <p:ph type="body" idx="14" sz="quarter"/>
+          </p:nvPr>
+        </p:nvSpPr>
+        <p:spPr/>
+        <p:txBody>
+          <a:bodyPr/>
+          <a:lstStyle/>
+          <a:p>
+            <a:r>
+              <a:t>— Lesson 1.5 covers the solution</a:t>
+            </a:r>
+          </a:p>
+        </p:txBody>
+      </p:sp>
+      <p:sp>
+        <p:nvSpPr>
+          <p:cNvPr id="3" name="Text Placeholder 2"/>
+          <p:cNvSpPr>
+            <a:spLocks noGrp="1"/>
+          </p:cNvSpPr>
+          <p:nvPr>
+            <p:ph type="body" idx="15" sz="quarter"/>
+          </p:nvPr>
+        </p:nvSpPr>
+        <p:spPr/>
+        <p:txBody>
+          <a:bodyPr/>
+          <a:lstStyle/>
+          <a:p>
+            <a:r>
+              <a:t>A model with 95% accuracy</a:t>
+            </a:r>
+          </a:p>
+          <a:p>
+            <a:r>
+              <a:t>can catch zero attacks.</a:t>
+            </a:r>
+          </a:p>
+          <a:p/>
+          <a:p>
+            <a:r>
+              <a:t>You need better metrics.</a:t>
+            </a:r>
+          </a:p>
+        </p:txBody>
+      </p:sp>
+      <p:sp>
+        <p:nvSpPr>
+          <p:cNvPr id="4" name="Title 3"/>
           <p:cNvSpPr>
             <a:spLocks noGrp="1"/>
           </p:cNvSpPr>
@@ -9136,19 +9059,19 @@
           <a:lstStyle/>
           <a:p>
             <a:r>
-              <a:t>EDA — Examine Your Data Before Training Anything</a:t>
-            </a:r>
-          </a:p>
-        </p:txBody>
-      </p:sp>
-      <p:sp>
-        <p:nvSpPr>
-          <p:cNvPr id="3" name="Content Placeholder 2"/>
+              <a:t>The Naive Accuracy Trap</a:t>
+            </a:r>
+          </a:p>
+        </p:txBody>
+      </p:sp>
+      <p:sp>
+        <p:nvSpPr>
+          <p:cNvPr id="5" name="Text Placeholder 4"/>
           <p:cNvSpPr>
             <a:spLocks noGrp="1"/>
           </p:cNvSpPr>
           <p:nvPr>
-            <p:ph idx="1"/>
+            <p:ph type="body" idx="16" sz="quarter"/>
           </p:nvPr>
         </p:nvSpPr>
         <p:spPr/>
@@ -9158,55 +9081,43 @@
           <a:p>
             <a:pPr/>
             <a:r>
-              <a:t>Skipping EDA is the #1 reason ML projects fail silently</a:t>
+              <a:t>10,000 connections, 100 are attacks (1%)</a:t>
             </a:r>
           </a:p>
           <a:p>
             <a:pPr/>
             <a:r>
-              <a:t>The model trains without errors, produces reasonable numbers...</a:t>
+              <a:t>A model that always predicts 'normal':</a:t>
+            </a:r>
+          </a:p>
+          <a:p>
+            <a:pPr lvl="1"/>
+            <a:r>
+              <a:t>Accuracy = 99%</a:t>
+            </a:r>
+          </a:p>
+          <a:p>
+            <a:pPr lvl="1"/>
+            <a:r>
+              <a:t>Attacks caught = 0</a:t>
             </a:r>
           </a:p>
           <a:p>
             <a:pPr/>
             <a:r>
-              <a:t>...then performs terribly in production</a:t>
-            </a:r>
-          </a:p>
-          <a:p>
-            <a:pPr/>
-            <a:r>
-              <a:t>Because a problem in the data was never caught</a:t>
-            </a:r>
-          </a:p>
-          <a:p>
-            <a:pPr/>
-            <a:r>
-              <a:t>What you are looking for:</a:t>
+              <a:t>This is everywhere in security:</a:t>
             </a:r>
           </a:p>
           <a:p>
             <a:pPr lvl="1"/>
             <a:r>
-              <a:t>Class balance — how many examples of each class?</a:t>
+              <a:t>Network intrusion: 99% normal, 1% attack</a:t>
             </a:r>
           </a:p>
           <a:p>
             <a:pPr lvl="1"/>
             <a:r>
-              <a:t>Missing values — gaps in log data, sensors that went offline</a:t>
-            </a:r>
-          </a:p>
-          <a:p>
-            <a:pPr lvl="1"/>
-            <a:r>
-              <a:t>Feature distributions — outliers, unexpected ranges</a:t>
-            </a:r>
-          </a:p>
-          <a:p>
-            <a:pPr lvl="1"/>
-            <a:r>
-              <a:t>Data leakage — features that accidentally reveal the label</a:t>
+              <a:t>Fraud: 99.8% legitimate, 0.2% fraud</a:t>
             </a:r>
           </a:p>
         </p:txBody>
@@ -9231,12 +9142,12 @@
       <p:grpSpPr/>
       <p:sp>
         <p:nvSpPr>
-          <p:cNvPr id="2" name="Title 1"/>
+          <p:cNvPr id="2" name="Text Placeholder 1"/>
           <p:cNvSpPr>
             <a:spLocks noGrp="1"/>
           </p:cNvSpPr>
           <p:nvPr>
-            <p:ph type="title"/>
+            <p:ph type="body" idx="13" sz="quarter"/>
           </p:nvPr>
         </p:nvSpPr>
         <p:spPr/>
@@ -9245,19 +9156,24 @@
           <a:lstStyle/>
           <a:p>
             <a:r>
-              <a:t>The Class Imbalance Problem</a:t>
-            </a:r>
-          </a:p>
-        </p:txBody>
-      </p:sp>
-      <p:sp>
-        <p:nvSpPr>
-          <p:cNvPr id="3" name="Content Placeholder 2"/>
+              <a:t>The Dataset:</a:t>
+            </a:r>
+          </a:p>
+          <a:p>
+            <a:r>
+              <a:t>Handwritten Digits</a:t>
+            </a:r>
+          </a:p>
+        </p:txBody>
+      </p:sp>
+      <p:sp>
+        <p:nvSpPr>
+          <p:cNvPr id="3" name="Text Placeholder 2"/>
           <p:cNvSpPr>
             <a:spLocks noGrp="1"/>
           </p:cNvSpPr>
           <p:nvPr>
-            <p:ph idx="1"/>
+            <p:ph type="body" idx="16" sz="quarter"/>
           </p:nvPr>
         </p:nvSpPr>
         <p:spPr/>
@@ -9265,63 +9181,8 @@
           <a:bodyPr/>
           <a:lstStyle/>
           <a:p>
-            <a:pPr/>
-            <a:r>
-              <a:t>Typical security dataset:</a:t>
-            </a:r>
-          </a:p>
-          <a:p>
-            <a:pPr lvl="1"/>
-            <a:r>
-              <a:t>Normal traffic:   950,000 connections   (95%)</a:t>
-            </a:r>
-          </a:p>
-          <a:p>
-            <a:pPr lvl="1"/>
-            <a:r>
-              <a:t>Attack traffic:     50,000 connections     (5%)</a:t>
-            </a:r>
-          </a:p>
-          <a:p>
-            <a:pPr/>
-            <a:r>
-              <a:t>A model that always predicts "normal":</a:t>
-            </a:r>
-          </a:p>
-          <a:p>
-            <a:pPr lvl="1"/>
-            <a:r>
-              <a:t>Accuracy = 95%</a:t>
-            </a:r>
-          </a:p>
-          <a:p>
-            <a:pPr lvl="1"/>
-            <a:r>
-              <a:t>Attacks caught = 0</a:t>
-            </a:r>
-          </a:p>
-          <a:p>
-            <a:pPr/>
-            <a:r>
-              <a:t>This is the naive accuracy trap — a score you must beat</a:t>
-            </a:r>
-          </a:p>
-          <a:p>
-            <a:pPr/>
-            <a:r>
-              <a:t>It is everywhere in security:</a:t>
-            </a:r>
-          </a:p>
-          <a:p>
-            <a:pPr lvl="1"/>
-            <a:r>
-              <a:t>Network intrusion: 99% normal, 1% attack</a:t>
-            </a:r>
-          </a:p>
-          <a:p>
-            <a:pPr lvl="1"/>
-            <a:r>
-              <a:t>Fraud detection:   99.8% legitimate, 0.2% fraud</a:t>
+            <a:r>
+              <a:t>06</a:t>
             </a:r>
           </a:p>
         </p:txBody>
@@ -9367,31 +9228,31 @@
           <a:p>
             <a:pPr/>
             <a:r>
-              <a:t>The three types of ML — supervised, unsupervised, reinforcement</a:t>
+              <a:t>The three types of ML</a:t>
             </a:r>
           </a:p>
           <a:p>
             <a:pPr/>
             <a:r>
-              <a:t>How a model actually learns — weights, loss, epochs</a:t>
+              <a:t>How a model actually learns — the training loop</a:t>
             </a:r>
           </a:p>
           <a:p>
             <a:pPr/>
             <a:r>
-              <a:t>The ML workflow — the 8-step loop every project follows</a:t>
+              <a:t>The ML workflow and train/test split</a:t>
             </a:r>
           </a:p>
           <a:p>
             <a:pPr/>
             <a:r>
-              <a:t>Exploratory Data Analysis (EDA) — why skipping it kills projects</a:t>
+              <a:t>Exploratory Data Analysis (EDA)</a:t>
             </a:r>
           </a:p>
           <a:p>
             <a:pPr/>
             <a:r>
-              <a:t>The dataset: 1,797 handwritten digits, 64 pixel features each</a:t>
+              <a:t>The dataset: handwritten digits</a:t>
             </a:r>
           </a:p>
           <a:p>
@@ -9403,13 +9264,13 @@
           <a:p>
             <a:pPr/>
             <a:r>
-              <a:t>Key vocabulary and Python tools</a:t>
+              <a:t>Python tools and key vocabulary</a:t>
             </a:r>
           </a:p>
           <a:p>
             <a:pPr/>
             <a:r>
-              <a:t>Workshop overview — 5 hands-on exercises</a:t>
+              <a:t>Workshop: 5 hands-on exercises</a:t>
             </a:r>
           </a:p>
         </p:txBody>
@@ -9469,81 +9330,35 @@
           <a:lstStyle/>
           <a:p>
             <a:r>
-              <a:t>Statistics Before Modelling</a:t>
-            </a:r>
-          </a:p>
-        </p:txBody>
-      </p:sp>
-      <p:sp>
-        <p:nvSpPr>
-          <p:cNvPr id="3" name="Content Placeholder 2"/>
-          <p:cNvSpPr>
-            <a:spLocks noGrp="1"/>
-          </p:cNvSpPr>
-          <p:nvPr>
-            <p:ph idx="1"/>
-          </p:nvPr>
-        </p:nvSpPr>
-        <p:spPr/>
-        <p:txBody>
-          <a:bodyPr/>
-          <a:lstStyle/>
-          <a:p>
-            <a:pPr/>
-            <a:r>
-              <a:t>df.describe() summarises every column in one call:</a:t>
-            </a:r>
-          </a:p>
-          <a:p>
-            <a:pPr lvl="1"/>
-            <a:r>
-              <a:t>count — how many non-null values (are there gaps?)</a:t>
-            </a:r>
-          </a:p>
-          <a:p>
-            <a:pPr lvl="1"/>
-            <a:r>
-              <a:t>mean, std — average and spread (is the feature useful?)</a:t>
-            </a:r>
-          </a:p>
-          <a:p>
-            <a:pPr lvl="1"/>
-            <a:r>
-              <a:t>min, max — are there impossible values? outliers?</a:t>
-            </a:r>
-          </a:p>
-          <a:p>
-            <a:pPr/>
-            <a:r>
-              <a:t>What the statistics catch:</a:t>
-            </a:r>
-          </a:p>
-          <a:p>
-            <a:pPr lvl="1"/>
-            <a:r>
-              <a:t>Zero-variance features (std = 0) → carries no information → remove it</a:t>
-            </a:r>
-          </a:p>
-          <a:p>
-            <a:pPr lvl="1"/>
-            <a:r>
-              <a:t>Wildly different scales → algorithms like KNN will break</a:t>
-            </a:r>
-          </a:p>
-          <a:p>
-            <a:pPr lvl="1"/>
-            <a:r>
-              <a:t>Missing values → NaN propagation → silent wrong predictions</a:t>
-            </a:r>
-          </a:p>
-          <a:p>
-            <a:pPr/>
-            <a:r>
-              <a:t>In security data, all of these are common</a:t>
-            </a:r>
-          </a:p>
-        </p:txBody>
-      </p:sp>
+              <a:t>1,797 Images — 10 Classes — 64 Pixel Features Each</a:t>
+            </a:r>
+          </a:p>
+        </p:txBody>
+      </p:sp>
+      <p:pic>
+        <p:nvPicPr>
+          <p:cNvPr id="3" name="Picture 2" descr="digit_grid.png"/>
+          <p:cNvPicPr>
+            <a:picLocks noChangeAspect="1"/>
+          </p:cNvPicPr>
+          <p:nvPr/>
+        </p:nvPicPr>
+        <p:blipFill>
+          <a:blip r:embed="rId2"/>
+          <a:stretch>
+            <a:fillRect/>
+          </a:stretch>
+        </p:blipFill>
+        <p:spPr>
+          <a:xfrm>
+            <a:off x="1554480" y="1371600"/>
+            <a:ext cx="9144000" cy="4198070"/>
+          </a:xfrm>
+          <a:prstGeom prst="rect">
+            <a:avLst/>
+          </a:prstGeom>
+        </p:spPr>
+      </p:pic>
     </p:spTree>
   </p:cSld>
   <p:clrMapOvr>
@@ -9578,75 +9393,35 @@
           <a:lstStyle/>
           <a:p>
             <a:r>
-              <a:t>Data Leakage — The Subtle Killer</a:t>
-            </a:r>
-          </a:p>
-        </p:txBody>
-      </p:sp>
-      <p:sp>
-        <p:nvSpPr>
-          <p:cNvPr id="3" name="Content Placeholder 2"/>
-          <p:cNvSpPr>
-            <a:spLocks noGrp="1"/>
-          </p:cNvSpPr>
-          <p:nvPr>
-            <p:ph idx="1"/>
-          </p:nvPr>
-        </p:nvSpPr>
-        <p:spPr/>
-        <p:txBody>
-          <a:bodyPr/>
-          <a:lstStyle/>
-          <a:p>
-            <a:pPr/>
-            <a:r>
-              <a:t>Sometimes a feature contains information about the label</a:t>
-            </a:r>
-          </a:p>
-          <a:p>
-            <a:pPr/>
-            <a:r>
-              <a:t>that would not be available at prediction time</a:t>
-            </a:r>
-          </a:p>
-          <a:p>
-            <a:pPr/>
-            <a:r>
-              <a:t>Example: a column "was_flagged_by_ids"</a:t>
-            </a:r>
-          </a:p>
-          <a:p>
-            <a:pPr lvl="1"/>
-            <a:r>
-              <a:t>Makes the model look perfect during training</a:t>
-            </a:r>
-          </a:p>
-          <a:p>
-            <a:pPr lvl="1"/>
-            <a:r>
-              <a:t>But this column would never exist on live traffic</a:t>
-            </a:r>
-          </a:p>
-          <a:p>
-            <a:pPr/>
-            <a:r>
-              <a:t>The model learned a shortcut, not the real pattern</a:t>
-            </a:r>
-          </a:p>
-          <a:p>
-            <a:pPr/>
-            <a:r>
-              <a:t>Always ask: "Would I have this feature at prediction time?"</a:t>
-            </a:r>
-          </a:p>
-          <a:p>
-            <a:pPr/>
-            <a:r>
-              <a:t>If the answer is no, remove it before training</a:t>
-            </a:r>
-          </a:p>
-        </p:txBody>
-      </p:sp>
+              <a:t>What the Model Actually Sees — Numbers, Not Images</a:t>
+            </a:r>
+          </a:p>
+        </p:txBody>
+      </p:sp>
+      <p:pic>
+        <p:nvPicPr>
+          <p:cNvPr id="3" name="Picture 2" descr="what_model_sees.png"/>
+          <p:cNvPicPr>
+            <a:picLocks noChangeAspect="1"/>
+          </p:cNvPicPr>
+          <p:nvPr/>
+        </p:nvPicPr>
+        <p:blipFill>
+          <a:blip r:embed="rId2"/>
+          <a:stretch>
+            <a:fillRect/>
+          </a:stretch>
+        </p:blipFill>
+        <p:spPr>
+          <a:xfrm>
+            <a:off x="1097280" y="1371600"/>
+            <a:ext cx="10058400" cy="3580421"/>
+          </a:xfrm>
+          <a:prstGeom prst="rect">
+            <a:avLst/>
+          </a:prstGeom>
+        </p:spPr>
+      </p:pic>
     </p:spTree>
   </p:cSld>
   <p:clrMapOvr>
@@ -9667,12 +9442,12 @@
       <p:grpSpPr/>
       <p:sp>
         <p:nvSpPr>
-          <p:cNvPr id="2" name="Text Placeholder 1"/>
+          <p:cNvPr id="2" name="Title 1"/>
           <p:cNvSpPr>
             <a:spLocks noGrp="1"/>
           </p:cNvSpPr>
           <p:nvPr>
-            <p:ph type="body" idx="13" sz="quarter"/>
+            <p:ph type="title"/>
           </p:nvPr>
         </p:nvSpPr>
         <p:spPr/>
@@ -9681,37 +9456,35 @@
           <a:lstStyle/>
           <a:p>
             <a:r>
-              <a:t>The Dataset:</a:t>
-            </a:r>
-          </a:p>
-          <a:p>
-            <a:r>
-              <a:t>Handwritten Digits</a:t>
-            </a:r>
-          </a:p>
-        </p:txBody>
-      </p:sp>
-      <p:sp>
-        <p:nvSpPr>
-          <p:cNvPr id="3" name="Text Placeholder 2"/>
-          <p:cNvSpPr>
-            <a:spLocks noGrp="1"/>
-          </p:cNvSpPr>
-          <p:nvPr>
-            <p:ph type="body" idx="16" sz="quarter"/>
-          </p:nvPr>
-        </p:nvSpPr>
-        <p:spPr/>
-        <p:txBody>
-          <a:bodyPr/>
-          <a:lstStyle/>
-          <a:p>
-            <a:r>
-              <a:t>06</a:t>
-            </a:r>
-          </a:p>
-        </p:txBody>
-      </p:sp>
+              <a:t>Average Image per Class — The Prototypes the Model Learns</a:t>
+            </a:r>
+          </a:p>
+        </p:txBody>
+      </p:sp>
+      <p:pic>
+        <p:nvPicPr>
+          <p:cNvPr id="3" name="Picture 2" descr="avg_digits.png"/>
+          <p:cNvPicPr>
+            <a:picLocks noChangeAspect="1"/>
+          </p:cNvPicPr>
+          <p:nvPr/>
+        </p:nvPicPr>
+        <p:blipFill>
+          <a:blip r:embed="rId2"/>
+          <a:stretch>
+            <a:fillRect/>
+          </a:stretch>
+        </p:blipFill>
+        <p:spPr>
+          <a:xfrm>
+            <a:off x="1554480" y="1371600"/>
+            <a:ext cx="9144000" cy="4201467"/>
+          </a:xfrm>
+          <a:prstGeom prst="rect">
+            <a:avLst/>
+          </a:prstGeom>
+        </p:spPr>
+      </p:pic>
     </p:spTree>
   </p:cSld>
   <p:clrMapOvr>
@@ -9732,12 +9505,12 @@
       <p:grpSpPr/>
       <p:sp>
         <p:nvSpPr>
-          <p:cNvPr id="2" name="Title 1"/>
+          <p:cNvPr id="2" name="Text Placeholder 1"/>
           <p:cNvSpPr>
             <a:spLocks noGrp="1"/>
           </p:cNvSpPr>
           <p:nvPr>
-            <p:ph type="title"/>
+            <p:ph type="body" idx="13" sz="quarter"/>
           </p:nvPr>
         </p:nvSpPr>
         <p:spPr/>
@@ -9746,19 +9519,19 @@
           <a:lstStyle/>
           <a:p>
             <a:r>
-              <a:t>The Digits Dataset — What You Will Work With</a:t>
-            </a:r>
-          </a:p>
-        </p:txBody>
-      </p:sp>
-      <p:sp>
-        <p:nvSpPr>
-          <p:cNvPr id="3" name="Content Placeholder 2"/>
+              <a:t>Features vs Labels</a:t>
+            </a:r>
+          </a:p>
+        </p:txBody>
+      </p:sp>
+      <p:sp>
+        <p:nvSpPr>
+          <p:cNvPr id="3" name="Text Placeholder 2"/>
           <p:cNvSpPr>
             <a:spLocks noGrp="1"/>
           </p:cNvSpPr>
           <p:nvPr>
-            <p:ph idx="1"/>
+            <p:ph type="body" idx="16" sz="quarter"/>
           </p:nvPr>
         </p:nvSpPr>
         <p:spPr/>
@@ -9766,51 +9539,8 @@
           <a:bodyPr/>
           <a:lstStyle/>
           <a:p>
-            <a:pPr/>
-            <a:r>
-              <a:t>UCI Optical Recognition of Handwritten Digits</a:t>
-            </a:r>
-          </a:p>
-          <a:p>
-            <a:pPr/>
-            <a:r>
-              <a:t>Ships inside scikit-learn — no download needed</a:t>
-            </a:r>
-          </a:p>
-          <a:p>
-            <a:pPr/>
-            <a:r>
-              <a:t>1,797 images of handwritten digits (0–9)</a:t>
-            </a:r>
-          </a:p>
-          <a:p>
-            <a:pPr/>
-            <a:r>
-              <a:t>Each image: 8×8 pixels, brightness values 0 (white) to 16 (full ink)</a:t>
-            </a:r>
-          </a:p>
-          <a:p>
-            <a:pPr/>
-            <a:r>
-              <a:t>Each image is flattened to 64 numbers → one row in the dataset</a:t>
-            </a:r>
-          </a:p>
-          <a:p>
-            <a:pPr/>
-            <a:r>
-              <a:t>64 features (pixel values) + 1 label (digit 0–9) per sample</a:t>
-            </a:r>
-          </a:p>
-          <a:p>
-            <a:pPr/>
-            <a:r>
-              <a:t>Balanced: ~180 samples per class — no imbalance problem here</a:t>
-            </a:r>
-          </a:p>
-          <a:p>
-            <a:pPr/>
-            <a:r>
-              <a:t>A classic benchmark — simple enough to learn on, complex enough to be real</a:t>
+            <a:r>
+              <a:t>07</a:t>
             </a:r>
           </a:p>
         </p:txBody>
@@ -9849,81 +9579,35 @@
           <a:lstStyle/>
           <a:p>
             <a:r>
-              <a:t>What the Model Actually Sees</a:t>
-            </a:r>
-          </a:p>
-        </p:txBody>
-      </p:sp>
-      <p:sp>
-        <p:nvSpPr>
-          <p:cNvPr id="3" name="Content Placeholder 2"/>
-          <p:cNvSpPr>
-            <a:spLocks noGrp="1"/>
-          </p:cNvSpPr>
-          <p:nvPr>
-            <p:ph idx="1"/>
-          </p:nvPr>
-        </p:nvSpPr>
-        <p:spPr/>
-        <p:txBody>
-          <a:bodyPr/>
-          <a:lstStyle/>
-          <a:p>
-            <a:pPr/>
-            <a:r>
-              <a:t>A human sees a shape — a "0", a "7", a "3"</a:t>
-            </a:r>
-          </a:p>
-          <a:p>
-            <a:pPr/>
-            <a:r>
-              <a:t>The model never sees an image</a:t>
-            </a:r>
-          </a:p>
-          <a:p>
-            <a:pPr/>
-            <a:r>
-              <a:t>It receives a flat row of 64 numbers:</a:t>
-            </a:r>
-          </a:p>
-          <a:p>
-            <a:pPr lvl="1"/>
-            <a:r>
-              <a:t>[0, 0, 5, 13, 9, 1, 0, 0, 0, 0, 13, 15, 10, 15, 5, 0, ...]</a:t>
-            </a:r>
-          </a:p>
-          <a:p>
-            <a:pPr/>
-            <a:r>
-              <a:t>This is the most important shift in ML thinking:</a:t>
-            </a:r>
-          </a:p>
-          <a:p>
-            <a:pPr lvl="1"/>
-            <a:r>
-              <a:t>Everything is numbers — images, text, logs, packets</a:t>
-            </a:r>
-          </a:p>
-          <a:p>
-            <a:pPr lvl="1"/>
-            <a:r>
-              <a:t>Raw data → extract numerical features → feed to model</a:t>
-            </a:r>
-          </a:p>
-          <a:p>
-            <a:pPr/>
-            <a:r>
-              <a:t>The same structure applies to every security use case:</a:t>
-            </a:r>
-          </a:p>
-          <a:p>
-            <a:pPr lvl="1"/>
-            <a:r>
-              <a:t>URL features, packet headers, log fields, file metadata</a:t>
-            </a:r>
-          </a:p>
-        </p:txBody>
-      </p:sp>
+              <a:t>The Same Structure — Only the Domain Changes</a:t>
+            </a:r>
+          </a:p>
+        </p:txBody>
+      </p:sp>
+      <p:pic>
+        <p:nvPicPr>
+          <p:cNvPr id="3" name="Picture 2" descr="features_labels.png"/>
+          <p:cNvPicPr>
+            <a:picLocks noChangeAspect="1"/>
+          </p:cNvPicPr>
+          <p:nvPr/>
+        </p:nvPicPr>
+        <p:blipFill>
+          <a:blip r:embed="rId2"/>
+          <a:stretch>
+            <a:fillRect/>
+          </a:stretch>
+        </p:blipFill>
+        <p:spPr>
+          <a:xfrm>
+            <a:off x="1097280" y="1371600"/>
+            <a:ext cx="10058400" cy="4564730"/>
+          </a:xfrm>
+          <a:prstGeom prst="rect">
+            <a:avLst/>
+          </a:prstGeom>
+        </p:spPr>
+      </p:pic>
     </p:spTree>
   </p:cSld>
   <p:clrMapOvr>
@@ -9944,12 +9628,12 @@
       <p:grpSpPr/>
       <p:sp>
         <p:nvSpPr>
-          <p:cNvPr id="2" name="Text Placeholder 1"/>
+          <p:cNvPr id="2" name="Title 1"/>
           <p:cNvSpPr>
             <a:spLocks noGrp="1"/>
           </p:cNvSpPr>
           <p:nvPr>
-            <p:ph type="body" idx="13" sz="quarter"/>
+            <p:ph type="title"/>
           </p:nvPr>
         </p:nvSpPr>
         <p:spPr/>
@@ -9958,19 +9642,19 @@
           <a:lstStyle/>
           <a:p>
             <a:r>
-              <a:t>Features vs Labels</a:t>
-            </a:r>
-          </a:p>
-        </p:txBody>
-      </p:sp>
-      <p:sp>
-        <p:nvSpPr>
-          <p:cNvPr id="3" name="Text Placeholder 2"/>
+              <a:t>The Pattern: Raw Data → Features → Model → Prediction</a:t>
+            </a:r>
+          </a:p>
+        </p:txBody>
+      </p:sp>
+      <p:sp>
+        <p:nvSpPr>
+          <p:cNvPr id="3" name="Content Placeholder 2"/>
           <p:cNvSpPr>
             <a:spLocks noGrp="1"/>
           </p:cNvSpPr>
           <p:nvPr>
-            <p:ph type="body" idx="16" sz="quarter"/>
+            <p:ph idx="1"/>
           </p:nvPr>
         </p:nvSpPr>
         <p:spPr/>
@@ -9978,8 +9662,48 @@
           <a:bodyPr/>
           <a:lstStyle/>
           <a:p>
-            <a:r>
-              <a:t>07</a:t>
+            <a:pPr/>
+            <a:r>
+              <a:t>1.  Start with raw data (logs, images, URLs, packets)</a:t>
+            </a:r>
+          </a:p>
+          <a:p>
+            <a:pPr/>
+            <a:r>
+              <a:t>2.  Extract features (X) — turn raw data into numbers</a:t>
+            </a:r>
+          </a:p>
+          <a:p>
+            <a:pPr/>
+            <a:r>
+              <a:t>3.  Identify labels (y) — what are you predicting?</a:t>
+            </a:r>
+          </a:p>
+          <a:p>
+            <a:pPr/>
+            <a:r>
+              <a:t>4.  model.fit(X, y) — the model finds the pattern</a:t>
+            </a:r>
+          </a:p>
+          <a:p>
+            <a:pPr/>
+            <a:r>
+              <a:t>5.  model.predict(X_new) — apply to new, unseen data</a:t>
+            </a:r>
+          </a:p>
+          <a:p>
+            <a:pPr/>
+          </a:p>
+          <a:p>
+            <a:pPr/>
+            <a:r>
+              <a:t>This 5-step pattern applies to every ML project</a:t>
+            </a:r>
+          </a:p>
+          <a:p>
+            <a:pPr/>
+            <a:r>
+              <a:t>Everything is numbers: images, text, logs, packets</a:t>
             </a:r>
           </a:p>
         </p:txBody>
@@ -10004,12 +9728,12 @@
       <p:grpSpPr/>
       <p:sp>
         <p:nvSpPr>
-          <p:cNvPr id="2" name="Title 1"/>
+          <p:cNvPr id="2" name="Text Placeholder 1"/>
           <p:cNvSpPr>
             <a:spLocks noGrp="1"/>
           </p:cNvSpPr>
           <p:nvPr>
-            <p:ph type="title"/>
+            <p:ph type="body" idx="13" sz="quarter"/>
           </p:nvPr>
         </p:nvSpPr>
         <p:spPr/>
@@ -10018,19 +9742,24 @@
           <a:lstStyle/>
           <a:p>
             <a:r>
-              <a:t>Features (X) and Labels (y) — The Fundamental Split</a:t>
-            </a:r>
-          </a:p>
-        </p:txBody>
-      </p:sp>
-      <p:sp>
-        <p:nvSpPr>
-          <p:cNvPr id="3" name="Content Placeholder 2"/>
+              <a:t>Vocabulary &amp;</a:t>
+            </a:r>
+          </a:p>
+          <a:p>
+            <a:r>
+              <a:t>Python Tools</a:t>
+            </a:r>
+          </a:p>
+        </p:txBody>
+      </p:sp>
+      <p:sp>
+        <p:nvSpPr>
+          <p:cNvPr id="3" name="Text Placeholder 2"/>
           <p:cNvSpPr>
             <a:spLocks noGrp="1"/>
           </p:cNvSpPr>
           <p:nvPr>
-            <p:ph idx="1"/>
+            <p:ph type="body" idx="16" sz="quarter"/>
           </p:nvPr>
         </p:nvSpPr>
         <p:spPr/>
@@ -10038,51 +9767,8 @@
           <a:bodyPr/>
           <a:lstStyle/>
           <a:p>
-            <a:pPr/>
-            <a:r>
-              <a:t>Every supervised ML problem has exactly two things:</a:t>
-            </a:r>
-          </a:p>
-          <a:p>
-            <a:pPr lvl="1"/>
-            <a:r>
-              <a:t>Features (X) — what you measure about each sample (the inputs)</a:t>
-            </a:r>
-          </a:p>
-          <a:p>
-            <a:pPr lvl="1"/>
-            <a:r>
-              <a:t>Labels (y) — the correct answer for each sample (what to predict)</a:t>
-            </a:r>
-          </a:p>
-          <a:p>
-            <a:pPr/>
-            <a:r>
-              <a:t>The structure is always the same — only the domain changes:</a:t>
-            </a:r>
-          </a:p>
-          <a:p>
-            <a:pPr lvl="1"/>
-            <a:r>
-              <a:t>Digit recognition:   64 pixel values  →  digit 0–9</a:t>
-            </a:r>
-          </a:p>
-          <a:p>
-            <a:pPr lvl="1"/>
-            <a:r>
-              <a:t>Phishing detection:  URL length, # dots, has @  →  phishing 0/1</a:t>
-            </a:r>
-          </a:p>
-          <a:p>
-            <a:pPr lvl="1"/>
-            <a:r>
-              <a:t>Network intrusion:   bytes sent, duration, SYN flags  →  malicious 0/1</a:t>
-            </a:r>
-          </a:p>
-          <a:p>
-            <a:pPr lvl="1"/>
-            <a:r>
-              <a:t>Malware classification:  file size, entropy, imports  →  family name</a:t>
+            <a:r>
+              <a:t>08</a:t>
             </a:r>
           </a:p>
         </p:txBody>
@@ -10121,69 +9807,35 @@
           <a:lstStyle/>
           <a:p>
             <a:r>
-              <a:t>The Pattern: Raw Data → Features → Model → Prediction</a:t>
-            </a:r>
-          </a:p>
-        </p:txBody>
-      </p:sp>
-      <p:sp>
-        <p:nvSpPr>
-          <p:cNvPr id="3" name="Content Placeholder 2"/>
-          <p:cNvSpPr>
-            <a:spLocks noGrp="1"/>
-          </p:cNvSpPr>
-          <p:nvPr>
-            <p:ph idx="1"/>
-          </p:nvPr>
-        </p:nvSpPr>
-        <p:spPr/>
-        <p:txBody>
-          <a:bodyPr/>
-          <a:lstStyle/>
-          <a:p>
-            <a:pPr/>
-            <a:r>
-              <a:t>Step 1: Start with raw data (logs, images, URLs, packets)</a:t>
-            </a:r>
-          </a:p>
-          <a:p>
-            <a:pPr/>
-            <a:r>
-              <a:t>Step 2: Extract features (X) — turn raw data into numbers</a:t>
-            </a:r>
-          </a:p>
-          <a:p>
-            <a:pPr/>
-            <a:r>
-              <a:t>Step 3: Identify labels (y) — what are you predicting?</a:t>
-            </a:r>
-          </a:p>
-          <a:p>
-            <a:pPr/>
-            <a:r>
-              <a:t>Step 4: model.fit(X, y) — the model finds the pattern</a:t>
-            </a:r>
-          </a:p>
-          <a:p>
-            <a:pPr/>
-            <a:r>
-              <a:t>Step 5: model.predict(X_new) — apply the pattern to new data</a:t>
-            </a:r>
-          </a:p>
-          <a:p>
-            <a:pPr/>
-            <a:r>
-              <a:t>This 5-step pattern applies to every ML project</a:t>
-            </a:r>
-          </a:p>
-          <a:p>
-            <a:pPr/>
-            <a:r>
-              <a:t>In the workshop, you will do all 5 on the digits dataset</a:t>
-            </a:r>
-          </a:p>
-        </p:txBody>
-      </p:sp>
+              <a:t>Python Libraries Used in Every Lesson</a:t>
+            </a:r>
+          </a:p>
+        </p:txBody>
+      </p:sp>
+      <p:pic>
+        <p:nvPicPr>
+          <p:cNvPr id="3" name="Picture 2" descr="python_tools.png"/>
+          <p:cNvPicPr>
+            <a:picLocks noChangeAspect="1"/>
+          </p:cNvPicPr>
+          <p:nvPr/>
+        </p:nvPicPr>
+        <p:blipFill>
+          <a:blip r:embed="rId2"/>
+          <a:stretch>
+            <a:fillRect/>
+          </a:stretch>
+        </p:blipFill>
+        <p:spPr>
+          <a:xfrm>
+            <a:off x="640080" y="1645920"/>
+            <a:ext cx="10972800" cy="3210651"/>
+          </a:xfrm>
+          <a:prstGeom prst="rect">
+            <a:avLst/>
+          </a:prstGeom>
+        </p:spPr>
+      </p:pic>
     </p:spTree>
   </p:cSld>
   <p:clrMapOvr>
@@ -10204,12 +9856,12 @@
       <p:grpSpPr/>
       <p:sp>
         <p:nvSpPr>
-          <p:cNvPr id="2" name="Text Placeholder 1"/>
+          <p:cNvPr id="2" name="Title 1"/>
           <p:cNvSpPr>
             <a:spLocks noGrp="1"/>
           </p:cNvSpPr>
           <p:nvPr>
-            <p:ph type="body" idx="13" sz="quarter"/>
+            <p:ph type="title"/>
           </p:nvPr>
         </p:nvSpPr>
         <p:spPr/>
@@ -10218,24 +9870,19 @@
           <a:lstStyle/>
           <a:p>
             <a:r>
-              <a:t>Vocabulary &amp;</a:t>
-            </a:r>
-          </a:p>
-          <a:p>
-            <a:r>
-              <a:t>Python Tools</a:t>
-            </a:r>
-          </a:p>
-        </p:txBody>
-      </p:sp>
-      <p:sp>
-        <p:nvSpPr>
-          <p:cNvPr id="3" name="Text Placeholder 2"/>
+              <a:t>Key Vocabulary</a:t>
+            </a:r>
+          </a:p>
+        </p:txBody>
+      </p:sp>
+      <p:sp>
+        <p:nvSpPr>
+          <p:cNvPr id="3" name="Content Placeholder 2"/>
           <p:cNvSpPr>
             <a:spLocks noGrp="1"/>
           </p:cNvSpPr>
           <p:nvPr>
-            <p:ph type="body" idx="16" sz="quarter"/>
+            <p:ph idx="1"/>
           </p:nvPr>
         </p:nvSpPr>
         <p:spPr/>
@@ -10243,8 +9890,63 @@
           <a:bodyPr/>
           <a:lstStyle/>
           <a:p>
-            <a:r>
-              <a:t>08</a:t>
+            <a:pPr/>
+            <a:r>
+              <a:t>Feature — one measurable input (URL length, bytes sent, pixel brightness)</a:t>
+            </a:r>
+          </a:p>
+          <a:p>
+            <a:pPr/>
+            <a:r>
+              <a:t>Label / Target — the answer the model predicts (phishing=1, legit=0)</a:t>
+            </a:r>
+          </a:p>
+          <a:p>
+            <a:pPr/>
+            <a:r>
+              <a:t>Sample — one row of data (one URL, one connection, one image)</a:t>
+            </a:r>
+          </a:p>
+          <a:p>
+            <a:pPr/>
+            <a:r>
+              <a:t>Training set — data the model learns from</a:t>
+            </a:r>
+          </a:p>
+          <a:p>
+            <a:pPr/>
+            <a:r>
+              <a:t>Test set — held-back data to evaluate honestly</a:t>
+            </a:r>
+          </a:p>
+          <a:p>
+            <a:pPr/>
+            <a:r>
+              <a:t>Weights — numbers inside the model, adjusted during training</a:t>
+            </a:r>
+          </a:p>
+          <a:p>
+            <a:pPr/>
+            <a:r>
+              <a:t>Loss — how wrong the predictions are (training minimises this)</a:t>
+            </a:r>
+          </a:p>
+          <a:p>
+            <a:pPr/>
+            <a:r>
+              <a:t>Epoch — one full pass through the training data</a:t>
+            </a:r>
+          </a:p>
+          <a:p>
+            <a:pPr/>
+            <a:r>
+              <a:t>Overfitting — memorised training data, fails on new data</a:t>
+            </a:r>
+          </a:p>
+          <a:p>
+            <a:pPr/>
+            <a:r>
+              <a:t>Class imbalance — one label far more common (99% benign, 1% attack)</a:t>
             </a:r>
           </a:p>
         </p:txBody>
@@ -10269,12 +9971,12 @@
       <p:grpSpPr/>
       <p:sp>
         <p:nvSpPr>
-          <p:cNvPr id="2" name="Title 1"/>
+          <p:cNvPr id="2" name="Text Placeholder 1"/>
           <p:cNvSpPr>
             <a:spLocks noGrp="1"/>
           </p:cNvSpPr>
           <p:nvPr>
-            <p:ph type="title"/>
+            <p:ph type="body" idx="13" sz="quarter"/>
           </p:nvPr>
         </p:nvSpPr>
         <p:spPr/>
@@ -10283,19 +9985,24 @@
           <a:lstStyle/>
           <a:p>
             <a:r>
-              <a:t>Key Vocabulary</a:t>
-            </a:r>
-          </a:p>
-        </p:txBody>
-      </p:sp>
-      <p:sp>
-        <p:nvSpPr>
-          <p:cNvPr id="3" name="Content Placeholder 2"/>
+              <a:t>Workshop</a:t>
+            </a:r>
+          </a:p>
+          <a:p>
+            <a:r>
+              <a:t>5 Hands-On Exercises</a:t>
+            </a:r>
+          </a:p>
+        </p:txBody>
+      </p:sp>
+      <p:sp>
+        <p:nvSpPr>
+          <p:cNvPr id="3" name="Text Placeholder 2"/>
           <p:cNvSpPr>
             <a:spLocks noGrp="1"/>
           </p:cNvSpPr>
           <p:nvPr>
-            <p:ph idx="1"/>
+            <p:ph type="body" idx="16" sz="quarter"/>
           </p:nvPr>
         </p:nvSpPr>
         <p:spPr/>
@@ -10303,51 +10010,8 @@
           <a:bodyPr/>
           <a:lstStyle/>
           <a:p>
-            <a:pPr/>
-            <a:r>
-              <a:t>Feature — one measurable input (URL length, bytes sent, pixel brightness)</a:t>
-            </a:r>
-          </a:p>
-          <a:p>
-            <a:pPr/>
-            <a:r>
-              <a:t>Label / Target — the answer the model predicts (phishing=1, legit=0)</a:t>
-            </a:r>
-          </a:p>
-          <a:p>
-            <a:pPr/>
-            <a:r>
-              <a:t>Sample — one row of data (one URL, one connection, one image)</a:t>
-            </a:r>
-          </a:p>
-          <a:p>
-            <a:pPr/>
-            <a:r>
-              <a:t>Training set — the data the model learns from</a:t>
-            </a:r>
-          </a:p>
-          <a:p>
-            <a:pPr/>
-            <a:r>
-              <a:t>Test set — held-back data to evaluate the model honestly</a:t>
-            </a:r>
-          </a:p>
-          <a:p>
-            <a:pPr/>
-            <a:r>
-              <a:t>Weights — the numbers inside the model, adjusted during training</a:t>
-            </a:r>
-          </a:p>
-          <a:p>
-            <a:pPr/>
-            <a:r>
-              <a:t>Loss — how wrong the predictions are; training minimises this</a:t>
-            </a:r>
-          </a:p>
-          <a:p>
-            <a:pPr/>
-            <a:r>
-              <a:t>Epoch — one full pass through the training data</a:t>
+            <a:r>
+              <a:t>09</a:t>
             </a:r>
           </a:p>
         </p:txBody>
@@ -10451,7 +10115,7 @@
           <a:lstStyle/>
           <a:p>
             <a:r>
-              <a:t>More Key Terms</a:t>
+              <a:t>Workshop — Full EDA on the Digits Dataset</a:t>
             </a:r>
           </a:p>
         </p:txBody>
@@ -10473,49 +10137,46 @@
           <a:p>
             <a:pPr/>
             <a:r>
-              <a:t>Model — the mathematical function learned from training data</a:t>
+              <a:t>Exercise 1: Load the dataset — Bunch, DataFrame, features vs labels</a:t>
             </a:r>
           </a:p>
           <a:p>
             <a:pPr/>
             <a:r>
-              <a:t>Overfitting — model memorised training data but fails on new data</a:t>
+              <a:t>Exercise 2: Shape and statistics — .describe(), missing values, zero-variance</a:t>
             </a:r>
           </a:p>
           <a:p>
             <a:pPr/>
             <a:r>
-              <a:t>Underfitting — model is too simple to capture the real pattern</a:t>
+              <a:t>Exercise 3: Class balance — the naive accuracy trap, imbalance ratio</a:t>
             </a:r>
           </a:p>
           <a:p>
             <a:pPr/>
             <a:r>
-              <a:t>Class imbalance — one label is far more common than others</a:t>
-            </a:r>
-          </a:p>
-          <a:p>
-            <a:pPr lvl="1"/>
-            <a:r>
-              <a:t>In security: 99% benign, 1% attack is typical</a:t>
+              <a:t>Exercise 4: Visualise — image grids, average prototypes per class</a:t>
             </a:r>
           </a:p>
           <a:p>
             <a:pPr/>
             <a:r>
-              <a:t>EDA — Exploratory Data Analysis — inspecting data before modelling</a:t>
+              <a:t>Exercise 5: What the model sees — number grids, correlations, security analogy</a:t>
             </a:r>
           </a:p>
           <a:p>
             <a:pPr/>
-            <a:r>
-              <a:t>Bunch — scikit-learn's container: .data (X), .target (y), .DESCR</a:t>
-            </a:r>
           </a:p>
           <a:p>
             <a:pPr/>
             <a:r>
-              <a:t>DataFrame — pandas table with named columns and easy filtering</a:t>
+              <a:t>Each exercise: lecture.md → handson.md → solution_*.py</a:t>
+            </a:r>
+          </a:p>
+          <a:p>
+            <a:pPr/>
+            <a:r>
+              <a:t>Run your script after each step — verify output before moving on</a:t>
             </a:r>
           </a:p>
         </p:txBody>
@@ -10540,7 +10201,71 @@
       <p:grpSpPr/>
       <p:sp>
         <p:nvSpPr>
-          <p:cNvPr id="2" name="Title 1"/>
+          <p:cNvPr id="2" name="Text Placeholder 1"/>
+          <p:cNvSpPr>
+            <a:spLocks noGrp="1"/>
+          </p:cNvSpPr>
+          <p:nvPr>
+            <p:ph type="body" idx="12" sz="quarter"/>
+          </p:nvPr>
+        </p:nvSpPr>
+        <p:spPr/>
+        <p:txBody>
+          <a:bodyPr/>
+          <a:lstStyle/>
+          <a:p>
+            <a:pPr/>
+            <a:r>
+              <a:t>ML finds patterns from labelled examples — no hand-crafted rules</a:t>
+            </a:r>
+          </a:p>
+          <a:p>
+            <a:pPr/>
+            <a:r>
+              <a:t>Supervised learning: features (X) → label (y) — most common in security</a:t>
+            </a:r>
+          </a:p>
+          <a:p>
+            <a:pPr/>
+            <a:r>
+              <a:t>Training = adjusting weights to minimise loss over many epochs</a:t>
+            </a:r>
+          </a:p>
+          <a:p>
+            <a:pPr/>
+            <a:r>
+              <a:t>Every ML project: data → EDA → split → train → evaluate → tune → deploy</a:t>
+            </a:r>
+          </a:p>
+          <a:p>
+            <a:pPr/>
+            <a:r>
+              <a:t>Never evaluate on training data — always use a held-out test set</a:t>
+            </a:r>
+          </a:p>
+          <a:p>
+            <a:pPr/>
+            <a:r>
+              <a:t>EDA catches silent failures: class imbalance, missing values, leakage</a:t>
+            </a:r>
+          </a:p>
+          <a:p>
+            <a:pPr/>
+            <a:r>
+              <a:t>Everything is numbers — images, text, logs all become feature rows</a:t>
+            </a:r>
+          </a:p>
+          <a:p>
+            <a:pPr/>
+            <a:r>
+              <a:t>Next: 5 exercises doing the full EDA yourself</a:t>
+            </a:r>
+          </a:p>
+        </p:txBody>
+      </p:sp>
+      <p:sp>
+        <p:nvSpPr>
+          <p:cNvPr id="3" name="Title 2"/>
           <p:cNvSpPr>
             <a:spLocks noGrp="1"/>
           </p:cNvSpPr>
@@ -10554,83 +10279,7 @@
           <a:lstStyle/>
           <a:p>
             <a:r>
-              <a:t>Python Libraries You Will Use in Every Lesson</a:t>
-            </a:r>
-          </a:p>
-        </p:txBody>
-      </p:sp>
-      <p:sp>
-        <p:nvSpPr>
-          <p:cNvPr id="3" name="Content Placeholder 2"/>
-          <p:cNvSpPr>
-            <a:spLocks noGrp="1"/>
-          </p:cNvSpPr>
-          <p:nvPr>
-            <p:ph idx="1"/>
-          </p:nvPr>
-        </p:nvSpPr>
-        <p:spPr/>
-        <p:txBody>
-          <a:bodyPr/>
-          <a:lstStyle/>
-          <a:p>
-            <a:pPr/>
-            <a:r>
-              <a:t>NumPy (import numpy as np)</a:t>
-            </a:r>
-          </a:p>
-          <a:p>
-            <a:pPr lvl="1"/>
-            <a:r>
-              <a:t>Fast numerical arrays — the foundation of all ML in Python</a:t>
-            </a:r>
-          </a:p>
-          <a:p>
-            <a:pPr lvl="1"/>
-            <a:r>
-              <a:t>ndarray: 1D = list of numbers, 2D = table, 3D = stack of tables</a:t>
-            </a:r>
-          </a:p>
-          <a:p>
-            <a:pPr/>
-            <a:r>
-              <a:t>pandas (import pandas as pd)</a:t>
-            </a:r>
-          </a:p>
-          <a:p>
-            <a:pPr lvl="1"/>
-            <a:r>
-              <a:t>DataFrames for tabular data — .head(), .describe(), .value_counts()</a:t>
-            </a:r>
-          </a:p>
-          <a:p>
-            <a:pPr lvl="1"/>
-            <a:r>
-              <a:t>Named columns, easy filtering, consistent interface with sklearn</a:t>
-            </a:r>
-          </a:p>
-          <a:p>
-            <a:pPr/>
-            <a:r>
-              <a:t>Matplotlib (import matplotlib.pyplot as plt)</a:t>
-            </a:r>
-          </a:p>
-          <a:p>
-            <a:pPr lvl="1"/>
-            <a:r>
-              <a:t>Plotting: scatter, line, bar, image grids, heatmaps</a:t>
-            </a:r>
-          </a:p>
-          <a:p>
-            <a:pPr/>
-            <a:r>
-              <a:t>scikit-learn (import sklearn)</a:t>
-            </a:r>
-          </a:p>
-          <a:p>
-            <a:pPr lvl="1"/>
-            <a:r>
-              <a:t>ML algorithms, built-in datasets, evaluation metrics, preprocessing</a:t>
+              <a:t>Summary</a:t>
             </a:r>
           </a:p>
         </p:txBody>
@@ -10669,386 +10318,6 @@
           <a:lstStyle/>
           <a:p>
             <a:r>
-              <a:t>Workshop</a:t>
-            </a:r>
-          </a:p>
-          <a:p>
-            <a:r>
-              <a:t>5 Hands-On Exercises</a:t>
-            </a:r>
-          </a:p>
-        </p:txBody>
-      </p:sp>
-      <p:sp>
-        <p:nvSpPr>
-          <p:cNvPr id="3" name="Text Placeholder 2"/>
-          <p:cNvSpPr>
-            <a:spLocks noGrp="1"/>
-          </p:cNvSpPr>
-          <p:nvPr>
-            <p:ph type="body" idx="16" sz="quarter"/>
-          </p:nvPr>
-        </p:nvSpPr>
-        <p:spPr/>
-        <p:txBody>
-          <a:bodyPr/>
-          <a:lstStyle/>
-          <a:p>
-            <a:r>
-              <a:t>09</a:t>
-            </a:r>
-          </a:p>
-        </p:txBody>
-      </p:sp>
-    </p:spTree>
-  </p:cSld>
-  <p:clrMapOvr>
-    <a:masterClrMapping/>
-  </p:clrMapOvr>
-</p:sld>
-</file>
-
-<file path=ppt/slides/slide33.xml><?xml version="1.0" encoding="utf-8"?>
-<p:sld xmlns:a="http://schemas.openxmlformats.org/drawingml/2006/main" xmlns:p="http://schemas.openxmlformats.org/presentationml/2006/main" xmlns:r="http://schemas.openxmlformats.org/officeDocument/2006/relationships">
-  <p:cSld>
-    <p:spTree>
-      <p:nvGrpSpPr>
-        <p:cNvPr id="1" name=""/>
-        <p:cNvGrpSpPr/>
-        <p:nvPr/>
-      </p:nvGrpSpPr>
-      <p:grpSpPr/>
-      <p:sp>
-        <p:nvSpPr>
-          <p:cNvPr id="2" name="Title 1"/>
-          <p:cNvSpPr>
-            <a:spLocks noGrp="1"/>
-          </p:cNvSpPr>
-          <p:nvPr>
-            <p:ph type="title"/>
-          </p:nvPr>
-        </p:nvSpPr>
-        <p:spPr/>
-        <p:txBody>
-          <a:bodyPr/>
-          <a:lstStyle/>
-          <a:p>
-            <a:r>
-              <a:t>Workshop — Full EDA on the Digits Dataset</a:t>
-            </a:r>
-          </a:p>
-        </p:txBody>
-      </p:sp>
-      <p:sp>
-        <p:nvSpPr>
-          <p:cNvPr id="3" name="Content Placeholder 2"/>
-          <p:cNvSpPr>
-            <a:spLocks noGrp="1"/>
-          </p:cNvSpPr>
-          <p:nvPr>
-            <p:ph idx="1"/>
-          </p:nvPr>
-        </p:nvSpPr>
-        <p:spPr/>
-        <p:txBody>
-          <a:bodyPr/>
-          <a:lstStyle/>
-          <a:p>
-            <a:pPr/>
-            <a:r>
-              <a:t>Before training any model, you must understand your data</a:t>
-            </a:r>
-          </a:p>
-          <a:p>
-            <a:pPr/>
-            <a:r>
-              <a:t>This workshop walks through the full EDA sequence</a:t>
-            </a:r>
-          </a:p>
-          <a:p>
-            <a:pPr/>
-            <a:r>
-              <a:t>The same sequence you will run at the start of every ML project</a:t>
-            </a:r>
-          </a:p>
-          <a:p>
-            <a:pPr/>
-            <a:r>
-              <a:t>Exercise 1: Load the dataset — Bunch, DataFrame, features vs labels</a:t>
-            </a:r>
-          </a:p>
-          <a:p>
-            <a:pPr/>
-            <a:r>
-              <a:t>Exercise 2: Shape and statistics — .describe(), missing values, zero-variance</a:t>
-            </a:r>
-          </a:p>
-          <a:p>
-            <a:pPr/>
-            <a:r>
-              <a:t>Exercise 3: Class balance — the naive accuracy trap, imbalance ratio</a:t>
-            </a:r>
-          </a:p>
-          <a:p>
-            <a:pPr/>
-            <a:r>
-              <a:t>Exercise 4: Visualise — image grids, average prototypes per class</a:t>
-            </a:r>
-          </a:p>
-          <a:p>
-            <a:pPr/>
-            <a:r>
-              <a:t>Exercise 5: What the model sees — number grids, correlations, security analogy</a:t>
-            </a:r>
-          </a:p>
-        </p:txBody>
-      </p:sp>
-    </p:spTree>
-  </p:cSld>
-  <p:clrMapOvr>
-    <a:masterClrMapping/>
-  </p:clrMapOvr>
-</p:sld>
-</file>
-
-<file path=ppt/slides/slide34.xml><?xml version="1.0" encoding="utf-8"?>
-<p:sld xmlns:a="http://schemas.openxmlformats.org/drawingml/2006/main" xmlns:p="http://schemas.openxmlformats.org/presentationml/2006/main" xmlns:r="http://schemas.openxmlformats.org/officeDocument/2006/relationships">
-  <p:cSld>
-    <p:spTree>
-      <p:nvGrpSpPr>
-        <p:cNvPr id="1" name=""/>
-        <p:cNvGrpSpPr/>
-        <p:nvPr/>
-      </p:nvGrpSpPr>
-      <p:grpSpPr/>
-      <p:sp>
-        <p:nvSpPr>
-          <p:cNvPr id="2" name="Title 1"/>
-          <p:cNvSpPr>
-            <a:spLocks noGrp="1"/>
-          </p:cNvSpPr>
-          <p:nvPr>
-            <p:ph type="title"/>
-          </p:nvPr>
-        </p:nvSpPr>
-        <p:spPr/>
-        <p:txBody>
-          <a:bodyPr/>
-          <a:lstStyle/>
-          <a:p>
-            <a:r>
-              <a:t>Workshop Structure</a:t>
-            </a:r>
-          </a:p>
-        </p:txBody>
-      </p:sp>
-      <p:sp>
-        <p:nvSpPr>
-          <p:cNvPr id="3" name="Content Placeholder 2"/>
-          <p:cNvSpPr>
-            <a:spLocks noGrp="1"/>
-          </p:cNvSpPr>
-          <p:nvPr>
-            <p:ph idx="1"/>
-          </p:nvPr>
-        </p:nvSpPr>
-        <p:spPr/>
-        <p:txBody>
-          <a:bodyPr/>
-          <a:lstStyle/>
-          <a:p>
-            <a:pPr/>
-            <a:r>
-              <a:t>Each exercise folder contains three files:</a:t>
-            </a:r>
-          </a:p>
-          <a:p>
-            <a:pPr lvl="1"/>
-            <a:r>
-              <a:t>lecture.md — concept explanation (read first)</a:t>
-            </a:r>
-          </a:p>
-          <a:p>
-            <a:pPr lvl="1"/>
-            <a:r>
-              <a:t>handson.md — step-by-step lab instructions</a:t>
-            </a:r>
-          </a:p>
-          <a:p>
-            <a:pPr lvl="1"/>
-            <a:r>
-              <a:t>solution_*.py — reference implementation (open last)</a:t>
-            </a:r>
-          </a:p>
-          <a:p>
-            <a:pPr/>
-            <a:r>
-              <a:t>Workflow for each exercise:</a:t>
-            </a:r>
-          </a:p>
-          <a:p>
-            <a:pPr lvl="1"/>
-            <a:r>
-              <a:t>1.  Read the lecture — understand the concept and methods</a:t>
-            </a:r>
-          </a:p>
-          <a:p>
-            <a:pPr lvl="1"/>
-            <a:r>
-              <a:t>2.  Follow the handson — build your script step by step</a:t>
-            </a:r>
-          </a:p>
-          <a:p>
-            <a:pPr lvl="1"/>
-            <a:r>
-              <a:t>3.  Run your script and verify output matches expected results</a:t>
-            </a:r>
-          </a:p>
-          <a:p>
-            <a:pPr lvl="1"/>
-            <a:r>
-              <a:t>4.  Compare against the solution when done</a:t>
-            </a:r>
-          </a:p>
-        </p:txBody>
-      </p:sp>
-    </p:spTree>
-  </p:cSld>
-  <p:clrMapOvr>
-    <a:masterClrMapping/>
-  </p:clrMapOvr>
-</p:sld>
-</file>
-
-<file path=ppt/slides/slide35.xml><?xml version="1.0" encoding="utf-8"?>
-<p:sld xmlns:a="http://schemas.openxmlformats.org/drawingml/2006/main" xmlns:p="http://schemas.openxmlformats.org/presentationml/2006/main" xmlns:r="http://schemas.openxmlformats.org/officeDocument/2006/relationships">
-  <p:cSld>
-    <p:spTree>
-      <p:nvGrpSpPr>
-        <p:cNvPr id="1" name=""/>
-        <p:cNvGrpSpPr/>
-        <p:nvPr/>
-      </p:nvGrpSpPr>
-      <p:grpSpPr/>
-      <p:sp>
-        <p:nvSpPr>
-          <p:cNvPr id="2" name="Text Placeholder 1"/>
-          <p:cNvSpPr>
-            <a:spLocks noGrp="1"/>
-          </p:cNvSpPr>
-          <p:nvPr>
-            <p:ph type="body" idx="12" sz="quarter"/>
-          </p:nvPr>
-        </p:nvSpPr>
-        <p:spPr/>
-        <p:txBody>
-          <a:bodyPr/>
-          <a:lstStyle/>
-          <a:p>
-            <a:pPr/>
-            <a:r>
-              <a:t>ML finds patterns from labelled examples — no hand-crafted rules</a:t>
-            </a:r>
-          </a:p>
-          <a:p>
-            <a:pPr/>
-            <a:r>
-              <a:t>Supervised learning: features (X) → label (y). Most common in security</a:t>
-            </a:r>
-          </a:p>
-          <a:p>
-            <a:pPr/>
-            <a:r>
-              <a:t>Training = adjusting weights to minimise loss over many epochs</a:t>
-            </a:r>
-          </a:p>
-          <a:p>
-            <a:pPr/>
-            <a:r>
-              <a:t>Every ML project: data → EDA → split → train → evaluate → tune → deploy</a:t>
-            </a:r>
-          </a:p>
-          <a:p>
-            <a:pPr/>
-            <a:r>
-              <a:t>Never evaluate on training data — always use a held-out test set</a:t>
-            </a:r>
-          </a:p>
-          <a:p>
-            <a:pPr/>
-            <a:r>
-              <a:t>EDA catches silent failures: class imbalance, missing values, leakage</a:t>
-            </a:r>
-          </a:p>
-          <a:p>
-            <a:pPr/>
-            <a:r>
-              <a:t>Everything is numbers — images, text, logs all become feature rows</a:t>
-            </a:r>
-          </a:p>
-          <a:p>
-            <a:pPr/>
-            <a:r>
-              <a:t>Next: 5 exercises to do the full EDA yourself on the digits dataset</a:t>
-            </a:r>
-          </a:p>
-        </p:txBody>
-      </p:sp>
-      <p:sp>
-        <p:nvSpPr>
-          <p:cNvPr id="3" name="Title 2"/>
-          <p:cNvSpPr>
-            <a:spLocks noGrp="1"/>
-          </p:cNvSpPr>
-          <p:nvPr>
-            <p:ph type="title"/>
-          </p:nvPr>
-        </p:nvSpPr>
-        <p:spPr/>
-        <p:txBody>
-          <a:bodyPr/>
-          <a:lstStyle/>
-          <a:p>
-            <a:r>
-              <a:t>Summary</a:t>
-            </a:r>
-          </a:p>
-        </p:txBody>
-      </p:sp>
-    </p:spTree>
-  </p:cSld>
-  <p:clrMapOvr>
-    <a:masterClrMapping/>
-  </p:clrMapOvr>
-</p:sld>
-</file>
-
-<file path=ppt/slides/slide36.xml><?xml version="1.0" encoding="utf-8"?>
-<p:sld xmlns:a="http://schemas.openxmlformats.org/drawingml/2006/main" xmlns:p="http://schemas.openxmlformats.org/presentationml/2006/main" xmlns:r="http://schemas.openxmlformats.org/officeDocument/2006/relationships">
-  <p:cSld>
-    <p:spTree>
-      <p:nvGrpSpPr>
-        <p:cNvPr id="1" name=""/>
-        <p:cNvGrpSpPr/>
-        <p:nvPr/>
-      </p:nvGrpSpPr>
-      <p:grpSpPr/>
-      <p:sp>
-        <p:nvSpPr>
-          <p:cNvPr id="2" name="Text Placeholder 1"/>
-          <p:cNvSpPr>
-            <a:spLocks noGrp="1"/>
-          </p:cNvSpPr>
-          <p:nvPr>
-            <p:ph type="body" idx="13" sz="quarter"/>
-          </p:nvPr>
-        </p:nvSpPr>
-        <p:spPr/>
-        <p:txBody>
-          <a:bodyPr/>
-          <a:lstStyle/>
-          <a:p>
-            <a:r>
               <a:t>Next → Lesson 1.2: Linear Regression</a:t>
             </a:r>
           </a:p>
@@ -11109,7 +10378,7 @@
           <a:lstStyle/>
           <a:p>
             <a:r>
-              <a:t>Traditional Programming — You Write the Rules</a:t>
+              <a:t>Two Approaches to Solving Problems</a:t>
             </a:r>
           </a:p>
         </p:txBody>
@@ -11121,7 +10390,7 @@
             <a:spLocks noGrp="1"/>
           </p:cNvSpPr>
           <p:nvPr>
-            <p:ph idx="1"/>
+            <p:ph idx="2" sz="half"/>
           </p:nvPr>
         </p:nvSpPr>
         <p:spPr/>
@@ -11131,55 +10400,125 @@
           <a:p>
             <a:pPr/>
             <a:r>
-              <a:t>You hand-craft explicit rules:</a:t>
+              <a:t>Traditional Programming</a:t>
+            </a:r>
+          </a:p>
+          <a:p>
+            <a:pPr/>
+          </a:p>
+          <a:p>
+            <a:pPr/>
+            <a:r>
+              <a:t>You write the rules:</a:t>
             </a:r>
           </a:p>
           <a:p>
             <a:pPr lvl="1"/>
             <a:r>
-              <a:t>if "free money" in email → mark as spam</a:t>
+              <a:t>if "free money" in email → spam</a:t>
             </a:r>
           </a:p>
           <a:p>
             <a:pPr lvl="1"/>
             <a:r>
-              <a:t>if sender not in contacts → mark as spam</a:t>
+              <a:t>if sender not in contacts → spam</a:t>
+            </a:r>
+          </a:p>
+          <a:p>
+            <a:pPr/>
+          </a:p>
+          <a:p>
+            <a:pPr/>
+            <a:r>
+              <a:t>Problem:</a:t>
             </a:r>
           </a:p>
           <a:p>
             <a:pPr lvl="1"/>
             <a:r>
-              <a:t>if subject contains "URGENT" → mark as spam</a:t>
-            </a:r>
-          </a:p>
+              <a:t>Attackers learn your rules</a:t>
+            </a:r>
+          </a:p>
+          <a:p>
+            <a:pPr lvl="1"/>
+            <a:r>
+              <a:t>Change one word → bypass the filter</a:t>
+            </a:r>
+          </a:p>
+          <a:p>
+            <a:pPr lvl="1"/>
+            <a:r>
+              <a:t>Rules don't scale</a:t>
+            </a:r>
+          </a:p>
+        </p:txBody>
+      </p:sp>
+      <p:sp>
+        <p:nvSpPr>
+          <p:cNvPr id="4" name="Content Placeholder 3"/>
+          <p:cNvSpPr>
+            <a:spLocks noGrp="1"/>
+          </p:cNvSpPr>
+          <p:nvPr>
+            <p:ph idx="12" sz="half"/>
+          </p:nvPr>
+        </p:nvSpPr>
+        <p:spPr/>
+        <p:txBody>
+          <a:bodyPr/>
+          <a:lstStyle/>
           <a:p>
             <a:pPr/>
             <a:r>
-              <a:t>The computer applies your rules to every email</a:t>
+              <a:t>Machine Learning</a:t>
             </a:r>
           </a:p>
           <a:p>
             <a:pPr/>
-            <a:r>
-              <a:t>The problem:</a:t>
+          </a:p>
+          <a:p>
+            <a:pPr/>
+            <a:r>
+              <a:t>You provide labelled examples:</a:t>
             </a:r>
           </a:p>
           <a:p>
             <a:pPr lvl="1"/>
             <a:r>
-              <a:t>Attackers learn your rules and work around them</a:t>
+              <a:t>10,000 emails tagged spam / legit</a:t>
             </a:r>
           </a:p>
           <a:p>
             <a:pPr lvl="1"/>
             <a:r>
-              <a:t>Change one word → bypass the filter</a:t>
+              <a:t>The model finds the patterns</a:t>
+            </a:r>
+          </a:p>
+          <a:p>
+            <a:pPr/>
+          </a:p>
+          <a:p>
+            <a:pPr/>
+            <a:r>
+              <a:t>Advantage:</a:t>
             </a:r>
           </a:p>
           <a:p>
             <a:pPr lvl="1"/>
             <a:r>
-              <a:t>Rules don't scale to millions of evolving patterns</a:t>
+              <a:t>Catches subtle signal combinations</a:t>
+            </a:r>
+          </a:p>
+          <a:p>
+            <a:pPr lvl="1"/>
+            <a:r>
+              <a:t>Adapts as new data arrives</a:t>
+            </a:r>
+          </a:p>
+          <a:p>
+            <a:pPr lvl="1"/>
+            <a:r>
+              <a:t>Scales to millions of patterns</a:t>
             </a:r>
           </a:p>
         </p:txBody>
@@ -11204,7 +10543,59 @@
       <p:grpSpPr/>
       <p:sp>
         <p:nvSpPr>
-          <p:cNvPr id="2" name="Title 1"/>
+          <p:cNvPr id="2" name="Text Placeholder 1"/>
+          <p:cNvSpPr>
+            <a:spLocks noGrp="1"/>
+          </p:cNvSpPr>
+          <p:nvPr>
+            <p:ph type="body" idx="14" sz="quarter"/>
+          </p:nvPr>
+        </p:nvSpPr>
+        <p:spPr/>
+        <p:txBody>
+          <a:bodyPr/>
+          <a:lstStyle/>
+          <a:p>
+            <a:r>
+              <a:t>— The core insight behind security ML</a:t>
+            </a:r>
+          </a:p>
+        </p:txBody>
+      </p:sp>
+      <p:sp>
+        <p:nvSpPr>
+          <p:cNvPr id="3" name="Text Placeholder 2"/>
+          <p:cNvSpPr>
+            <a:spLocks noGrp="1"/>
+          </p:cNvSpPr>
+          <p:nvPr>
+            <p:ph type="body" idx="15" sz="quarter"/>
+          </p:nvPr>
+        </p:nvSpPr>
+        <p:spPr/>
+        <p:txBody>
+          <a:bodyPr/>
+          <a:lstStyle/>
+          <a:p>
+            <a:r>
+              <a:t>Attackers constantly change tactics,</a:t>
+            </a:r>
+          </a:p>
+          <a:p>
+            <a:r>
+              <a:t>but their statistical patterns persist</a:t>
+            </a:r>
+          </a:p>
+          <a:p>
+            <a:r>
+              <a:t>across campaigns.</a:t>
+            </a:r>
+          </a:p>
+        </p:txBody>
+      </p:sp>
+      <p:sp>
+        <p:nvSpPr>
+          <p:cNvPr id="4" name="Title 3"/>
           <p:cNvSpPr>
             <a:spLocks noGrp="1"/>
           </p:cNvSpPr>
@@ -11218,19 +10609,19 @@
           <a:lstStyle/>
           <a:p>
             <a:r>
-              <a:t>Machine Learning — The Computer Finds the Rules</a:t>
-            </a:r>
-          </a:p>
-        </p:txBody>
-      </p:sp>
-      <p:sp>
-        <p:nvSpPr>
-          <p:cNvPr id="3" name="Content Placeholder 2"/>
+              <a:t>Why This Matters for Security</a:t>
+            </a:r>
+          </a:p>
+        </p:txBody>
+      </p:sp>
+      <p:sp>
+        <p:nvSpPr>
+          <p:cNvPr id="5" name="Text Placeholder 4"/>
           <p:cNvSpPr>
             <a:spLocks noGrp="1"/>
           </p:cNvSpPr>
           <p:nvPr>
-            <p:ph idx="1"/>
+            <p:ph type="body" idx="16" sz="quarter"/>
           </p:nvPr>
         </p:nvSpPr>
         <p:spPr/>
@@ -11240,55 +10631,31 @@
           <a:p>
             <a:pPr/>
             <a:r>
-              <a:t>You provide thousands of labelled examples:</a:t>
+              <a:t>Already in production security tooling:</a:t>
             </a:r>
           </a:p>
           <a:p>
             <a:pPr lvl="1"/>
             <a:r>
-              <a:t>10,000 emails, each tagged as spam or legitimate</a:t>
-            </a:r>
-          </a:p>
-          <a:p>
-            <a:pPr/>
-            <a:r>
-              <a:t>Each email described by measurable properties:</a:t>
+              <a:t>Email filters (Gmail: 99.9% spam blocked)</a:t>
             </a:r>
           </a:p>
           <a:p>
             <a:pPr lvl="1"/>
             <a:r>
-              <a:t>word_count=42, num_links=8, has_attachment=1, domain_age=3</a:t>
-            </a:r>
-          </a:p>
-          <a:p>
-            <a:pPr/>
-            <a:r>
-              <a:t>model.fit(emails, labels)  — the model finds patterns</a:t>
-            </a:r>
-          </a:p>
-          <a:p>
-            <a:pPr/>
-            <a:r>
-              <a:t>model.predict(new_email)   — applies those patterns to new data</a:t>
-            </a:r>
-          </a:p>
-          <a:p>
-            <a:pPr/>
-            <a:r>
-              <a:t>The patterns are combinations of dozens of subtle signals</a:t>
+              <a:t>Endpoint detection (behavioural analysis)</a:t>
             </a:r>
           </a:p>
           <a:p>
             <a:pPr lvl="1"/>
             <a:r>
-              <a:t>No human would think to write them as rules</a:t>
-            </a:r>
-          </a:p>
-          <a:p>
-            <a:pPr/>
-            <a:r>
-              <a:t>This is why ML outperforms hand-crafted rules on complex problems</a:t>
+              <a:t>SIEM (anomaly scoring across logs)</a:t>
+            </a:r>
+          </a:p>
+          <a:p>
+            <a:pPr lvl="1"/>
+            <a:r>
+              <a:t>Network IDS (traffic classification)</a:t>
             </a:r>
           </a:p>
         </p:txBody>
@@ -11313,12 +10680,12 @@
       <p:grpSpPr/>
       <p:sp>
         <p:nvSpPr>
-          <p:cNvPr id="2" name="Title 1"/>
+          <p:cNvPr id="2" name="Text Placeholder 1"/>
           <p:cNvSpPr>
             <a:spLocks noGrp="1"/>
           </p:cNvSpPr>
           <p:nvPr>
-            <p:ph type="title"/>
+            <p:ph type="body" idx="13" sz="quarter"/>
           </p:nvPr>
         </p:nvSpPr>
         <p:spPr/>
@@ -11327,19 +10694,24 @@
           <a:lstStyle/>
           <a:p>
             <a:r>
-              <a:t>Why This Matters for Security</a:t>
-            </a:r>
-          </a:p>
-        </p:txBody>
-      </p:sp>
-      <p:sp>
-        <p:nvSpPr>
-          <p:cNvPr id="3" name="Content Placeholder 2"/>
+              <a:t>The Three Types of</a:t>
+            </a:r>
+          </a:p>
+          <a:p>
+            <a:r>
+              <a:t>Machine Learning</a:t>
+            </a:r>
+          </a:p>
+        </p:txBody>
+      </p:sp>
+      <p:sp>
+        <p:nvSpPr>
+          <p:cNvPr id="3" name="Text Placeholder 2"/>
           <p:cNvSpPr>
             <a:spLocks noGrp="1"/>
           </p:cNvSpPr>
           <p:nvPr>
-            <p:ph idx="1"/>
+            <p:ph type="body" idx="16" sz="quarter"/>
           </p:nvPr>
         </p:nvSpPr>
         <p:spPr/>
@@ -11347,51 +10719,8 @@
           <a:bodyPr/>
           <a:lstStyle/>
           <a:p>
-            <a:pPr/>
-            <a:r>
-              <a:t>Attackers constantly change their tactics</a:t>
-            </a:r>
-          </a:p>
-          <a:p>
-            <a:pPr/>
-            <a:r>
-              <a:t>But their statistical patterns persist across campaigns</a:t>
-            </a:r>
-          </a:p>
-          <a:p>
-            <a:pPr/>
-            <a:r>
-              <a:t>ML detects those persistent patterns automatically</a:t>
-            </a:r>
-          </a:p>
-          <a:p>
-            <a:pPr/>
-            <a:r>
-              <a:t>Already deployed in production security tooling:</a:t>
-            </a:r>
-          </a:p>
-          <a:p>
-            <a:pPr lvl="1"/>
-            <a:r>
-              <a:t>Email filters — Gmail blocks 99.9% of spam with ML</a:t>
-            </a:r>
-          </a:p>
-          <a:p>
-            <a:pPr lvl="1"/>
-            <a:r>
-              <a:t>Endpoint detection — behavioural analysis of process activity</a:t>
-            </a:r>
-          </a:p>
-          <a:p>
-            <a:pPr lvl="1"/>
-            <a:r>
-              <a:t>SIEM correlation — anomaly scoring across log sources</a:t>
-            </a:r>
-          </a:p>
-          <a:p>
-            <a:pPr lvl="1"/>
-            <a:r>
-              <a:t>Network intrusion detection — traffic classification at wire speed</a:t>
+            <a:r>
+              <a:t>02</a:t>
             </a:r>
           </a:p>
         </p:txBody>
@@ -11416,12 +10745,12 @@
       <p:grpSpPr/>
       <p:sp>
         <p:nvSpPr>
-          <p:cNvPr id="2" name="Text Placeholder 1"/>
+          <p:cNvPr id="2" name="Title 1"/>
           <p:cNvSpPr>
             <a:spLocks noGrp="1"/>
           </p:cNvSpPr>
           <p:nvPr>
-            <p:ph type="body" idx="13" sz="quarter"/>
+            <p:ph type="title"/>
           </p:nvPr>
         </p:nvSpPr>
         <p:spPr/>
@@ -11430,37 +10759,35 @@
           <a:lstStyle/>
           <a:p>
             <a:r>
-              <a:t>The Three Types of</a:t>
-            </a:r>
-          </a:p>
-          <a:p>
-            <a:r>
-              <a:t>Machine Learning</a:t>
-            </a:r>
-          </a:p>
-        </p:txBody>
-      </p:sp>
-      <p:sp>
-        <p:nvSpPr>
-          <p:cNvPr id="3" name="Text Placeholder 2"/>
-          <p:cNvSpPr>
-            <a:spLocks noGrp="1"/>
-          </p:cNvSpPr>
-          <p:nvPr>
-            <p:ph type="body" idx="16" sz="quarter"/>
-          </p:nvPr>
-        </p:nvSpPr>
-        <p:spPr/>
-        <p:txBody>
-          <a:bodyPr/>
-          <a:lstStyle/>
-          <a:p>
-            <a:r>
-              <a:t>02</a:t>
-            </a:r>
-          </a:p>
-        </p:txBody>
-      </p:sp>
+              <a:t>Supervised, Unsupervised, and Reinforcement Learning</a:t>
+            </a:r>
+          </a:p>
+        </p:txBody>
+      </p:sp>
+      <p:pic>
+        <p:nvPicPr>
+          <p:cNvPr id="3" name="Picture 2" descr="three_types.png"/>
+          <p:cNvPicPr>
+            <a:picLocks noChangeAspect="1"/>
+          </p:cNvPicPr>
+          <p:nvPr/>
+        </p:nvPicPr>
+        <p:blipFill>
+          <a:blip r:embed="rId2"/>
+          <a:stretch>
+            <a:fillRect/>
+          </a:stretch>
+        </p:blipFill>
+        <p:spPr>
+          <a:xfrm>
+            <a:off x="640080" y="1463040"/>
+            <a:ext cx="10972800" cy="4057170"/>
+          </a:xfrm>
+          <a:prstGeom prst="rect">
+            <a:avLst/>
+          </a:prstGeom>
+        </p:spPr>
+      </p:pic>
     </p:spTree>
   </p:cSld>
   <p:clrMapOvr>
@@ -11481,12 +10808,12 @@
       <p:grpSpPr/>
       <p:sp>
         <p:nvSpPr>
-          <p:cNvPr id="2" name="Title 1"/>
+          <p:cNvPr id="2" name="Text Placeholder 1"/>
           <p:cNvSpPr>
             <a:spLocks noGrp="1"/>
           </p:cNvSpPr>
           <p:nvPr>
-            <p:ph type="title"/>
+            <p:ph type="body" idx="13" sz="quarter"/>
           </p:nvPr>
         </p:nvSpPr>
         <p:spPr/>
@@ -11495,19 +10822,24 @@
           <a:lstStyle/>
           <a:p>
             <a:r>
-              <a:t>Supervised Learning — Labelled Examples</a:t>
-            </a:r>
-          </a:p>
-        </p:txBody>
-      </p:sp>
-      <p:sp>
-        <p:nvSpPr>
-          <p:cNvPr id="3" name="Content Placeholder 2"/>
+              <a:t>How a Model</a:t>
+            </a:r>
+          </a:p>
+          <a:p>
+            <a:r>
+              <a:t>Actually Learns</a:t>
+            </a:r>
+          </a:p>
+        </p:txBody>
+      </p:sp>
+      <p:sp>
+        <p:nvSpPr>
+          <p:cNvPr id="3" name="Text Placeholder 2"/>
           <p:cNvSpPr>
             <a:spLocks noGrp="1"/>
           </p:cNvSpPr>
           <p:nvPr>
-            <p:ph idx="1"/>
+            <p:ph type="body" idx="16" sz="quarter"/>
           </p:nvPr>
         </p:nvSpPr>
         <p:spPr/>
@@ -11515,57 +10847,8 @@
           <a:bodyPr/>
           <a:lstStyle/>
           <a:p>
-            <a:pPr/>
-            <a:r>
-              <a:t>Every sample has a correct answer (label) attached</a:t>
-            </a:r>
-          </a:p>
-          <a:p>
-            <a:pPr/>
-            <a:r>
-              <a:t>The model learns the mapping: input features → label</a:t>
-            </a:r>
-          </a:p>
-          <a:p>
-            <a:pPr/>
-            <a:r>
-              <a:t>Input:  [url_length=92, num_dots=5, has_at=1]  →  phishing</a:t>
-            </a:r>
-          </a:p>
-          <a:p>
-            <a:pPr/>
-            <a:r>
-              <a:t>Input:  [url_length=14, num_dots=1, has_at=0]  →  legitimate</a:t>
-            </a:r>
-          </a:p>
-          <a:p>
-            <a:pPr/>
-            <a:r>
-              <a:t>The most widely used type in security:</a:t>
-            </a:r>
-          </a:p>
-          <a:p>
-            <a:pPr lvl="1"/>
-            <a:r>
-              <a:t>Phishing URL classifier</a:t>
-            </a:r>
-          </a:p>
-          <a:p>
-            <a:pPr lvl="1"/>
-            <a:r>
-              <a:t>Malware vs benign file classifier</a:t>
-            </a:r>
-          </a:p>
-          <a:p>
-            <a:pPr lvl="1"/>
-            <a:r>
-              <a:t>Network intrusion detector</a:t>
-            </a:r>
-          </a:p>
-          <a:p>
-            <a:pPr/>
-            <a:r>
-              <a:t>Focus of Stages 1 and 2 in this curriculum</a:t>
+            <a:r>
+              <a:t>03</a:t>
             </a:r>
           </a:p>
         </p:txBody>
@@ -11604,81 +10887,35 @@
           <a:lstStyle/>
           <a:p>
             <a:r>
-              <a:t>Unsupervised Learning — No Labels Needed</a:t>
-            </a:r>
-          </a:p>
-        </p:txBody>
-      </p:sp>
-      <p:sp>
-        <p:nvSpPr>
-          <p:cNvPr id="3" name="Content Placeholder 2"/>
-          <p:cNvSpPr>
-            <a:spLocks noGrp="1"/>
-          </p:cNvSpPr>
-          <p:nvPr>
-            <p:ph idx="1"/>
-          </p:nvPr>
-        </p:nvSpPr>
-        <p:spPr/>
-        <p:txBody>
-          <a:bodyPr/>
-          <a:lstStyle/>
-          <a:p>
-            <a:pPr/>
-            <a:r>
-              <a:t>No labels — the algorithm finds structure in the data on its own</a:t>
-            </a:r>
-          </a:p>
-          <a:p>
-            <a:pPr/>
-            <a:r>
-              <a:t>Input:  [bytes_sent, duration, unique_ports]   (no label)</a:t>
-            </a:r>
-          </a:p>
-          <a:p>
-            <a:pPr/>
-            <a:r>
-              <a:t>Output: "this connection looks different from all the others"</a:t>
-            </a:r>
-          </a:p>
-          <a:p>
-            <a:pPr/>
-            <a:r>
-              <a:t>You don't need to know what an attack looks like</a:t>
-            </a:r>
-          </a:p>
-          <a:p>
-            <a:pPr/>
-            <a:r>
-              <a:t>You just need to know when something deviates from normal</a:t>
-            </a:r>
-          </a:p>
-          <a:p>
-            <a:pPr/>
-            <a:r>
-              <a:t>Security applications:</a:t>
-            </a:r>
-          </a:p>
-          <a:p>
-            <a:pPr lvl="1"/>
-            <a:r>
-              <a:t>Anomaly detection in network traffic</a:t>
-            </a:r>
-          </a:p>
-          <a:p>
-            <a:pPr lvl="1"/>
-            <a:r>
-              <a:t>Clustering user behaviour to find insider threats</a:t>
-            </a:r>
-          </a:p>
-          <a:p>
-            <a:pPr/>
-            <a:r>
-              <a:t>Covered in Stage 2, Lesson 2.3</a:t>
-            </a:r>
-          </a:p>
-        </p:txBody>
-      </p:sp>
+              <a:t>The Training Loop</a:t>
+            </a:r>
+          </a:p>
+        </p:txBody>
+      </p:sp>
+      <p:pic>
+        <p:nvPicPr>
+          <p:cNvPr id="3" name="Picture 2" descr="learning_loop.png"/>
+          <p:cNvPicPr>
+            <a:picLocks noChangeAspect="1"/>
+          </p:cNvPicPr>
+          <p:nvPr/>
+        </p:nvPicPr>
+        <p:blipFill>
+          <a:blip r:embed="rId2"/>
+          <a:stretch>
+            <a:fillRect/>
+          </a:stretch>
+        </p:blipFill>
+        <p:spPr>
+          <a:xfrm>
+            <a:off x="2468880" y="1097280"/>
+            <a:ext cx="6858000" cy="7611438"/>
+          </a:xfrm>
+          <a:prstGeom prst="rect">
+            <a:avLst/>
+          </a:prstGeom>
+        </p:spPr>
+      </p:pic>
     </p:spTree>
   </p:cSld>
   <p:clrMapOvr>

</xml_diff>

<commit_message>
Rebuild Lecture 1 with cleaner structure and professional visuals
Reorganised from 9 fragmented sections (32 slides) to 6 focused
sections (28 slides) with a clear narrative arc. Improved image
quality with consistent colour palette, better layout variety,
and tighter content per slide.
</commit_message>
<xml_diff>
--- a/stage1_classic_ml/01_what_is_ml/Lecture-1-What-is-ML.pptx
+++ b/stage1_classic_ml/01_what_is_ml/Lecture-1-What-is-ML.pptx
@@ -39,10 +39,6 @@
     <p:sldId id="281" r:id="rId37"/>
     <p:sldId id="282" r:id="rId38"/>
     <p:sldId id="283" r:id="rId39"/>
-    <p:sldId id="284" r:id="rId40"/>
-    <p:sldId id="285" r:id="rId41"/>
-    <p:sldId id="286" r:id="rId42"/>
-    <p:sldId id="287" r:id="rId43"/>
   </p:sldIdLst>
   <p:sldSz cx="12188825" cy="6858000"/>
   <p:notesSz cx="7010400" cy="9296400"/>
@@ -8346,7 +8342,7 @@
           <a:lstStyle/>
           <a:p>
             <a:r>
-              <a:t>Lesson 1.1 — Stage 1: Classic Machine Learning</a:t>
+              <a:t>Lesson 1.1  |  Stage 1: Classic Machine Learning</a:t>
             </a:r>
           </a:p>
         </p:txBody>
@@ -8388,7 +8384,7 @@
           <a:lstStyle/>
           <a:p>
             <a:r>
-              <a:t>For Security Professionals</a:t>
+              <a:t>From Rules to Learning  -  A Security Perspective</a:t>
             </a:r>
           </a:p>
         </p:txBody>
@@ -8427,14 +8423,14 @@
           <a:lstStyle/>
           <a:p>
             <a:r>
-              <a:t>Watching the Loss Drop Over Training</a:t>
+              <a:t>The Training Loop</a:t>
             </a:r>
           </a:p>
         </p:txBody>
       </p:sp>
       <p:pic>
         <p:nvPicPr>
-          <p:cNvPr id="3" name="Picture 2" descr="loss_curve.png"/>
+          <p:cNvPr id="3" name="Picture 2" descr="training_loop.png"/>
           <p:cNvPicPr>
             <a:picLocks noChangeAspect="1"/>
           </p:cNvPicPr>
@@ -8448,8 +8444,8 @@
         </p:blipFill>
         <p:spPr>
           <a:xfrm>
-            <a:off x="1828800" y="1371600"/>
-            <a:ext cx="8229600" cy="4065447"/>
+            <a:off x="1371600" y="1097280"/>
+            <a:ext cx="9418320" cy="5096032"/>
           </a:xfrm>
           <a:prstGeom prst="rect">
             <a:avLst/>
@@ -8476,55 +8472,7 @@
       <p:grpSpPr/>
       <p:sp>
         <p:nvSpPr>
-          <p:cNvPr id="2" name="Text Placeholder 1"/>
-          <p:cNvSpPr>
-            <a:spLocks noGrp="1"/>
-          </p:cNvSpPr>
-          <p:nvPr>
-            <p:ph type="body" idx="14" sz="quarter"/>
-          </p:nvPr>
-        </p:nvSpPr>
-        <p:spPr/>
-        <p:txBody>
-          <a:bodyPr/>
-          <a:lstStyle/>
-          <a:p/>
-        </p:txBody>
-      </p:sp>
-      <p:sp>
-        <p:nvSpPr>
-          <p:cNvPr id="3" name="Text Placeholder 2"/>
-          <p:cNvSpPr>
-            <a:spLocks noGrp="1"/>
-          </p:cNvSpPr>
-          <p:nvPr>
-            <p:ph type="body" idx="15" sz="quarter"/>
-          </p:nvPr>
-        </p:nvSpPr>
-        <p:spPr/>
-        <p:txBody>
-          <a:bodyPr/>
-          <a:lstStyle/>
-          <a:p>
-            <a:r>
-              <a:t>The patterns are combinations of</a:t>
-            </a:r>
-          </a:p>
-          <a:p>
-            <a:r>
-              <a:t>dozens of subtle signals that</a:t>
-            </a:r>
-          </a:p>
-          <a:p>
-            <a:r>
-              <a:t>no human would write as rules.</a:t>
-            </a:r>
-          </a:p>
-        </p:txBody>
-      </p:sp>
-      <p:sp>
-        <p:nvSpPr>
-          <p:cNvPr id="4" name="Title 3"/>
+          <p:cNvPr id="2" name="Title 1"/>
           <p:cNvSpPr>
             <a:spLocks noGrp="1"/>
           </p:cNvSpPr>
@@ -8538,63 +8486,35 @@
           <a:lstStyle/>
           <a:p>
             <a:r>
-              <a:t>Weights and Loss — What the Model Learns</a:t>
-            </a:r>
-          </a:p>
-        </p:txBody>
-      </p:sp>
-      <p:sp>
-        <p:nvSpPr>
-          <p:cNvPr id="5" name="Text Placeholder 4"/>
-          <p:cNvSpPr>
-            <a:spLocks noGrp="1"/>
-          </p:cNvSpPr>
-          <p:nvPr>
-            <p:ph type="body" idx="16" sz="quarter"/>
-          </p:nvPr>
-        </p:nvSpPr>
-        <p:spPr/>
-        <p:txBody>
-          <a:bodyPr/>
-          <a:lstStyle/>
-          <a:p>
-            <a:pPr/>
-            <a:r>
-              <a:t>Weights — numbers inside the model</a:t>
-            </a:r>
-          </a:p>
-          <a:p>
-            <a:pPr lvl="1"/>
-            <a:r>
-              <a:t>Adjusted during training to minimise loss</a:t>
-            </a:r>
-          </a:p>
-          <a:p>
-            <a:pPr/>
-            <a:r>
-              <a:t>Loss — how wrong the predictions are</a:t>
-            </a:r>
-          </a:p>
-          <a:p>
-            <a:pPr lvl="1"/>
-            <a:r>
-              <a:t>Training = finding weights that minimise loss</a:t>
-            </a:r>
-          </a:p>
-          <a:p>
-            <a:pPr/>
-            <a:r>
-              <a:t>You don't write any of this</a:t>
-            </a:r>
-          </a:p>
-          <a:p>
-            <a:pPr lvl="1"/>
-            <a:r>
-              <a:t>The ML library handles it automatically</a:t>
-            </a:r>
-          </a:p>
-        </p:txBody>
-      </p:sp>
+              <a:t>Loss Decreases as the Model Learns</a:t>
+            </a:r>
+          </a:p>
+        </p:txBody>
+      </p:sp>
+      <p:pic>
+        <p:nvPicPr>
+          <p:cNvPr id="3" name="Picture 2" descr="loss_curve.png"/>
+          <p:cNvPicPr>
+            <a:picLocks noChangeAspect="1"/>
+          </p:cNvPicPr>
+          <p:nvPr/>
+        </p:nvPicPr>
+        <p:blipFill>
+          <a:blip r:embed="rId2"/>
+          <a:stretch>
+            <a:fillRect/>
+          </a:stretch>
+        </p:blipFill>
+        <p:spPr>
+          <a:xfrm>
+            <a:off x="1371600" y="1371600"/>
+            <a:ext cx="9418320" cy="4178212"/>
+          </a:xfrm>
+          <a:prstGeom prst="rect">
+            <a:avLst/>
+          </a:prstGeom>
+        </p:spPr>
+      </p:pic>
     </p:spTree>
   </p:cSld>
   <p:clrMapOvr>
@@ -8620,7 +8540,7 @@
             <a:spLocks noGrp="1"/>
           </p:cNvSpPr>
           <p:nvPr>
-            <p:ph type="body" idx="13" sz="quarter"/>
+            <p:ph type="body" idx="14" sz="quarter"/>
           </p:nvPr>
         </p:nvSpPr>
         <p:spPr/>
@@ -8629,7 +8549,7 @@
           <a:lstStyle/>
           <a:p>
             <a:r>
-              <a:t>The ML Workflow</a:t>
+              <a:t/>
             </a:r>
           </a:p>
         </p:txBody>
@@ -8637,6 +8557,67 @@
       <p:sp>
         <p:nvSpPr>
           <p:cNvPr id="3" name="Text Placeholder 2"/>
+          <p:cNvSpPr>
+            <a:spLocks noGrp="1"/>
+          </p:cNvSpPr>
+          <p:nvPr>
+            <p:ph type="body" idx="15" sz="quarter"/>
+          </p:nvPr>
+        </p:nvSpPr>
+        <p:spPr/>
+        <p:txBody>
+          <a:bodyPr/>
+          <a:lstStyle/>
+          <a:p>
+            <a:r>
+              <a:rPr sz="1400"/>
+              <a:t>The model finds patterns</a:t>
+            </a:r>
+          </a:p>
+          <a:p>
+            <a:r>
+              <a:rPr sz="1400"/>
+              <a:t>across dozens of subtle</a:t>
+            </a:r>
+          </a:p>
+          <a:p>
+            <a:r>
+              <a:rPr sz="1400"/>
+              <a:t>signals that no human</a:t>
+            </a:r>
+          </a:p>
+          <a:p>
+            <a:r>
+              <a:rPr sz="1400"/>
+              <a:t>would write as rules.</a:t>
+            </a:r>
+          </a:p>
+        </p:txBody>
+      </p:sp>
+      <p:sp>
+        <p:nvSpPr>
+          <p:cNvPr id="4" name="Title 3"/>
+          <p:cNvSpPr>
+            <a:spLocks noGrp="1"/>
+          </p:cNvSpPr>
+          <p:nvPr>
+            <p:ph type="title"/>
+          </p:nvPr>
+        </p:nvSpPr>
+        <p:spPr/>
+        <p:txBody>
+          <a:bodyPr/>
+          <a:lstStyle/>
+          <a:p>
+            <a:r>
+              <a:t>The Key Concepts</a:t>
+            </a:r>
+          </a:p>
+        </p:txBody>
+      </p:sp>
+      <p:sp>
+        <p:nvSpPr>
+          <p:cNvPr id="5" name="Text Placeholder 4"/>
           <p:cNvSpPr>
             <a:spLocks noGrp="1"/>
           </p:cNvSpPr>
@@ -8650,7 +8631,62 @@
           <a:lstStyle/>
           <a:p>
             <a:r>
-              <a:t>04</a:t>
+              <a:rPr sz="1400"/>
+              <a:t>Weights</a:t>
+            </a:r>
+          </a:p>
+          <a:p>
+            <a:r>
+              <a:rPr sz="1400"/>
+              <a:t>  Numbers inside the model</a:t>
+            </a:r>
+          </a:p>
+          <a:p>
+            <a:r>
+              <a:rPr sz="1400"/>
+              <a:t>  Adjusted each training step</a:t>
+            </a:r>
+          </a:p>
+          <a:p>
+            <a:r>
+              <a:rPr sz="1400"/>
+              <a:t/>
+            </a:r>
+          </a:p>
+          <a:p>
+            <a:r>
+              <a:rPr sz="1400"/>
+              <a:t>Loss</a:t>
+            </a:r>
+          </a:p>
+          <a:p>
+            <a:r>
+              <a:rPr sz="1400"/>
+              <a:t>  How wrong the predictions are</a:t>
+            </a:r>
+          </a:p>
+          <a:p>
+            <a:r>
+              <a:rPr sz="1400"/>
+              <a:t>  Training = minimise loss</a:t>
+            </a:r>
+          </a:p>
+          <a:p>
+            <a:r>
+              <a:rPr sz="1400"/>
+              <a:t/>
+            </a:r>
+          </a:p>
+          <a:p>
+            <a:r>
+              <a:rPr sz="1400"/>
+              <a:t>Epoch</a:t>
+            </a:r>
+          </a:p>
+          <a:p>
+            <a:r>
+              <a:rPr sz="1400"/>
+              <a:t>  One full pass through all data</a:t>
             </a:r>
           </a:p>
         </p:txBody>
@@ -8675,12 +8711,12 @@
       <p:grpSpPr/>
       <p:sp>
         <p:nvSpPr>
-          <p:cNvPr id="2" name="Title 1"/>
+          <p:cNvPr id="2" name="Text Placeholder 1"/>
           <p:cNvSpPr>
             <a:spLocks noGrp="1"/>
           </p:cNvSpPr>
           <p:nvPr>
-            <p:ph type="title"/>
+            <p:ph type="body" idx="13" sz="quarter"/>
           </p:nvPr>
         </p:nvSpPr>
         <p:spPr/>
@@ -8689,35 +8725,37 @@
           <a:lstStyle/>
           <a:p>
             <a:r>
-              <a:t>Every Project Follows This Loop</a:t>
-            </a:r>
-          </a:p>
-        </p:txBody>
-      </p:sp>
-      <p:pic>
-        <p:nvPicPr>
-          <p:cNvPr id="3" name="Picture 2" descr="ml_workflow.png"/>
-          <p:cNvPicPr>
-            <a:picLocks noChangeAspect="1"/>
-          </p:cNvPicPr>
-          <p:nvPr/>
-        </p:nvPicPr>
-        <p:blipFill>
-          <a:blip r:embed="rId2"/>
-          <a:stretch>
-            <a:fillRect/>
-          </a:stretch>
-        </p:blipFill>
-        <p:spPr>
-          <a:xfrm>
-            <a:off x="457200" y="1371600"/>
-            <a:ext cx="11247120" cy="4675273"/>
-          </a:xfrm>
-          <a:prstGeom prst="rect">
-            <a:avLst/>
-          </a:prstGeom>
-        </p:spPr>
-      </p:pic>
+              <a:t>The ML Workflow</a:t>
+            </a:r>
+          </a:p>
+          <a:p>
+            <a:r>
+              <a:t>and EDA</a:t>
+            </a:r>
+          </a:p>
+        </p:txBody>
+      </p:sp>
+      <p:sp>
+        <p:nvSpPr>
+          <p:cNvPr id="3" name="Text Placeholder 2"/>
+          <p:cNvSpPr>
+            <a:spLocks noGrp="1"/>
+          </p:cNvSpPr>
+          <p:nvPr>
+            <p:ph type="body" idx="16" sz="quarter"/>
+          </p:nvPr>
+        </p:nvSpPr>
+        <p:spPr/>
+        <p:txBody>
+          <a:bodyPr/>
+          <a:lstStyle/>
+          <a:p>
+            <a:r>
+              <a:t>04</a:t>
+            </a:r>
+          </a:p>
+        </p:txBody>
+      </p:sp>
     </p:spTree>
   </p:cSld>
   <p:clrMapOvr>
@@ -8752,14 +8790,14 @@
           <a:lstStyle/>
           <a:p>
             <a:r>
-              <a:t>The Train / Test Split</a:t>
+              <a:t>Every ML Project Follows This Pipeline</a:t>
             </a:r>
           </a:p>
         </p:txBody>
       </p:sp>
       <p:pic>
         <p:nvPicPr>
-          <p:cNvPr id="3" name="Picture 2" descr="train_test_split.png"/>
+          <p:cNvPr id="3" name="Picture 2" descr="workflow.png"/>
           <p:cNvPicPr>
             <a:picLocks noChangeAspect="1"/>
           </p:cNvPicPr>
@@ -8773,8 +8811,8 @@
         </p:blipFill>
         <p:spPr>
           <a:xfrm>
-            <a:off x="1371600" y="1188720"/>
-            <a:ext cx="9418320" cy="3310682"/>
+            <a:off x="182880" y="1463040"/>
+            <a:ext cx="11795760" cy="3966036"/>
           </a:xfrm>
           <a:prstGeom prst="rect">
             <a:avLst/>
@@ -8801,12 +8839,12 @@
       <p:grpSpPr/>
       <p:sp>
         <p:nvSpPr>
-          <p:cNvPr id="2" name="Text Placeholder 1"/>
+          <p:cNvPr id="2" name="Title 1"/>
           <p:cNvSpPr>
             <a:spLocks noGrp="1"/>
           </p:cNvSpPr>
           <p:nvPr>
-            <p:ph type="body" idx="13" sz="quarter"/>
+            <p:ph type="title"/>
           </p:nvPr>
         </p:nvSpPr>
         <p:spPr/>
@@ -8815,37 +8853,35 @@
           <a:lstStyle/>
           <a:p>
             <a:r>
-              <a:t>Exploratory Data</a:t>
-            </a:r>
-          </a:p>
-          <a:p>
-            <a:r>
-              <a:t>Analysis (EDA)</a:t>
-            </a:r>
-          </a:p>
-        </p:txBody>
-      </p:sp>
-      <p:sp>
-        <p:nvSpPr>
-          <p:cNvPr id="3" name="Text Placeholder 2"/>
-          <p:cNvSpPr>
-            <a:spLocks noGrp="1"/>
-          </p:cNvSpPr>
-          <p:nvPr>
-            <p:ph type="body" idx="16" sz="quarter"/>
-          </p:nvPr>
-        </p:nvSpPr>
-        <p:spPr/>
-        <p:txBody>
-          <a:bodyPr/>
-          <a:lstStyle/>
-          <a:p>
-            <a:r>
-              <a:t>05</a:t>
-            </a:r>
-          </a:p>
-        </p:txBody>
-      </p:sp>
+              <a:t>The Train / Test Split</a:t>
+            </a:r>
+          </a:p>
+        </p:txBody>
+      </p:sp>
+      <p:pic>
+        <p:nvPicPr>
+          <p:cNvPr id="3" name="Picture 2" descr="train_test.png"/>
+          <p:cNvPicPr>
+            <a:picLocks noChangeAspect="1"/>
+          </p:cNvPicPr>
+          <p:nvPr/>
+        </p:nvPicPr>
+        <p:blipFill>
+          <a:blip r:embed="rId2"/>
+          <a:stretch>
+            <a:fillRect/>
+          </a:stretch>
+        </p:blipFill>
+        <p:spPr>
+          <a:xfrm>
+            <a:off x="914400" y="1280160"/>
+            <a:ext cx="10332720" cy="3639030"/>
+          </a:xfrm>
+          <a:prstGeom prst="rect">
+            <a:avLst/>
+          </a:prstGeom>
+        </p:spPr>
+      </p:pic>
     </p:spTree>
   </p:cSld>
   <p:clrMapOvr>
@@ -8880,7 +8916,7 @@
           <a:lstStyle/>
           <a:p>
             <a:r>
-              <a:t>EDA — Examine Your Data Before Training Anything</a:t>
+              <a:t>EDA: Examine Data Before Training</a:t>
             </a:r>
           </a:p>
         </p:txBody>
@@ -8901,8 +8937,8 @@
         </p:blipFill>
         <p:spPr>
           <a:xfrm>
-            <a:off x="1371600" y="1188720"/>
-            <a:ext cx="9418320" cy="4705989"/>
+            <a:off x="914400" y="1188720"/>
+            <a:ext cx="10058400" cy="4007846"/>
           </a:xfrm>
           <a:prstGeom prst="rect">
             <a:avLst/>
@@ -8964,8 +9000,8 @@
         </p:blipFill>
         <p:spPr>
           <a:xfrm>
-            <a:off x="1097280" y="1371600"/>
-            <a:ext cx="10058400" cy="4045561"/>
+            <a:off x="640080" y="1371600"/>
+            <a:ext cx="10972800" cy="3745424"/>
           </a:xfrm>
           <a:prstGeom prst="rect">
             <a:avLst/>
@@ -8997,7 +9033,7 @@
             <a:spLocks noGrp="1"/>
           </p:cNvSpPr>
           <p:nvPr>
-            <p:ph type="body" idx="14" sz="quarter"/>
+            <p:ph type="body" idx="13" sz="quarter"/>
           </p:nvPr>
         </p:nvSpPr>
         <p:spPr/>
@@ -9006,7 +9042,12 @@
           <a:lstStyle/>
           <a:p>
             <a:r>
-              <a:t>— Lesson 1.5 covers the solution</a:t>
+              <a:t>Meet the Dataset:</a:t>
+            </a:r>
+          </a:p>
+          <a:p>
+            <a:r>
+              <a:t>Handwritten Digits</a:t>
             </a:r>
           </a:p>
         </p:txBody>
@@ -9014,59 +9055,6 @@
       <p:sp>
         <p:nvSpPr>
           <p:cNvPr id="3" name="Text Placeholder 2"/>
-          <p:cNvSpPr>
-            <a:spLocks noGrp="1"/>
-          </p:cNvSpPr>
-          <p:nvPr>
-            <p:ph type="body" idx="15" sz="quarter"/>
-          </p:nvPr>
-        </p:nvSpPr>
-        <p:spPr/>
-        <p:txBody>
-          <a:bodyPr/>
-          <a:lstStyle/>
-          <a:p>
-            <a:r>
-              <a:t>A model with 95% accuracy</a:t>
-            </a:r>
-          </a:p>
-          <a:p>
-            <a:r>
-              <a:t>can catch zero attacks.</a:t>
-            </a:r>
-          </a:p>
-          <a:p/>
-          <a:p>
-            <a:r>
-              <a:t>You need better metrics.</a:t>
-            </a:r>
-          </a:p>
-        </p:txBody>
-      </p:sp>
-      <p:sp>
-        <p:nvSpPr>
-          <p:cNvPr id="4" name="Title 3"/>
-          <p:cNvSpPr>
-            <a:spLocks noGrp="1"/>
-          </p:cNvSpPr>
-          <p:nvPr>
-            <p:ph type="title"/>
-          </p:nvPr>
-        </p:nvSpPr>
-        <p:spPr/>
-        <p:txBody>
-          <a:bodyPr/>
-          <a:lstStyle/>
-          <a:p>
-            <a:r>
-              <a:t>The Naive Accuracy Trap</a:t>
-            </a:r>
-          </a:p>
-        </p:txBody>
-      </p:sp>
-      <p:sp>
-        <p:nvSpPr>
-          <p:cNvPr id="5" name="Text Placeholder 4"/>
           <p:cNvSpPr>
             <a:spLocks noGrp="1"/>
           </p:cNvSpPr>
@@ -9079,45 +9067,8 @@
           <a:bodyPr/>
           <a:lstStyle/>
           <a:p>
-            <a:pPr/>
-            <a:r>
-              <a:t>10,000 connections, 100 are attacks (1%)</a:t>
-            </a:r>
-          </a:p>
-          <a:p>
-            <a:pPr/>
-            <a:r>
-              <a:t>A model that always predicts 'normal':</a:t>
-            </a:r>
-          </a:p>
-          <a:p>
-            <a:pPr lvl="1"/>
-            <a:r>
-              <a:t>Accuracy = 99%</a:t>
-            </a:r>
-          </a:p>
-          <a:p>
-            <a:pPr lvl="1"/>
-            <a:r>
-              <a:t>Attacks caught = 0</a:t>
-            </a:r>
-          </a:p>
-          <a:p>
-            <a:pPr/>
-            <a:r>
-              <a:t>This is everywhere in security:</a:t>
-            </a:r>
-          </a:p>
-          <a:p>
-            <a:pPr lvl="1"/>
-            <a:r>
-              <a:t>Network intrusion: 99% normal, 1% attack</a:t>
-            </a:r>
-          </a:p>
-          <a:p>
-            <a:pPr lvl="1"/>
-            <a:r>
-              <a:t>Fraud: 99.8% legitimate, 0.2% fraud</a:t>
+            <a:r>
+              <a:t>05</a:t>
             </a:r>
           </a:p>
         </p:txBody>
@@ -9142,12 +9093,12 @@
       <p:grpSpPr/>
       <p:sp>
         <p:nvSpPr>
-          <p:cNvPr id="2" name="Text Placeholder 1"/>
+          <p:cNvPr id="2" name="Title 1"/>
           <p:cNvSpPr>
             <a:spLocks noGrp="1"/>
           </p:cNvSpPr>
           <p:nvPr>
-            <p:ph type="body" idx="13" sz="quarter"/>
+            <p:ph type="title"/>
           </p:nvPr>
         </p:nvSpPr>
         <p:spPr/>
@@ -9156,37 +9107,35 @@
           <a:lstStyle/>
           <a:p>
             <a:r>
-              <a:t>The Dataset:</a:t>
-            </a:r>
-          </a:p>
-          <a:p>
-            <a:r>
-              <a:t>Handwritten Digits</a:t>
-            </a:r>
-          </a:p>
-        </p:txBody>
-      </p:sp>
-      <p:sp>
-        <p:nvSpPr>
-          <p:cNvPr id="3" name="Text Placeholder 2"/>
-          <p:cNvSpPr>
-            <a:spLocks noGrp="1"/>
-          </p:cNvSpPr>
-          <p:nvPr>
-            <p:ph type="body" idx="16" sz="quarter"/>
-          </p:nvPr>
-        </p:nvSpPr>
-        <p:spPr/>
-        <p:txBody>
-          <a:bodyPr/>
-          <a:lstStyle/>
-          <a:p>
-            <a:r>
-              <a:t>06</a:t>
-            </a:r>
-          </a:p>
-        </p:txBody>
-      </p:sp>
+              <a:t>1,797 Images  -  10 Classes  -  64 Features Each</a:t>
+            </a:r>
+          </a:p>
+        </p:txBody>
+      </p:sp>
+      <p:pic>
+        <p:nvPicPr>
+          <p:cNvPr id="3" name="Picture 2" descr="digit_samples.png"/>
+          <p:cNvPicPr>
+            <a:picLocks noChangeAspect="1"/>
+          </p:cNvPicPr>
+          <p:nvPr/>
+        </p:nvPicPr>
+        <p:blipFill>
+          <a:blip r:embed="rId2"/>
+          <a:stretch>
+            <a:fillRect/>
+          </a:stretch>
+        </p:blipFill>
+        <p:spPr>
+          <a:xfrm>
+            <a:off x="457200" y="1463040"/>
+            <a:ext cx="11247120" cy="2917908"/>
+          </a:xfrm>
+          <a:prstGeom prst="rect">
+            <a:avLst/>
+          </a:prstGeom>
+        </p:spPr>
+      </p:pic>
     </p:spTree>
   </p:cSld>
   <p:clrMapOvr>
@@ -9220,57 +9169,39 @@
           <a:bodyPr/>
           <a:lstStyle/>
           <a:p>
-            <a:pPr/>
-            <a:r>
+            <a:r>
+              <a:rPr sz="1600"/>
               <a:t>Traditional programming vs machine learning</a:t>
             </a:r>
           </a:p>
           <a:p>
-            <a:pPr/>
-            <a:r>
+            <a:r>
+              <a:rPr sz="1600"/>
               <a:t>The three types of ML</a:t>
             </a:r>
           </a:p>
           <a:p>
-            <a:pPr/>
-            <a:r>
-              <a:t>How a model actually learns — the training loop</a:t>
-            </a:r>
-          </a:p>
-          <a:p>
-            <a:pPr/>
-            <a:r>
-              <a:t>The ML workflow and train/test split</a:t>
-            </a:r>
-          </a:p>
-          <a:p>
-            <a:pPr/>
-            <a:r>
-              <a:t>Exploratory Data Analysis (EDA)</a:t>
-            </a:r>
-          </a:p>
-          <a:p>
-            <a:pPr/>
-            <a:r>
-              <a:t>The dataset: handwritten digits</a:t>
-            </a:r>
-          </a:p>
-          <a:p>
-            <a:pPr/>
-            <a:r>
-              <a:t>Features vs labels — the fundamental split</a:t>
-            </a:r>
-          </a:p>
-          <a:p>
-            <a:pPr/>
-            <a:r>
-              <a:t>Python tools and key vocabulary</a:t>
-            </a:r>
-          </a:p>
-          <a:p>
-            <a:pPr/>
-            <a:r>
-              <a:t>Workshop: 5 hands-on exercises</a:t>
+            <a:r>
+              <a:rPr sz="1600"/>
+              <a:t>How a model learns - the training loop</a:t>
+            </a:r>
+          </a:p>
+          <a:p>
+            <a:r>
+              <a:rPr sz="1600"/>
+              <a:t>The ML workflow and EDA</a:t>
+            </a:r>
+          </a:p>
+          <a:p>
+            <a:r>
+              <a:rPr sz="1600"/>
+              <a:t>Meet the dataset: handwritten digits</a:t>
+            </a:r>
+          </a:p>
+          <a:p>
+            <a:r>
+              <a:rPr sz="1600"/>
+              <a:t>Python tools and getting started</a:t>
             </a:r>
           </a:p>
         </p:txBody>
@@ -9291,7 +9222,7 @@
           <a:lstStyle/>
           <a:p>
             <a:r>
-              <a:t>Agenda</a:t>
+              <a:t>What We'll Cover</a:t>
             </a:r>
           </a:p>
         </p:txBody>
@@ -9330,14 +9261,14 @@
           <a:lstStyle/>
           <a:p>
             <a:r>
-              <a:t>1,797 Images — 10 Classes — 64 Pixel Features Each</a:t>
+              <a:t>What the Model Actually Sees</a:t>
             </a:r>
           </a:p>
         </p:txBody>
       </p:sp>
       <p:pic>
         <p:nvPicPr>
-          <p:cNvPr id="3" name="Picture 2" descr="digit_grid.png"/>
+          <p:cNvPr id="3" name="Picture 2" descr="what_model_sees.png"/>
           <p:cNvPicPr>
             <a:picLocks noChangeAspect="1"/>
           </p:cNvPicPr>
@@ -9351,8 +9282,8 @@
         </p:blipFill>
         <p:spPr>
           <a:xfrm>
-            <a:off x="1554480" y="1371600"/>
-            <a:ext cx="9144000" cy="4198070"/>
+            <a:off x="914400" y="1371600"/>
+            <a:ext cx="10058400" cy="4375436"/>
           </a:xfrm>
           <a:prstGeom prst="rect">
             <a:avLst/>
@@ -9393,14 +9324,14 @@
           <a:lstStyle/>
           <a:p>
             <a:r>
-              <a:t>What the Model Actually Sees — Numbers, Not Images</a:t>
+              <a:t>Average Image per Class: The Learned Prototypes</a:t>
             </a:r>
           </a:p>
         </p:txBody>
       </p:sp>
       <p:pic>
         <p:nvPicPr>
-          <p:cNvPr id="3" name="Picture 2" descr="what_model_sees.png"/>
+          <p:cNvPr id="3" name="Picture 2" descr="avg_digits.png"/>
           <p:cNvPicPr>
             <a:picLocks noChangeAspect="1"/>
           </p:cNvPicPr>
@@ -9414,8 +9345,8 @@
         </p:blipFill>
         <p:spPr>
           <a:xfrm>
-            <a:off x="1097280" y="1371600"/>
-            <a:ext cx="10058400" cy="3580421"/>
+            <a:off x="457200" y="1828800"/>
+            <a:ext cx="11247120" cy="1322330"/>
           </a:xfrm>
           <a:prstGeom prst="rect">
             <a:avLst/>
@@ -9456,14 +9387,14 @@
           <a:lstStyle/>
           <a:p>
             <a:r>
-              <a:t>Average Image per Class — The Prototypes the Model Learns</a:t>
+              <a:t>Features (X) and Labels (y): The Universal Structure</a:t>
             </a:r>
           </a:p>
         </p:txBody>
       </p:sp>
       <p:pic>
         <p:nvPicPr>
-          <p:cNvPr id="3" name="Picture 2" descr="avg_digits.png"/>
+          <p:cNvPr id="3" name="Picture 2" descr="features_labels.png"/>
           <p:cNvPicPr>
             <a:picLocks noChangeAspect="1"/>
           </p:cNvPicPr>
@@ -9477,8 +9408,8 @@
         </p:blipFill>
         <p:spPr>
           <a:xfrm>
-            <a:off x="1554480" y="1371600"/>
-            <a:ext cx="9144000" cy="4201467"/>
+            <a:off x="640080" y="1188720"/>
+            <a:ext cx="10972800" cy="4001845"/>
           </a:xfrm>
           <a:prstGeom prst="rect">
             <a:avLst/>
@@ -9519,7 +9450,12 @@
           <a:lstStyle/>
           <a:p>
             <a:r>
-              <a:t>Features vs Labels</a:t>
+              <a:t>Python Tools</a:t>
+            </a:r>
+          </a:p>
+          <a:p>
+            <a:r>
+              <a:t>and Getting Started</a:t>
             </a:r>
           </a:p>
         </p:txBody>
@@ -9540,7 +9476,7 @@
           <a:lstStyle/>
           <a:p>
             <a:r>
-              <a:t>07</a:t>
+              <a:t>06</a:t>
             </a:r>
           </a:p>
         </p:txBody>
@@ -9579,14 +9515,14 @@
           <a:lstStyle/>
           <a:p>
             <a:r>
-              <a:t>The Same Structure — Only the Domain Changes</a:t>
+              <a:t>Four Libraries You'll Use in Every Lesson</a:t>
             </a:r>
           </a:p>
         </p:txBody>
       </p:sp>
       <p:pic>
         <p:nvPicPr>
-          <p:cNvPr id="3" name="Picture 2" descr="features_labels.png"/>
+          <p:cNvPr id="3" name="Picture 2" descr="python_tools.png"/>
           <p:cNvPicPr>
             <a:picLocks noChangeAspect="1"/>
           </p:cNvPicPr>
@@ -9600,8 +9536,8 @@
         </p:blipFill>
         <p:spPr>
           <a:xfrm>
-            <a:off x="1097280" y="1371600"/>
-            <a:ext cx="10058400" cy="4564730"/>
+            <a:off x="640080" y="1645920"/>
+            <a:ext cx="10972800" cy="3072384"/>
           </a:xfrm>
           <a:prstGeom prst="rect">
             <a:avLst/>
@@ -9642,7 +9578,7 @@
           <a:lstStyle/>
           <a:p>
             <a:r>
-              <a:t>The Pattern: Raw Data → Features → Model → Prediction</a:t>
+              <a:t>Key Vocabulary</a:t>
             </a:r>
           </a:p>
         </p:txBody>
@@ -9654,7 +9590,7 @@
             <a:spLocks noGrp="1"/>
           </p:cNvSpPr>
           <p:nvPr>
-            <p:ph idx="1"/>
+            <p:ph idx="2" sz="half"/>
           </p:nvPr>
         </p:nvSpPr>
         <p:spPr/>
@@ -9662,48 +9598,91 @@
           <a:bodyPr/>
           <a:lstStyle/>
           <a:p>
-            <a:pPr/>
-            <a:r>
-              <a:t>1.  Start with raw data (logs, images, URLs, packets)</a:t>
-            </a:r>
-          </a:p>
-          <a:p>
-            <a:pPr/>
-            <a:r>
-              <a:t>2.  Extract features (X) — turn raw data into numbers</a:t>
-            </a:r>
-          </a:p>
-          <a:p>
-            <a:pPr/>
-            <a:r>
-              <a:t>3.  Identify labels (y) — what are you predicting?</a:t>
-            </a:r>
-          </a:p>
-          <a:p>
-            <a:pPr/>
-            <a:r>
-              <a:t>4.  model.fit(X, y) — the model finds the pattern</a:t>
-            </a:r>
-          </a:p>
-          <a:p>
-            <a:pPr/>
-            <a:r>
-              <a:t>5.  model.predict(X_new) — apply to new, unseen data</a:t>
-            </a:r>
-          </a:p>
-          <a:p>
-            <a:pPr/>
-          </a:p>
-          <a:p>
-            <a:pPr/>
-            <a:r>
-              <a:t>This 5-step pattern applies to every ML project</a:t>
-            </a:r>
-          </a:p>
-          <a:p>
-            <a:pPr/>
-            <a:r>
-              <a:t>Everything is numbers: images, text, logs, packets</a:t>
+            <a:r>
+              <a:rPr sz="1400"/>
+              <a:t>Feature - one measurable input</a:t>
+            </a:r>
+          </a:p>
+          <a:p>
+            <a:r>
+              <a:rPr sz="1400"/>
+              <a:t>Label - the answer to predict</a:t>
+            </a:r>
+          </a:p>
+          <a:p>
+            <a:r>
+              <a:rPr sz="1400"/>
+              <a:t>Sample - one row of data</a:t>
+            </a:r>
+          </a:p>
+          <a:p>
+            <a:r>
+              <a:rPr sz="1400"/>
+              <a:t>Training set - data for learning</a:t>
+            </a:r>
+          </a:p>
+          <a:p>
+            <a:r>
+              <a:rPr sz="1400"/>
+              <a:t>Test set - data for evaluation</a:t>
+            </a:r>
+          </a:p>
+          <a:p>
+            <a:r>
+              <a:rPr sz="1400"/>
+              <a:t>Model - the learned function</a:t>
+            </a:r>
+          </a:p>
+        </p:txBody>
+      </p:sp>
+      <p:sp>
+        <p:nvSpPr>
+          <p:cNvPr id="4" name="Content Placeholder 3"/>
+          <p:cNvSpPr>
+            <a:spLocks noGrp="1"/>
+          </p:cNvSpPr>
+          <p:nvPr>
+            <p:ph idx="12" sz="half"/>
+          </p:nvPr>
+        </p:nvSpPr>
+        <p:spPr/>
+        <p:txBody>
+          <a:bodyPr/>
+          <a:lstStyle/>
+          <a:p>
+            <a:r>
+              <a:rPr sz="1400"/>
+              <a:t>Weights - adjustable parameters</a:t>
+            </a:r>
+          </a:p>
+          <a:p>
+            <a:r>
+              <a:rPr sz="1400"/>
+              <a:t>Loss - prediction error</a:t>
+            </a:r>
+          </a:p>
+          <a:p>
+            <a:r>
+              <a:rPr sz="1400"/>
+              <a:t>Epoch - one pass through data</a:t>
+            </a:r>
+          </a:p>
+          <a:p>
+            <a:r>
+              <a:rPr sz="1400"/>
+              <a:t>Overfitting - memorised, not learned</a:t>
+            </a:r>
+          </a:p>
+          <a:p>
+            <a:r>
+              <a:rPr sz="1400"/>
+              <a:t>Underfitting - too simple</a:t>
+            </a:r>
+          </a:p>
+          <a:p>
+            <a:r>
+              <a:rPr sz="1400"/>
+              <a:t>Class imbalance - skewed labels</a:t>
             </a:r>
           </a:p>
         </p:txBody>
@@ -9728,12 +9707,12 @@
       <p:grpSpPr/>
       <p:sp>
         <p:nvSpPr>
-          <p:cNvPr id="2" name="Text Placeholder 1"/>
+          <p:cNvPr id="2" name="Title 1"/>
           <p:cNvSpPr>
             <a:spLocks noGrp="1"/>
           </p:cNvSpPr>
           <p:nvPr>
-            <p:ph type="body" idx="13" sz="quarter"/>
+            <p:ph type="title"/>
           </p:nvPr>
         </p:nvSpPr>
         <p:spPr/>
@@ -9742,24 +9721,19 @@
           <a:lstStyle/>
           <a:p>
             <a:r>
-              <a:t>Vocabulary &amp;</a:t>
-            </a:r>
-          </a:p>
-          <a:p>
-            <a:r>
-              <a:t>Python Tools</a:t>
-            </a:r>
-          </a:p>
-        </p:txBody>
-      </p:sp>
-      <p:sp>
-        <p:nvSpPr>
-          <p:cNvPr id="3" name="Text Placeholder 2"/>
+              <a:t>Workshop: 5 Hands-On Exercises</a:t>
+            </a:r>
+          </a:p>
+        </p:txBody>
+      </p:sp>
+      <p:sp>
+        <p:nvSpPr>
+          <p:cNvPr id="3" name="Content Placeholder 2"/>
           <p:cNvSpPr>
             <a:spLocks noGrp="1"/>
           </p:cNvSpPr>
           <p:nvPr>
-            <p:ph type="body" idx="16" sz="quarter"/>
+            <p:ph idx="1"/>
           </p:nvPr>
         </p:nvSpPr>
         <p:spPr/>
@@ -9768,7 +9742,50 @@
           <a:lstStyle/>
           <a:p>
             <a:r>
-              <a:t>08</a:t>
+              <a:rPr sz="1600"/>
+              <a:t>Exercise 1:  Load the digits dataset into a DataFrame</a:t>
+            </a:r>
+          </a:p>
+          <a:p>
+            <a:r>
+              <a:rPr sz="1600"/>
+              <a:t>Exercise 2:  Shape, statistics, and missing values</a:t>
+            </a:r>
+          </a:p>
+          <a:p>
+            <a:r>
+              <a:rPr sz="1600"/>
+              <a:t>Exercise 3:  Class balance and the accuracy trap</a:t>
+            </a:r>
+          </a:p>
+          <a:p>
+            <a:r>
+              <a:rPr sz="1600"/>
+              <a:t>Exercise 4:  Visualise samples and average prototypes</a:t>
+            </a:r>
+          </a:p>
+          <a:p>
+            <a:r>
+              <a:rPr sz="1600"/>
+              <a:t>Exercise 5:  What the model sees - numbers and correlations</a:t>
+            </a:r>
+          </a:p>
+          <a:p>
+            <a:r>
+              <a:rPr sz="1600"/>
+              <a:t/>
+            </a:r>
+          </a:p>
+          <a:p>
+            <a:r>
+              <a:rPr sz="1600"/>
+              <a:t>Each exercise: lecture.md (concept) + handson.md (build it yourself)</a:t>
+            </a:r>
+          </a:p>
+          <a:p>
+            <a:r>
+              <a:rPr sz="1600"/>
+              <a:t>Solution files provided to check your work</a:t>
             </a:r>
           </a:p>
         </p:txBody>
@@ -9793,7 +9810,59 @@
       <p:grpSpPr/>
       <p:sp>
         <p:nvSpPr>
-          <p:cNvPr id="2" name="Title 1"/>
+          <p:cNvPr id="2" name="Text Placeholder 1"/>
+          <p:cNvSpPr>
+            <a:spLocks noGrp="1"/>
+          </p:cNvSpPr>
+          <p:nvPr>
+            <p:ph type="body" idx="12" sz="quarter"/>
+          </p:nvPr>
+        </p:nvSpPr>
+        <p:spPr/>
+        <p:txBody>
+          <a:bodyPr/>
+          <a:lstStyle/>
+          <a:p>
+            <a:r>
+              <a:rPr sz="1500"/>
+              <a:t>ML finds patterns from examples - no hand-crafted rules</a:t>
+            </a:r>
+          </a:p>
+          <a:p>
+            <a:r>
+              <a:rPr sz="1500"/>
+              <a:t>Supervised learning (X -&gt; y) is most common in security</a:t>
+            </a:r>
+          </a:p>
+          <a:p>
+            <a:r>
+              <a:rPr sz="1500"/>
+              <a:t>Training = adjusting weights to minimise loss over epochs</a:t>
+            </a:r>
+          </a:p>
+          <a:p>
+            <a:r>
+              <a:rPr sz="1500"/>
+              <a:t>Always: data -&gt; EDA -&gt; split -&gt; train -&gt; evaluate -&gt; tune</a:t>
+            </a:r>
+          </a:p>
+          <a:p>
+            <a:r>
+              <a:rPr sz="1500"/>
+              <a:t>Never evaluate on training data - it measures memorisation</a:t>
+            </a:r>
+          </a:p>
+          <a:p>
+            <a:r>
+              <a:rPr sz="1500"/>
+              <a:t>Class imbalance is everywhere in security - accuracy misleads</a:t>
+            </a:r>
+          </a:p>
+        </p:txBody>
+      </p:sp>
+      <p:sp>
+        <p:nvSpPr>
+          <p:cNvPr id="3" name="Title 2"/>
           <p:cNvSpPr>
             <a:spLocks noGrp="1"/>
           </p:cNvSpPr>
@@ -9807,35 +9876,16 @@
           <a:lstStyle/>
           <a:p>
             <a:r>
-              <a:t>Python Libraries Used in Every Lesson</a:t>
-            </a:r>
-          </a:p>
-        </p:txBody>
-      </p:sp>
-      <p:pic>
-        <p:nvPicPr>
-          <p:cNvPr id="3" name="Picture 2" descr="python_tools.png"/>
-          <p:cNvPicPr>
-            <a:picLocks noChangeAspect="1"/>
-          </p:cNvPicPr>
-          <p:nvPr/>
-        </p:nvPicPr>
-        <p:blipFill>
-          <a:blip r:embed="rId2"/>
-          <a:stretch>
-            <a:fillRect/>
-          </a:stretch>
-        </p:blipFill>
-        <p:spPr>
-          <a:xfrm>
-            <a:off x="640080" y="1645920"/>
-            <a:ext cx="10972800" cy="3210651"/>
-          </a:xfrm>
-          <a:prstGeom prst="rect">
-            <a:avLst/>
-          </a:prstGeom>
-        </p:spPr>
-      </p:pic>
+              <a:t>Key</a:t>
+            </a:r>
+          </a:p>
+          <a:p>
+            <a:r>
+              <a:t>Takeaways</a:t>
+            </a:r>
+          </a:p>
+        </p:txBody>
+      </p:sp>
     </p:spTree>
   </p:cSld>
   <p:clrMapOvr>
@@ -9856,121 +9906,6 @@
       <p:grpSpPr/>
       <p:sp>
         <p:nvSpPr>
-          <p:cNvPr id="2" name="Title 1"/>
-          <p:cNvSpPr>
-            <a:spLocks noGrp="1"/>
-          </p:cNvSpPr>
-          <p:nvPr>
-            <p:ph type="title"/>
-          </p:nvPr>
-        </p:nvSpPr>
-        <p:spPr/>
-        <p:txBody>
-          <a:bodyPr/>
-          <a:lstStyle/>
-          <a:p>
-            <a:r>
-              <a:t>Key Vocabulary</a:t>
-            </a:r>
-          </a:p>
-        </p:txBody>
-      </p:sp>
-      <p:sp>
-        <p:nvSpPr>
-          <p:cNvPr id="3" name="Content Placeholder 2"/>
-          <p:cNvSpPr>
-            <a:spLocks noGrp="1"/>
-          </p:cNvSpPr>
-          <p:nvPr>
-            <p:ph idx="1"/>
-          </p:nvPr>
-        </p:nvSpPr>
-        <p:spPr/>
-        <p:txBody>
-          <a:bodyPr/>
-          <a:lstStyle/>
-          <a:p>
-            <a:pPr/>
-            <a:r>
-              <a:t>Feature — one measurable input (URL length, bytes sent, pixel brightness)</a:t>
-            </a:r>
-          </a:p>
-          <a:p>
-            <a:pPr/>
-            <a:r>
-              <a:t>Label / Target — the answer the model predicts (phishing=1, legit=0)</a:t>
-            </a:r>
-          </a:p>
-          <a:p>
-            <a:pPr/>
-            <a:r>
-              <a:t>Sample — one row of data (one URL, one connection, one image)</a:t>
-            </a:r>
-          </a:p>
-          <a:p>
-            <a:pPr/>
-            <a:r>
-              <a:t>Training set — data the model learns from</a:t>
-            </a:r>
-          </a:p>
-          <a:p>
-            <a:pPr/>
-            <a:r>
-              <a:t>Test set — held-back data to evaluate honestly</a:t>
-            </a:r>
-          </a:p>
-          <a:p>
-            <a:pPr/>
-            <a:r>
-              <a:t>Weights — numbers inside the model, adjusted during training</a:t>
-            </a:r>
-          </a:p>
-          <a:p>
-            <a:pPr/>
-            <a:r>
-              <a:t>Loss — how wrong the predictions are (training minimises this)</a:t>
-            </a:r>
-          </a:p>
-          <a:p>
-            <a:pPr/>
-            <a:r>
-              <a:t>Epoch — one full pass through the training data</a:t>
-            </a:r>
-          </a:p>
-          <a:p>
-            <a:pPr/>
-            <a:r>
-              <a:t>Overfitting — memorised training data, fails on new data</a:t>
-            </a:r>
-          </a:p>
-          <a:p>
-            <a:pPr/>
-            <a:r>
-              <a:t>Class imbalance — one label far more common (99% benign, 1% attack)</a:t>
-            </a:r>
-          </a:p>
-        </p:txBody>
-      </p:sp>
-    </p:spTree>
-  </p:cSld>
-  <p:clrMapOvr>
-    <a:masterClrMapping/>
-  </p:clrMapOvr>
-</p:sld>
-</file>
-
-<file path=ppt/slides/slide29.xml><?xml version="1.0" encoding="utf-8"?>
-<p:sld xmlns:a="http://schemas.openxmlformats.org/drawingml/2006/main" xmlns:p="http://schemas.openxmlformats.org/presentationml/2006/main" xmlns:r="http://schemas.openxmlformats.org/officeDocument/2006/relationships">
-  <p:cSld>
-    <p:spTree>
-      <p:nvGrpSpPr>
-        <p:cNvPr id="1" name=""/>
-        <p:cNvGrpSpPr/>
-        <p:nvPr/>
-      </p:nvGrpSpPr>
-      <p:grpSpPr/>
-      <p:sp>
-        <p:nvSpPr>
           <p:cNvPr id="2" name="Text Placeholder 1"/>
           <p:cNvSpPr>
             <a:spLocks noGrp="1"/>
@@ -9985,12 +9920,7 @@
           <a:lstStyle/>
           <a:p>
             <a:r>
-              <a:t>Workshop</a:t>
-            </a:r>
-          </a:p>
-          <a:p>
-            <a:r>
-              <a:t>5 Hands-On Exercises</a:t>
+              <a:t>Next:  Lesson 1.2 - Linear Regression</a:t>
             </a:r>
           </a:p>
         </p:txBody>
@@ -10002,7 +9932,7 @@
             <a:spLocks noGrp="1"/>
           </p:cNvSpPr>
           <p:nvPr>
-            <p:ph type="body" idx="16" sz="quarter"/>
+            <p:ph type="body" idx="14" sz="quarter"/>
           </p:nvPr>
         </p:nvSpPr>
         <p:spPr/>
@@ -10011,7 +9941,7 @@
           <a:lstStyle/>
           <a:p>
             <a:r>
-              <a:t>09</a:t>
+              <a:t>What is Machine Learning?</a:t>
             </a:r>
           </a:p>
         </p:txBody>
@@ -10089,269 +10019,6 @@
 </p:sld>
 </file>
 
-<file path=ppt/slides/slide30.xml><?xml version="1.0" encoding="utf-8"?>
-<p:sld xmlns:a="http://schemas.openxmlformats.org/drawingml/2006/main" xmlns:p="http://schemas.openxmlformats.org/presentationml/2006/main" xmlns:r="http://schemas.openxmlformats.org/officeDocument/2006/relationships">
-  <p:cSld>
-    <p:spTree>
-      <p:nvGrpSpPr>
-        <p:cNvPr id="1" name=""/>
-        <p:cNvGrpSpPr/>
-        <p:nvPr/>
-      </p:nvGrpSpPr>
-      <p:grpSpPr/>
-      <p:sp>
-        <p:nvSpPr>
-          <p:cNvPr id="2" name="Title 1"/>
-          <p:cNvSpPr>
-            <a:spLocks noGrp="1"/>
-          </p:cNvSpPr>
-          <p:nvPr>
-            <p:ph type="title"/>
-          </p:nvPr>
-        </p:nvSpPr>
-        <p:spPr/>
-        <p:txBody>
-          <a:bodyPr/>
-          <a:lstStyle/>
-          <a:p>
-            <a:r>
-              <a:t>Workshop — Full EDA on the Digits Dataset</a:t>
-            </a:r>
-          </a:p>
-        </p:txBody>
-      </p:sp>
-      <p:sp>
-        <p:nvSpPr>
-          <p:cNvPr id="3" name="Content Placeholder 2"/>
-          <p:cNvSpPr>
-            <a:spLocks noGrp="1"/>
-          </p:cNvSpPr>
-          <p:nvPr>
-            <p:ph idx="1"/>
-          </p:nvPr>
-        </p:nvSpPr>
-        <p:spPr/>
-        <p:txBody>
-          <a:bodyPr/>
-          <a:lstStyle/>
-          <a:p>
-            <a:pPr/>
-            <a:r>
-              <a:t>Exercise 1: Load the dataset — Bunch, DataFrame, features vs labels</a:t>
-            </a:r>
-          </a:p>
-          <a:p>
-            <a:pPr/>
-            <a:r>
-              <a:t>Exercise 2: Shape and statistics — .describe(), missing values, zero-variance</a:t>
-            </a:r>
-          </a:p>
-          <a:p>
-            <a:pPr/>
-            <a:r>
-              <a:t>Exercise 3: Class balance — the naive accuracy trap, imbalance ratio</a:t>
-            </a:r>
-          </a:p>
-          <a:p>
-            <a:pPr/>
-            <a:r>
-              <a:t>Exercise 4: Visualise — image grids, average prototypes per class</a:t>
-            </a:r>
-          </a:p>
-          <a:p>
-            <a:pPr/>
-            <a:r>
-              <a:t>Exercise 5: What the model sees — number grids, correlations, security analogy</a:t>
-            </a:r>
-          </a:p>
-          <a:p>
-            <a:pPr/>
-          </a:p>
-          <a:p>
-            <a:pPr/>
-            <a:r>
-              <a:t>Each exercise: lecture.md → handson.md → solution_*.py</a:t>
-            </a:r>
-          </a:p>
-          <a:p>
-            <a:pPr/>
-            <a:r>
-              <a:t>Run your script after each step — verify output before moving on</a:t>
-            </a:r>
-          </a:p>
-        </p:txBody>
-      </p:sp>
-    </p:spTree>
-  </p:cSld>
-  <p:clrMapOvr>
-    <a:masterClrMapping/>
-  </p:clrMapOvr>
-</p:sld>
-</file>
-
-<file path=ppt/slides/slide31.xml><?xml version="1.0" encoding="utf-8"?>
-<p:sld xmlns:a="http://schemas.openxmlformats.org/drawingml/2006/main" xmlns:p="http://schemas.openxmlformats.org/presentationml/2006/main" xmlns:r="http://schemas.openxmlformats.org/officeDocument/2006/relationships">
-  <p:cSld>
-    <p:spTree>
-      <p:nvGrpSpPr>
-        <p:cNvPr id="1" name=""/>
-        <p:cNvGrpSpPr/>
-        <p:nvPr/>
-      </p:nvGrpSpPr>
-      <p:grpSpPr/>
-      <p:sp>
-        <p:nvSpPr>
-          <p:cNvPr id="2" name="Text Placeholder 1"/>
-          <p:cNvSpPr>
-            <a:spLocks noGrp="1"/>
-          </p:cNvSpPr>
-          <p:nvPr>
-            <p:ph type="body" idx="12" sz="quarter"/>
-          </p:nvPr>
-        </p:nvSpPr>
-        <p:spPr/>
-        <p:txBody>
-          <a:bodyPr/>
-          <a:lstStyle/>
-          <a:p>
-            <a:pPr/>
-            <a:r>
-              <a:t>ML finds patterns from labelled examples — no hand-crafted rules</a:t>
-            </a:r>
-          </a:p>
-          <a:p>
-            <a:pPr/>
-            <a:r>
-              <a:t>Supervised learning: features (X) → label (y) — most common in security</a:t>
-            </a:r>
-          </a:p>
-          <a:p>
-            <a:pPr/>
-            <a:r>
-              <a:t>Training = adjusting weights to minimise loss over many epochs</a:t>
-            </a:r>
-          </a:p>
-          <a:p>
-            <a:pPr/>
-            <a:r>
-              <a:t>Every ML project: data → EDA → split → train → evaluate → tune → deploy</a:t>
-            </a:r>
-          </a:p>
-          <a:p>
-            <a:pPr/>
-            <a:r>
-              <a:t>Never evaluate on training data — always use a held-out test set</a:t>
-            </a:r>
-          </a:p>
-          <a:p>
-            <a:pPr/>
-            <a:r>
-              <a:t>EDA catches silent failures: class imbalance, missing values, leakage</a:t>
-            </a:r>
-          </a:p>
-          <a:p>
-            <a:pPr/>
-            <a:r>
-              <a:t>Everything is numbers — images, text, logs all become feature rows</a:t>
-            </a:r>
-          </a:p>
-          <a:p>
-            <a:pPr/>
-            <a:r>
-              <a:t>Next: 5 exercises doing the full EDA yourself</a:t>
-            </a:r>
-          </a:p>
-        </p:txBody>
-      </p:sp>
-      <p:sp>
-        <p:nvSpPr>
-          <p:cNvPr id="3" name="Title 2"/>
-          <p:cNvSpPr>
-            <a:spLocks noGrp="1"/>
-          </p:cNvSpPr>
-          <p:nvPr>
-            <p:ph type="title"/>
-          </p:nvPr>
-        </p:nvSpPr>
-        <p:spPr/>
-        <p:txBody>
-          <a:bodyPr/>
-          <a:lstStyle/>
-          <a:p>
-            <a:r>
-              <a:t>Summary</a:t>
-            </a:r>
-          </a:p>
-        </p:txBody>
-      </p:sp>
-    </p:spTree>
-  </p:cSld>
-  <p:clrMapOvr>
-    <a:masterClrMapping/>
-  </p:clrMapOvr>
-</p:sld>
-</file>
-
-<file path=ppt/slides/slide32.xml><?xml version="1.0" encoding="utf-8"?>
-<p:sld xmlns:a="http://schemas.openxmlformats.org/drawingml/2006/main" xmlns:p="http://schemas.openxmlformats.org/presentationml/2006/main" xmlns:r="http://schemas.openxmlformats.org/officeDocument/2006/relationships">
-  <p:cSld>
-    <p:spTree>
-      <p:nvGrpSpPr>
-        <p:cNvPr id="1" name=""/>
-        <p:cNvGrpSpPr/>
-        <p:nvPr/>
-      </p:nvGrpSpPr>
-      <p:grpSpPr/>
-      <p:sp>
-        <p:nvSpPr>
-          <p:cNvPr id="2" name="Text Placeholder 1"/>
-          <p:cNvSpPr>
-            <a:spLocks noGrp="1"/>
-          </p:cNvSpPr>
-          <p:nvPr>
-            <p:ph type="body" idx="13" sz="quarter"/>
-          </p:nvPr>
-        </p:nvSpPr>
-        <p:spPr/>
-        <p:txBody>
-          <a:bodyPr/>
-          <a:lstStyle/>
-          <a:p>
-            <a:r>
-              <a:t>Next → Lesson 1.2: Linear Regression</a:t>
-            </a:r>
-          </a:p>
-        </p:txBody>
-      </p:sp>
-      <p:sp>
-        <p:nvSpPr>
-          <p:cNvPr id="3" name="Text Placeholder 2"/>
-          <p:cNvSpPr>
-            <a:spLocks noGrp="1"/>
-          </p:cNvSpPr>
-          <p:nvPr>
-            <p:ph type="body" idx="14" sz="quarter"/>
-          </p:nvPr>
-        </p:nvSpPr>
-        <p:spPr/>
-        <p:txBody>
-          <a:bodyPr/>
-          <a:lstStyle/>
-          <a:p>
-            <a:r>
-              <a:t>What is Machine Learning?</a:t>
-            </a:r>
-          </a:p>
-        </p:txBody>
-      </p:sp>
-    </p:spTree>
-  </p:cSld>
-  <p:clrMapOvr>
-    <a:masterClrMapping/>
-  </p:clrMapOvr>
-</p:sld>
-</file>
-
 <file path=ppt/slides/slide4.xml><?xml version="1.0" encoding="utf-8"?>
 <p:sld xmlns:a="http://schemas.openxmlformats.org/drawingml/2006/main" xmlns:p="http://schemas.openxmlformats.org/presentationml/2006/main" xmlns:r="http://schemas.openxmlformats.org/officeDocument/2006/relationships">
   <p:cSld>
@@ -10378,7 +10045,7 @@
           <a:lstStyle/>
           <a:p>
             <a:r>
-              <a:t>Two Approaches to Solving Problems</a:t>
+              <a:t>Two Approaches to Problem Solving</a:t>
             </a:r>
           </a:p>
         </p:txBody>
@@ -10398,57 +10065,63 @@
           <a:bodyPr/>
           <a:lstStyle/>
           <a:p>
-            <a:pPr/>
-            <a:r>
+            <a:r>
+              <a:rPr sz="1400"/>
               <a:t>Traditional Programming</a:t>
             </a:r>
           </a:p>
           <a:p>
-            <a:pPr/>
-          </a:p>
-          <a:p>
-            <a:pPr/>
-            <a:r>
-              <a:t>You write the rules:</a:t>
-            </a:r>
-          </a:p>
-          <a:p>
-            <a:pPr lvl="1"/>
-            <a:r>
-              <a:t>if "free money" in email → spam</a:t>
-            </a:r>
-          </a:p>
-          <a:p>
-            <a:pPr lvl="1"/>
-            <a:r>
-              <a:t>if sender not in contacts → spam</a:t>
-            </a:r>
-          </a:p>
-          <a:p>
-            <a:pPr/>
-          </a:p>
-          <a:p>
-            <a:pPr/>
-            <a:r>
+            <a:r>
+              <a:rPr sz="1400"/>
+              <a:t/>
+            </a:r>
+          </a:p>
+          <a:p>
+            <a:r>
+              <a:rPr sz="1400"/>
+              <a:t>You write explicit rules:</a:t>
+            </a:r>
+          </a:p>
+          <a:p>
+            <a:r>
+              <a:rPr sz="1400"/>
+              <a:t>  if "free money" in email: spam</a:t>
+            </a:r>
+          </a:p>
+          <a:p>
+            <a:r>
+              <a:rPr sz="1400"/>
+              <a:t>  if sender unknown: spam</a:t>
+            </a:r>
+          </a:p>
+          <a:p>
+            <a:r>
+              <a:rPr sz="1400"/>
+              <a:t/>
+            </a:r>
+          </a:p>
+          <a:p>
+            <a:r>
+              <a:rPr sz="1400"/>
               <a:t>Problem:</a:t>
             </a:r>
           </a:p>
           <a:p>
-            <a:pPr lvl="1"/>
-            <a:r>
-              <a:t>Attackers learn your rules</a:t>
-            </a:r>
-          </a:p>
-          <a:p>
-            <a:pPr lvl="1"/>
-            <a:r>
-              <a:t>Change one word → bypass the filter</a:t>
-            </a:r>
-          </a:p>
-          <a:p>
-            <a:pPr lvl="1"/>
-            <a:r>
-              <a:t>Rules don't scale</a:t>
+            <a:r>
+              <a:rPr sz="1400"/>
+              <a:t>  Attackers learn your rules</a:t>
+            </a:r>
+          </a:p>
+          <a:p>
+            <a:r>
+              <a:rPr sz="1400"/>
+              <a:t>  Change one word, bypass the filter</a:t>
+            </a:r>
+          </a:p>
+          <a:p>
+            <a:r>
+              <a:rPr sz="1400"/>
+              <a:t>  Rules don't scale to millions of signals</a:t>
             </a:r>
           </a:p>
         </p:txBody>
@@ -10468,57 +10141,63 @@
           <a:bodyPr/>
           <a:lstStyle/>
           <a:p>
-            <a:pPr/>
-            <a:r>
+            <a:r>
+              <a:rPr sz="1400"/>
               <a:t>Machine Learning</a:t>
             </a:r>
           </a:p>
           <a:p>
-            <a:pPr/>
-          </a:p>
-          <a:p>
-            <a:pPr/>
-            <a:r>
+            <a:r>
+              <a:rPr sz="1400"/>
+              <a:t/>
+            </a:r>
+          </a:p>
+          <a:p>
+            <a:r>
+              <a:rPr sz="1400"/>
               <a:t>You provide labelled examples:</a:t>
             </a:r>
           </a:p>
           <a:p>
-            <a:pPr lvl="1"/>
-            <a:r>
-              <a:t>10,000 emails tagged spam / legit</a:t>
-            </a:r>
-          </a:p>
-          <a:p>
-            <a:pPr lvl="1"/>
-            <a:r>
-              <a:t>The model finds the patterns</a:t>
-            </a:r>
-          </a:p>
-          <a:p>
-            <a:pPr/>
-          </a:p>
-          <a:p>
-            <a:pPr/>
-            <a:r>
+            <a:r>
+              <a:rPr sz="1400"/>
+              <a:t>  10,000 emails tagged spam / legit</a:t>
+            </a:r>
+          </a:p>
+          <a:p>
+            <a:r>
+              <a:rPr sz="1400"/>
+              <a:t>  Model discovers the patterns itself</a:t>
+            </a:r>
+          </a:p>
+          <a:p>
+            <a:r>
+              <a:rPr sz="1400"/>
+              <a:t/>
+            </a:r>
+          </a:p>
+          <a:p>
+            <a:r>
+              <a:rPr sz="1400"/>
               <a:t>Advantage:</a:t>
             </a:r>
           </a:p>
           <a:p>
-            <a:pPr lvl="1"/>
-            <a:r>
-              <a:t>Catches subtle signal combinations</a:t>
-            </a:r>
-          </a:p>
-          <a:p>
-            <a:pPr lvl="1"/>
-            <a:r>
-              <a:t>Adapts as new data arrives</a:t>
-            </a:r>
-          </a:p>
-          <a:p>
-            <a:pPr lvl="1"/>
-            <a:r>
-              <a:t>Scales to millions of patterns</a:t>
+            <a:r>
+              <a:rPr sz="1400"/>
+              <a:t>  Catches subtle combinations</a:t>
+            </a:r>
+          </a:p>
+          <a:p>
+            <a:r>
+              <a:rPr sz="1400"/>
+              <a:t>  Adapts when new data arrives</a:t>
+            </a:r>
+          </a:p>
+          <a:p>
+            <a:r>
+              <a:rPr sz="1400"/>
+              <a:t>  Scales across entire organisations</a:t>
             </a:r>
           </a:p>
         </p:txBody>
@@ -10543,59 +10222,7 @@
       <p:grpSpPr/>
       <p:sp>
         <p:nvSpPr>
-          <p:cNvPr id="2" name="Text Placeholder 1"/>
-          <p:cNvSpPr>
-            <a:spLocks noGrp="1"/>
-          </p:cNvSpPr>
-          <p:nvPr>
-            <p:ph type="body" idx="14" sz="quarter"/>
-          </p:nvPr>
-        </p:nvSpPr>
-        <p:spPr/>
-        <p:txBody>
-          <a:bodyPr/>
-          <a:lstStyle/>
-          <a:p>
-            <a:r>
-              <a:t>— The core insight behind security ML</a:t>
-            </a:r>
-          </a:p>
-        </p:txBody>
-      </p:sp>
-      <p:sp>
-        <p:nvSpPr>
-          <p:cNvPr id="3" name="Text Placeholder 2"/>
-          <p:cNvSpPr>
-            <a:spLocks noGrp="1"/>
-          </p:cNvSpPr>
-          <p:nvPr>
-            <p:ph type="body" idx="15" sz="quarter"/>
-          </p:nvPr>
-        </p:nvSpPr>
-        <p:spPr/>
-        <p:txBody>
-          <a:bodyPr/>
-          <a:lstStyle/>
-          <a:p>
-            <a:r>
-              <a:t>Attackers constantly change tactics,</a:t>
-            </a:r>
-          </a:p>
-          <a:p>
-            <a:r>
-              <a:t>but their statistical patterns persist</a:t>
-            </a:r>
-          </a:p>
-          <a:p>
-            <a:r>
-              <a:t>across campaigns.</a:t>
-            </a:r>
-          </a:p>
-        </p:txBody>
-      </p:sp>
-      <p:sp>
-        <p:nvSpPr>
-          <p:cNvPr id="4" name="Title 3"/>
+          <p:cNvPr id="2" name="Title 1"/>
           <p:cNvSpPr>
             <a:spLocks noGrp="1"/>
           </p:cNvSpPr>
@@ -10609,57 +10236,35 @@
           <a:lstStyle/>
           <a:p>
             <a:r>
-              <a:t>Why This Matters for Security</a:t>
-            </a:r>
-          </a:p>
-        </p:txBody>
-      </p:sp>
-      <p:sp>
-        <p:nvSpPr>
-          <p:cNvPr id="5" name="Text Placeholder 4"/>
-          <p:cNvSpPr>
-            <a:spLocks noGrp="1"/>
-          </p:cNvSpPr>
-          <p:nvPr>
-            <p:ph type="body" idx="16" sz="quarter"/>
-          </p:nvPr>
-        </p:nvSpPr>
-        <p:spPr/>
-        <p:txBody>
-          <a:bodyPr/>
-          <a:lstStyle/>
-          <a:p>
-            <a:pPr/>
-            <a:r>
-              <a:t>Already in production security tooling:</a:t>
-            </a:r>
-          </a:p>
-          <a:p>
-            <a:pPr lvl="1"/>
-            <a:r>
-              <a:t>Email filters (Gmail: 99.9% spam blocked)</a:t>
-            </a:r>
-          </a:p>
-          <a:p>
-            <a:pPr lvl="1"/>
-            <a:r>
-              <a:t>Endpoint detection (behavioural analysis)</a:t>
-            </a:r>
-          </a:p>
-          <a:p>
-            <a:pPr lvl="1"/>
-            <a:r>
-              <a:t>SIEM (anomaly scoring across logs)</a:t>
-            </a:r>
-          </a:p>
-          <a:p>
-            <a:pPr lvl="1"/>
-            <a:r>
-              <a:t>Network IDS (traffic classification)</a:t>
-            </a:r>
-          </a:p>
-        </p:txBody>
-      </p:sp>
+              <a:t>The Fundamental Difference</a:t>
+            </a:r>
+          </a:p>
+        </p:txBody>
+      </p:sp>
+      <p:pic>
+        <p:nvPicPr>
+          <p:cNvPr id="3" name="Picture 2" descr="trad_vs_ml.png"/>
+          <p:cNvPicPr>
+            <a:picLocks noChangeAspect="1"/>
+          </p:cNvPicPr>
+          <p:nvPr/>
+        </p:nvPicPr>
+        <p:blipFill>
+          <a:blip r:embed="rId2"/>
+          <a:stretch>
+            <a:fillRect/>
+          </a:stretch>
+        </p:blipFill>
+        <p:spPr>
+          <a:xfrm>
+            <a:off x="640080" y="1371600"/>
+            <a:ext cx="10972800" cy="3728170"/>
+          </a:xfrm>
+          <a:prstGeom prst="rect">
+            <a:avLst/>
+          </a:prstGeom>
+        </p:spPr>
+      </p:pic>
     </p:spTree>
   </p:cSld>
   <p:clrMapOvr>
@@ -10685,7 +10290,7 @@
             <a:spLocks noGrp="1"/>
           </p:cNvSpPr>
           <p:nvPr>
-            <p:ph type="body" idx="13" sz="quarter"/>
+            <p:ph type="body" idx="14" sz="quarter"/>
           </p:nvPr>
         </p:nvSpPr>
         <p:spPr/>
@@ -10694,12 +10299,7 @@
           <a:lstStyle/>
           <a:p>
             <a:r>
-              <a:t>The Three Types of</a:t>
-            </a:r>
-          </a:p>
-          <a:p>
-            <a:r>
-              <a:t>Machine Learning</a:t>
+              <a:t/>
             </a:r>
           </a:p>
         </p:txBody>
@@ -10707,6 +10307,67 @@
       <p:sp>
         <p:nvSpPr>
           <p:cNvPr id="3" name="Text Placeholder 2"/>
+          <p:cNvSpPr>
+            <a:spLocks noGrp="1"/>
+          </p:cNvSpPr>
+          <p:nvPr>
+            <p:ph type="body" idx="15" sz="quarter"/>
+          </p:nvPr>
+        </p:nvSpPr>
+        <p:spPr/>
+        <p:txBody>
+          <a:bodyPr/>
+          <a:lstStyle/>
+          <a:p>
+            <a:r>
+              <a:rPr sz="1400"/>
+              <a:t>Attackers constantly change</a:t>
+            </a:r>
+          </a:p>
+          <a:p>
+            <a:r>
+              <a:rPr sz="1400"/>
+              <a:t>tactics, but their statistical</a:t>
+            </a:r>
+          </a:p>
+          <a:p>
+            <a:r>
+              <a:rPr sz="1400"/>
+              <a:t>patterns persist across</a:t>
+            </a:r>
+          </a:p>
+          <a:p>
+            <a:r>
+              <a:rPr sz="1400"/>
+              <a:t>campaigns.</a:t>
+            </a:r>
+          </a:p>
+        </p:txBody>
+      </p:sp>
+      <p:sp>
+        <p:nvSpPr>
+          <p:cNvPr id="4" name="Title 3"/>
+          <p:cNvSpPr>
+            <a:spLocks noGrp="1"/>
+          </p:cNvSpPr>
+          <p:nvPr>
+            <p:ph type="title"/>
+          </p:nvPr>
+        </p:nvSpPr>
+        <p:spPr/>
+        <p:txBody>
+          <a:bodyPr/>
+          <a:lstStyle/>
+          <a:p>
+            <a:r>
+              <a:t>Why This Matters for Security</a:t>
+            </a:r>
+          </a:p>
+        </p:txBody>
+      </p:sp>
+      <p:sp>
+        <p:nvSpPr>
+          <p:cNvPr id="5" name="Text Placeholder 4"/>
           <p:cNvSpPr>
             <a:spLocks noGrp="1"/>
           </p:cNvSpPr>
@@ -10720,7 +10381,50 @@
           <a:lstStyle/>
           <a:p>
             <a:r>
-              <a:t>02</a:t>
+              <a:rPr sz="1400"/>
+              <a:t>Already in production:</a:t>
+            </a:r>
+          </a:p>
+          <a:p>
+            <a:r>
+              <a:rPr sz="1400"/>
+              <a:t>  Email filters (99.9% spam blocked)</a:t>
+            </a:r>
+          </a:p>
+          <a:p>
+            <a:r>
+              <a:rPr sz="1400"/>
+              <a:t>  Endpoint detection (behavioural)</a:t>
+            </a:r>
+          </a:p>
+          <a:p>
+            <a:r>
+              <a:rPr sz="1400"/>
+              <a:t>  SIEM (anomaly scoring)</a:t>
+            </a:r>
+          </a:p>
+          <a:p>
+            <a:r>
+              <a:rPr sz="1400"/>
+              <a:t>  Network IDS (traffic classification)</a:t>
+            </a:r>
+          </a:p>
+          <a:p>
+            <a:r>
+              <a:rPr sz="1400"/>
+              <a:t/>
+            </a:r>
+          </a:p>
+          <a:p>
+            <a:r>
+              <a:rPr sz="1400"/>
+              <a:t>Traditional rules are reactive;</a:t>
+            </a:r>
+          </a:p>
+          <a:p>
+            <a:r>
+              <a:rPr sz="1400"/>
+              <a:t>ML models are predictive.</a:t>
             </a:r>
           </a:p>
         </p:txBody>
@@ -10745,12 +10449,12 @@
       <p:grpSpPr/>
       <p:sp>
         <p:nvSpPr>
-          <p:cNvPr id="2" name="Title 1"/>
+          <p:cNvPr id="2" name="Text Placeholder 1"/>
           <p:cNvSpPr>
             <a:spLocks noGrp="1"/>
           </p:cNvSpPr>
           <p:nvPr>
-            <p:ph type="title"/>
+            <p:ph type="body" idx="13" sz="quarter"/>
           </p:nvPr>
         </p:nvSpPr>
         <p:spPr/>
@@ -10759,35 +10463,37 @@
           <a:lstStyle/>
           <a:p>
             <a:r>
-              <a:t>Supervised, Unsupervised, and Reinforcement Learning</a:t>
-            </a:r>
-          </a:p>
-        </p:txBody>
-      </p:sp>
-      <p:pic>
-        <p:nvPicPr>
-          <p:cNvPr id="3" name="Picture 2" descr="three_types.png"/>
-          <p:cNvPicPr>
-            <a:picLocks noChangeAspect="1"/>
-          </p:cNvPicPr>
-          <p:nvPr/>
-        </p:nvPicPr>
-        <p:blipFill>
-          <a:blip r:embed="rId2"/>
-          <a:stretch>
-            <a:fillRect/>
-          </a:stretch>
-        </p:blipFill>
-        <p:spPr>
-          <a:xfrm>
-            <a:off x="640080" y="1463040"/>
-            <a:ext cx="10972800" cy="4057170"/>
-          </a:xfrm>
-          <a:prstGeom prst="rect">
-            <a:avLst/>
-          </a:prstGeom>
-        </p:spPr>
-      </p:pic>
+              <a:t>The Three Types of</a:t>
+            </a:r>
+          </a:p>
+          <a:p>
+            <a:r>
+              <a:t>Machine Learning</a:t>
+            </a:r>
+          </a:p>
+        </p:txBody>
+      </p:sp>
+      <p:sp>
+        <p:nvSpPr>
+          <p:cNvPr id="3" name="Text Placeholder 2"/>
+          <p:cNvSpPr>
+            <a:spLocks noGrp="1"/>
+          </p:cNvSpPr>
+          <p:nvPr>
+            <p:ph type="body" idx="16" sz="quarter"/>
+          </p:nvPr>
+        </p:nvSpPr>
+        <p:spPr/>
+        <p:txBody>
+          <a:bodyPr/>
+          <a:lstStyle/>
+          <a:p>
+            <a:r>
+              <a:t>02</a:t>
+            </a:r>
+          </a:p>
+        </p:txBody>
+      </p:sp>
     </p:spTree>
   </p:cSld>
   <p:clrMapOvr>
@@ -10808,12 +10514,12 @@
       <p:grpSpPr/>
       <p:sp>
         <p:nvSpPr>
-          <p:cNvPr id="2" name="Text Placeholder 1"/>
+          <p:cNvPr id="2" name="Title 1"/>
           <p:cNvSpPr>
             <a:spLocks noGrp="1"/>
           </p:cNvSpPr>
           <p:nvPr>
-            <p:ph type="body" idx="13" sz="quarter"/>
+            <p:ph type="title"/>
           </p:nvPr>
         </p:nvSpPr>
         <p:spPr/>
@@ -10822,37 +10528,35 @@
           <a:lstStyle/>
           <a:p>
             <a:r>
-              <a:t>How a Model</a:t>
-            </a:r>
-          </a:p>
-          <a:p>
-            <a:r>
-              <a:t>Actually Learns</a:t>
-            </a:r>
-          </a:p>
-        </p:txBody>
-      </p:sp>
-      <p:sp>
-        <p:nvSpPr>
-          <p:cNvPr id="3" name="Text Placeholder 2"/>
-          <p:cNvSpPr>
-            <a:spLocks noGrp="1"/>
-          </p:cNvSpPr>
-          <p:nvPr>
-            <p:ph type="body" idx="16" sz="quarter"/>
-          </p:nvPr>
-        </p:nvSpPr>
-        <p:spPr/>
-        <p:txBody>
-          <a:bodyPr/>
-          <a:lstStyle/>
-          <a:p>
-            <a:r>
-              <a:t>03</a:t>
-            </a:r>
-          </a:p>
-        </p:txBody>
-      </p:sp>
+              <a:t>Supervised, Unsupervised, and Reinforcement Learning</a:t>
+            </a:r>
+          </a:p>
+        </p:txBody>
+      </p:sp>
+      <p:pic>
+        <p:nvPicPr>
+          <p:cNvPr id="3" name="Picture 2" descr="three_types.png"/>
+          <p:cNvPicPr>
+            <a:picLocks noChangeAspect="1"/>
+          </p:cNvPicPr>
+          <p:nvPr/>
+        </p:nvPicPr>
+        <p:blipFill>
+          <a:blip r:embed="rId2"/>
+          <a:stretch>
+            <a:fillRect/>
+          </a:stretch>
+        </p:blipFill>
+        <p:spPr>
+          <a:xfrm>
+            <a:off x="457200" y="1371600"/>
+            <a:ext cx="11247120" cy="3610789"/>
+          </a:xfrm>
+          <a:prstGeom prst="rect">
+            <a:avLst/>
+          </a:prstGeom>
+        </p:spPr>
+      </p:pic>
     </p:spTree>
   </p:cSld>
   <p:clrMapOvr>
@@ -10873,12 +10577,12 @@
       <p:grpSpPr/>
       <p:sp>
         <p:nvSpPr>
-          <p:cNvPr id="2" name="Title 1"/>
+          <p:cNvPr id="2" name="Text Placeholder 1"/>
           <p:cNvSpPr>
             <a:spLocks noGrp="1"/>
           </p:cNvSpPr>
           <p:nvPr>
-            <p:ph type="title"/>
+            <p:ph type="body" idx="13" sz="quarter"/>
           </p:nvPr>
         </p:nvSpPr>
         <p:spPr/>
@@ -10887,35 +10591,37 @@
           <a:lstStyle/>
           <a:p>
             <a:r>
-              <a:t>The Training Loop</a:t>
-            </a:r>
-          </a:p>
-        </p:txBody>
-      </p:sp>
-      <p:pic>
-        <p:nvPicPr>
-          <p:cNvPr id="3" name="Picture 2" descr="learning_loop.png"/>
-          <p:cNvPicPr>
-            <a:picLocks noChangeAspect="1"/>
-          </p:cNvPicPr>
-          <p:nvPr/>
-        </p:nvPicPr>
-        <p:blipFill>
-          <a:blip r:embed="rId2"/>
-          <a:stretch>
-            <a:fillRect/>
-          </a:stretch>
-        </p:blipFill>
-        <p:spPr>
-          <a:xfrm>
-            <a:off x="2468880" y="1097280"/>
-            <a:ext cx="6858000" cy="7611438"/>
-          </a:xfrm>
-          <a:prstGeom prst="rect">
-            <a:avLst/>
-          </a:prstGeom>
-        </p:spPr>
-      </p:pic>
+              <a:t>How a Model</a:t>
+            </a:r>
+          </a:p>
+          <a:p>
+            <a:r>
+              <a:t>Actually Learns</a:t>
+            </a:r>
+          </a:p>
+        </p:txBody>
+      </p:sp>
+      <p:sp>
+        <p:nvSpPr>
+          <p:cNvPr id="3" name="Text Placeholder 2"/>
+          <p:cNvSpPr>
+            <a:spLocks noGrp="1"/>
+          </p:cNvSpPr>
+          <p:nvPr>
+            <p:ph type="body" idx="16" sz="quarter"/>
+          </p:nvPr>
+        </p:nvSpPr>
+        <p:spPr/>
+        <p:txBody>
+          <a:bodyPr/>
+          <a:lstStyle/>
+          <a:p>
+            <a:r>
+              <a:t>03</a:t>
+            </a:r>
+          </a:p>
+        </p:txBody>
+      </p:sp>
     </p:spTree>
   </p:cSld>
   <p:clrMapOvr>

</xml_diff>

<commit_message>
Apply Calibri font and bold headers to all 17 lectures; improve Lecture 1
- All lectures: switched every text run to Calibri, made slide titles bold
- Lecture 1: rebuilt with 29 slides (was 28), 14 images (was 13)
  - Added new Real-World Example slide (phishing URL detection pipeline)
  - Improved vocabulary slide with bold term/definition formatting
  - Better bullet hierarchy with colour-coded categories
  - All matplotlib charts regenerated with Calibri labels
</commit_message>
<xml_diff>
--- a/stage1_classic_ml/01_what_is_ml/Lecture-1-What-is-ML.pptx
+++ b/stage1_classic_ml/01_what_is_ml/Lecture-1-What-is-ML.pptx
@@ -39,6 +39,7 @@
     <p:sldId id="281" r:id="rId37"/>
     <p:sldId id="282" r:id="rId38"/>
     <p:sldId id="283" r:id="rId39"/>
+    <p:sldId id="284" r:id="rId40"/>
   </p:sldIdLst>
   <p:sldSz cx="12188825" cy="6858000"/>
   <p:notesSz cx="7010400" cy="9296400"/>
@@ -8321,6 +8322,9 @@
           <a:lstStyle/>
           <a:p>
             <a:r>
+              <a:rPr sz="1400" b="1">
+                <a:latin typeface="Calibri"/>
+              </a:rPr>
               <a:t>AI Basic Training</a:t>
             </a:r>
           </a:p>
@@ -8342,6 +8346,9 @@
           <a:lstStyle/>
           <a:p>
             <a:r>
+              <a:rPr sz="1800">
+                <a:latin typeface="Calibri"/>
+              </a:rPr>
               <a:t>Lesson 1.1  |  Stage 1: Classic Machine Learning</a:t>
             </a:r>
           </a:p>
@@ -8363,6 +8370,9 @@
           <a:lstStyle/>
           <a:p>
             <a:r>
+              <a:rPr sz="3600" b="1">
+                <a:latin typeface="Calibri"/>
+              </a:rPr>
               <a:t>What is Machine Learning?</a:t>
             </a:r>
           </a:p>
@@ -8384,7 +8394,10 @@
           <a:lstStyle/>
           <a:p>
             <a:r>
-              <a:t>From Rules to Learning  -  A Security Perspective</a:t>
+              <a:rPr sz="1200">
+                <a:latin typeface="Calibri"/>
+              </a:rPr>
+              <a:t>From Rules to Learning  —  A Security Perspective</a:t>
             </a:r>
           </a:p>
         </p:txBody>
@@ -8409,12 +8422,12 @@
       <p:grpSpPr/>
       <p:sp>
         <p:nvSpPr>
-          <p:cNvPr id="2" name="Title 1"/>
+          <p:cNvPr id="2" name="Text Placeholder 1"/>
           <p:cNvSpPr>
             <a:spLocks noGrp="1"/>
           </p:cNvSpPr>
           <p:nvPr>
-            <p:ph type="title"/>
+            <p:ph type="body" idx="13" sz="quarter"/>
           </p:nvPr>
         </p:nvSpPr>
         <p:spPr/>
@@ -8422,36 +8435,57 @@
           <a:bodyPr/>
           <a:lstStyle/>
           <a:p>
-            <a:r>
-              <a:t>The Training Loop</a:t>
+            <a:pPr>
+              <a:spcAft>
+                <a:spcPts val="400"/>
+              </a:spcAft>
+            </a:pPr>
+            <a:r>
+              <a:rPr sz="2800" b="1">
+                <a:latin typeface="Calibri"/>
+              </a:rPr>
+              <a:t>How a Model</a:t>
+            </a:r>
+          </a:p>
+          <a:p>
+            <a:pPr>
+              <a:spcAft>
+                <a:spcPts val="400"/>
+              </a:spcAft>
+            </a:pPr>
+            <a:r>
+              <a:rPr sz="2800" b="1">
+                <a:latin typeface="Calibri"/>
+              </a:rPr>
+              <a:t>Actually Learns</a:t>
             </a:r>
           </a:p>
         </p:txBody>
       </p:sp>
-      <p:pic>
-        <p:nvPicPr>
-          <p:cNvPr id="3" name="Picture 2" descr="training_loop.png"/>
-          <p:cNvPicPr>
-            <a:picLocks noChangeAspect="1"/>
-          </p:cNvPicPr>
-          <p:nvPr/>
-        </p:nvPicPr>
-        <p:blipFill>
-          <a:blip r:embed="rId2"/>
-          <a:stretch>
-            <a:fillRect/>
-          </a:stretch>
-        </p:blipFill>
-        <p:spPr>
-          <a:xfrm>
-            <a:off x="1371600" y="1097280"/>
-            <a:ext cx="9418320" cy="5096032"/>
-          </a:xfrm>
-          <a:prstGeom prst="rect">
-            <a:avLst/>
-          </a:prstGeom>
-        </p:spPr>
-      </p:pic>
+      <p:sp>
+        <p:nvSpPr>
+          <p:cNvPr id="3" name="Text Placeholder 2"/>
+          <p:cNvSpPr>
+            <a:spLocks noGrp="1"/>
+          </p:cNvSpPr>
+          <p:nvPr>
+            <p:ph type="body" idx="16" sz="quarter"/>
+          </p:nvPr>
+        </p:nvSpPr>
+        <p:spPr/>
+        <p:txBody>
+          <a:bodyPr/>
+          <a:lstStyle/>
+          <a:p>
+            <a:r>
+              <a:rPr sz="4800" b="1">
+                <a:latin typeface="Calibri"/>
+              </a:rPr>
+              <a:t>03</a:t>
+            </a:r>
+          </a:p>
+        </p:txBody>
+      </p:sp>
     </p:spTree>
   </p:cSld>
   <p:clrMapOvr>
@@ -8486,14 +8520,17 @@
           <a:lstStyle/>
           <a:p>
             <a:r>
-              <a:t>Loss Decreases as the Model Learns</a:t>
+              <a:rPr sz="2400" b="1">
+                <a:latin typeface="Calibri"/>
+              </a:rPr>
+              <a:t>The Training Loop</a:t>
             </a:r>
           </a:p>
         </p:txBody>
       </p:sp>
       <p:pic>
         <p:nvPicPr>
-          <p:cNvPr id="3" name="Picture 2" descr="loss_curve.png"/>
+          <p:cNvPr id="3" name="Picture 2" descr="training_loop.png"/>
           <p:cNvPicPr>
             <a:picLocks noChangeAspect="1"/>
           </p:cNvPicPr>
@@ -8507,8 +8544,8 @@
         </p:blipFill>
         <p:spPr>
           <a:xfrm>
-            <a:off x="1371600" y="1371600"/>
-            <a:ext cx="9418320" cy="4178212"/>
+            <a:off x="1097280" y="1097280"/>
+            <a:ext cx="9966960" cy="4880728"/>
           </a:xfrm>
           <a:prstGeom prst="rect">
             <a:avLst/>
@@ -8535,68 +8572,7 @@
       <p:grpSpPr/>
       <p:sp>
         <p:nvSpPr>
-          <p:cNvPr id="2" name="Text Placeholder 1"/>
-          <p:cNvSpPr>
-            <a:spLocks noGrp="1"/>
-          </p:cNvSpPr>
-          <p:nvPr>
-            <p:ph type="body" idx="14" sz="quarter"/>
-          </p:nvPr>
-        </p:nvSpPr>
-        <p:spPr/>
-        <p:txBody>
-          <a:bodyPr/>
-          <a:lstStyle/>
-          <a:p>
-            <a:r>
-              <a:t/>
-            </a:r>
-          </a:p>
-        </p:txBody>
-      </p:sp>
-      <p:sp>
-        <p:nvSpPr>
-          <p:cNvPr id="3" name="Text Placeholder 2"/>
-          <p:cNvSpPr>
-            <a:spLocks noGrp="1"/>
-          </p:cNvSpPr>
-          <p:nvPr>
-            <p:ph type="body" idx="15" sz="quarter"/>
-          </p:nvPr>
-        </p:nvSpPr>
-        <p:spPr/>
-        <p:txBody>
-          <a:bodyPr/>
-          <a:lstStyle/>
-          <a:p>
-            <a:r>
-              <a:rPr sz="1400"/>
-              <a:t>The model finds patterns</a:t>
-            </a:r>
-          </a:p>
-          <a:p>
-            <a:r>
-              <a:rPr sz="1400"/>
-              <a:t>across dozens of subtle</a:t>
-            </a:r>
-          </a:p>
-          <a:p>
-            <a:r>
-              <a:rPr sz="1400"/>
-              <a:t>signals that no human</a:t>
-            </a:r>
-          </a:p>
-          <a:p>
-            <a:r>
-              <a:rPr sz="1400"/>
-              <a:t>would write as rules.</a:t>
-            </a:r>
-          </a:p>
-        </p:txBody>
-      </p:sp>
-      <p:sp>
-        <p:nvSpPr>
-          <p:cNvPr id="4" name="Title 3"/>
+          <p:cNvPr id="2" name="Title 1"/>
           <p:cNvSpPr>
             <a:spLocks noGrp="1"/>
           </p:cNvSpPr>
@@ -8610,87 +8586,38 @@
           <a:lstStyle/>
           <a:p>
             <a:r>
-              <a:t>The Key Concepts</a:t>
+              <a:rPr sz="2400" b="1">
+                <a:latin typeface="Calibri"/>
+              </a:rPr>
+              <a:t>Loss Decreases as the Model Learns</a:t>
             </a:r>
           </a:p>
         </p:txBody>
       </p:sp>
-      <p:sp>
-        <p:nvSpPr>
-          <p:cNvPr id="5" name="Text Placeholder 4"/>
-          <p:cNvSpPr>
-            <a:spLocks noGrp="1"/>
-          </p:cNvSpPr>
-          <p:nvPr>
-            <p:ph type="body" idx="16" sz="quarter"/>
-          </p:nvPr>
-        </p:nvSpPr>
-        <p:spPr/>
-        <p:txBody>
-          <a:bodyPr/>
-          <a:lstStyle/>
-          <a:p>
-            <a:r>
-              <a:rPr sz="1400"/>
-              <a:t>Weights</a:t>
-            </a:r>
-          </a:p>
-          <a:p>
-            <a:r>
-              <a:rPr sz="1400"/>
-              <a:t>  Numbers inside the model</a:t>
-            </a:r>
-          </a:p>
-          <a:p>
-            <a:r>
-              <a:rPr sz="1400"/>
-              <a:t>  Adjusted each training step</a:t>
-            </a:r>
-          </a:p>
-          <a:p>
-            <a:r>
-              <a:rPr sz="1400"/>
-              <a:t/>
-            </a:r>
-          </a:p>
-          <a:p>
-            <a:r>
-              <a:rPr sz="1400"/>
-              <a:t>Loss</a:t>
-            </a:r>
-          </a:p>
-          <a:p>
-            <a:r>
-              <a:rPr sz="1400"/>
-              <a:t>  How wrong the predictions are</a:t>
-            </a:r>
-          </a:p>
-          <a:p>
-            <a:r>
-              <a:rPr sz="1400"/>
-              <a:t>  Training = minimise loss</a:t>
-            </a:r>
-          </a:p>
-          <a:p>
-            <a:r>
-              <a:rPr sz="1400"/>
-              <a:t/>
-            </a:r>
-          </a:p>
-          <a:p>
-            <a:r>
-              <a:rPr sz="1400"/>
-              <a:t>Epoch</a:t>
-            </a:r>
-          </a:p>
-          <a:p>
-            <a:r>
-              <a:rPr sz="1400"/>
-              <a:t>  One full pass through all data</a:t>
-            </a:r>
-          </a:p>
-        </p:txBody>
-      </p:sp>
+      <p:pic>
+        <p:nvPicPr>
+          <p:cNvPr id="3" name="Picture 2" descr="loss_curve.png"/>
+          <p:cNvPicPr>
+            <a:picLocks noChangeAspect="1"/>
+          </p:cNvPicPr>
+          <p:nvPr/>
+        </p:nvPicPr>
+        <p:blipFill>
+          <a:blip r:embed="rId2"/>
+          <a:stretch>
+            <a:fillRect/>
+          </a:stretch>
+        </p:blipFill>
+        <p:spPr>
+          <a:xfrm>
+            <a:off x="1371600" y="1371600"/>
+            <a:ext cx="9418320" cy="4131218"/>
+          </a:xfrm>
+          <a:prstGeom prst="rect">
+            <a:avLst/>
+          </a:prstGeom>
+        </p:spPr>
+      </p:pic>
     </p:spTree>
   </p:cSld>
   <p:clrMapOvr>
@@ -8716,7 +8643,7 @@
             <a:spLocks noGrp="1"/>
           </p:cNvSpPr>
           <p:nvPr>
-            <p:ph type="body" idx="13" sz="quarter"/>
+            <p:ph type="body" idx="14" sz="quarter"/>
           </p:nvPr>
         </p:nvSpPr>
         <p:spPr/>
@@ -8725,12 +8652,10 @@
           <a:lstStyle/>
           <a:p>
             <a:r>
-              <a:t>The ML Workflow</a:t>
-            </a:r>
-          </a:p>
-          <a:p>
-            <a:r>
-              <a:t>and EDA</a:t>
+              <a:rPr sz="1000">
+                <a:latin typeface="Calibri"/>
+              </a:rPr>
+              <a:t/>
             </a:r>
           </a:p>
         </p:txBody>
@@ -8738,6 +8663,110 @@
       <p:sp>
         <p:nvSpPr>
           <p:cNvPr id="3" name="Text Placeholder 2"/>
+          <p:cNvSpPr>
+            <a:spLocks noGrp="1"/>
+          </p:cNvSpPr>
+          <p:nvPr>
+            <p:ph type="body" idx="15" sz="quarter"/>
+          </p:nvPr>
+        </p:nvSpPr>
+        <p:spPr/>
+        <p:txBody>
+          <a:bodyPr/>
+          <a:lstStyle/>
+          <a:p>
+            <a:pPr>
+              <a:spcAft>
+                <a:spcPts val="400"/>
+              </a:spcAft>
+            </a:pPr>
+            <a:r>
+              <a:rPr sz="1300" b="0">
+                <a:solidFill>
+                  <a:srgbClr val="555555"/>
+                </a:solidFill>
+                <a:latin typeface="Calibri"/>
+              </a:rPr>
+              <a:t>The model finds patterns</a:t>
+            </a:r>
+          </a:p>
+          <a:p>
+            <a:pPr>
+              <a:spcAft>
+                <a:spcPts val="400"/>
+              </a:spcAft>
+            </a:pPr>
+            <a:r>
+              <a:rPr sz="1300" b="0">
+                <a:solidFill>
+                  <a:srgbClr val="555555"/>
+                </a:solidFill>
+                <a:latin typeface="Calibri"/>
+              </a:rPr>
+              <a:t>across dozens of subtle</a:t>
+            </a:r>
+          </a:p>
+          <a:p>
+            <a:pPr>
+              <a:spcAft>
+                <a:spcPts val="400"/>
+              </a:spcAft>
+            </a:pPr>
+            <a:r>
+              <a:rPr sz="1300" b="0">
+                <a:solidFill>
+                  <a:srgbClr val="555555"/>
+                </a:solidFill>
+                <a:latin typeface="Calibri"/>
+              </a:rPr>
+              <a:t>signals that no human</a:t>
+            </a:r>
+          </a:p>
+          <a:p>
+            <a:pPr>
+              <a:spcAft>
+                <a:spcPts val="400"/>
+              </a:spcAft>
+            </a:pPr>
+            <a:r>
+              <a:rPr sz="1300" b="0">
+                <a:solidFill>
+                  <a:srgbClr val="555555"/>
+                </a:solidFill>
+                <a:latin typeface="Calibri"/>
+              </a:rPr>
+              <a:t>would write as rules.</a:t>
+            </a:r>
+          </a:p>
+        </p:txBody>
+      </p:sp>
+      <p:sp>
+        <p:nvSpPr>
+          <p:cNvPr id="4" name="Title 3"/>
+          <p:cNvSpPr>
+            <a:spLocks noGrp="1"/>
+          </p:cNvSpPr>
+          <p:nvPr>
+            <p:ph type="title"/>
+          </p:nvPr>
+        </p:nvSpPr>
+        <p:spPr/>
+        <p:txBody>
+          <a:bodyPr/>
+          <a:lstStyle/>
+          <a:p>
+            <a:r>
+              <a:rPr sz="2400" b="1">
+                <a:latin typeface="Calibri"/>
+              </a:rPr>
+              <a:t>The Key Concepts</a:t>
+            </a:r>
+          </a:p>
+        </p:txBody>
+      </p:sp>
+      <p:sp>
+        <p:nvSpPr>
+          <p:cNvPr id="5" name="Text Placeholder 4"/>
           <p:cNvSpPr>
             <a:spLocks noGrp="1"/>
           </p:cNvSpPr>
@@ -8750,8 +8779,155 @@
           <a:bodyPr/>
           <a:lstStyle/>
           <a:p>
-            <a:r>
-              <a:t>04</a:t>
+            <a:pPr>
+              <a:spcAft>
+                <a:spcPts val="400"/>
+              </a:spcAft>
+            </a:pPr>
+            <a:r>
+              <a:rPr sz="1500" b="1">
+                <a:solidFill>
+                  <a:srgbClr val="0F3460"/>
+                </a:solidFill>
+                <a:latin typeface="Calibri"/>
+              </a:rPr>
+              <a:t>Weights</a:t>
+            </a:r>
+          </a:p>
+          <a:p>
+            <a:pPr>
+              <a:spcAft>
+                <a:spcPts val="400"/>
+              </a:spcAft>
+            </a:pPr>
+            <a:r>
+              <a:rPr sz="1300" b="0">
+                <a:latin typeface="Calibri"/>
+              </a:rPr>
+              <a:t>  Numbers inside the model</a:t>
+            </a:r>
+          </a:p>
+          <a:p>
+            <a:pPr>
+              <a:spcAft>
+                <a:spcPts val="400"/>
+              </a:spcAft>
+            </a:pPr>
+            <a:r>
+              <a:rPr sz="1300" b="0">
+                <a:latin typeface="Calibri"/>
+              </a:rPr>
+              <a:t>  Adjusted each training step</a:t>
+            </a:r>
+          </a:p>
+          <a:p>
+            <a:pPr>
+              <a:spcAft>
+                <a:spcPts val="400"/>
+              </a:spcAft>
+            </a:pPr>
+            <a:r>
+              <a:rPr sz="600" b="0">
+                <a:latin typeface="Calibri"/>
+              </a:rPr>
+              <a:t/>
+            </a:r>
+          </a:p>
+          <a:p>
+            <a:pPr>
+              <a:spcAft>
+                <a:spcPts val="400"/>
+              </a:spcAft>
+            </a:pPr>
+            <a:r>
+              <a:rPr sz="1500" b="1">
+                <a:solidFill>
+                  <a:srgbClr val="E94560"/>
+                </a:solidFill>
+                <a:latin typeface="Calibri"/>
+              </a:rPr>
+              <a:t>Loss</a:t>
+            </a:r>
+          </a:p>
+          <a:p>
+            <a:pPr>
+              <a:spcAft>
+                <a:spcPts val="400"/>
+              </a:spcAft>
+            </a:pPr>
+            <a:r>
+              <a:rPr sz="1300" b="0">
+                <a:latin typeface="Calibri"/>
+              </a:rPr>
+              <a:t>  How wrong the predictions are</a:t>
+            </a:r>
+          </a:p>
+          <a:p>
+            <a:pPr>
+              <a:spcAft>
+                <a:spcPts val="400"/>
+              </a:spcAft>
+            </a:pPr>
+            <a:r>
+              <a:rPr sz="1300" b="0">
+                <a:latin typeface="Calibri"/>
+              </a:rPr>
+              <a:t>  Training = minimise loss</a:t>
+            </a:r>
+          </a:p>
+          <a:p>
+            <a:pPr>
+              <a:spcAft>
+                <a:spcPts val="400"/>
+              </a:spcAft>
+            </a:pPr>
+            <a:r>
+              <a:rPr sz="600" b="0">
+                <a:latin typeface="Calibri"/>
+              </a:rPr>
+              <a:t/>
+            </a:r>
+          </a:p>
+          <a:p>
+            <a:pPr>
+              <a:spcAft>
+                <a:spcPts val="400"/>
+              </a:spcAft>
+            </a:pPr>
+            <a:r>
+              <a:rPr sz="1500" b="1">
+                <a:solidFill>
+                  <a:srgbClr val="2D6A4F"/>
+                </a:solidFill>
+                <a:latin typeface="Calibri"/>
+              </a:rPr>
+              <a:t>Epoch</a:t>
+            </a:r>
+          </a:p>
+          <a:p>
+            <a:pPr>
+              <a:spcAft>
+                <a:spcPts val="400"/>
+              </a:spcAft>
+            </a:pPr>
+            <a:r>
+              <a:rPr sz="1300" b="0">
+                <a:latin typeface="Calibri"/>
+              </a:rPr>
+              <a:t>  One full pass through all data</a:t>
+            </a:r>
+          </a:p>
+          <a:p>
+            <a:pPr>
+              <a:spcAft>
+                <a:spcPts val="400"/>
+              </a:spcAft>
+            </a:pPr>
+            <a:r>
+              <a:rPr sz="1300" b="0">
+                <a:latin typeface="Calibri"/>
+              </a:rPr>
+              <a:t>  Typical: 10–100 epochs to converge</a:t>
             </a:r>
           </a:p>
         </p:txBody>
@@ -8776,12 +8952,12 @@
       <p:grpSpPr/>
       <p:sp>
         <p:nvSpPr>
-          <p:cNvPr id="2" name="Title 1"/>
+          <p:cNvPr id="2" name="Text Placeholder 1"/>
           <p:cNvSpPr>
             <a:spLocks noGrp="1"/>
           </p:cNvSpPr>
           <p:nvPr>
-            <p:ph type="title"/>
+            <p:ph type="body" idx="13" sz="quarter"/>
           </p:nvPr>
         </p:nvSpPr>
         <p:spPr/>
@@ -8789,36 +8965,57 @@
           <a:bodyPr/>
           <a:lstStyle/>
           <a:p>
-            <a:r>
-              <a:t>Every ML Project Follows This Pipeline</a:t>
+            <a:pPr>
+              <a:spcAft>
+                <a:spcPts val="400"/>
+              </a:spcAft>
+            </a:pPr>
+            <a:r>
+              <a:rPr sz="2800" b="1">
+                <a:latin typeface="Calibri"/>
+              </a:rPr>
+              <a:t>The ML Workflow</a:t>
+            </a:r>
+          </a:p>
+          <a:p>
+            <a:pPr>
+              <a:spcAft>
+                <a:spcPts val="400"/>
+              </a:spcAft>
+            </a:pPr>
+            <a:r>
+              <a:rPr sz="2800" b="1">
+                <a:latin typeface="Calibri"/>
+              </a:rPr>
+              <a:t>and EDA</a:t>
             </a:r>
           </a:p>
         </p:txBody>
       </p:sp>
-      <p:pic>
-        <p:nvPicPr>
-          <p:cNvPr id="3" name="Picture 2" descr="workflow.png"/>
-          <p:cNvPicPr>
-            <a:picLocks noChangeAspect="1"/>
-          </p:cNvPicPr>
-          <p:nvPr/>
-        </p:nvPicPr>
-        <p:blipFill>
-          <a:blip r:embed="rId2"/>
-          <a:stretch>
-            <a:fillRect/>
-          </a:stretch>
-        </p:blipFill>
-        <p:spPr>
-          <a:xfrm>
-            <a:off x="182880" y="1463040"/>
-            <a:ext cx="11795760" cy="3966036"/>
-          </a:xfrm>
-          <a:prstGeom prst="rect">
-            <a:avLst/>
-          </a:prstGeom>
-        </p:spPr>
-      </p:pic>
+      <p:sp>
+        <p:nvSpPr>
+          <p:cNvPr id="3" name="Text Placeholder 2"/>
+          <p:cNvSpPr>
+            <a:spLocks noGrp="1"/>
+          </p:cNvSpPr>
+          <p:nvPr>
+            <p:ph type="body" idx="16" sz="quarter"/>
+          </p:nvPr>
+        </p:nvSpPr>
+        <p:spPr/>
+        <p:txBody>
+          <a:bodyPr/>
+          <a:lstStyle/>
+          <a:p>
+            <a:r>
+              <a:rPr sz="4800" b="1">
+                <a:latin typeface="Calibri"/>
+              </a:rPr>
+              <a:t>04</a:t>
+            </a:r>
+          </a:p>
+        </p:txBody>
+      </p:sp>
     </p:spTree>
   </p:cSld>
   <p:clrMapOvr>
@@ -8853,14 +9050,17 @@
           <a:lstStyle/>
           <a:p>
             <a:r>
-              <a:t>The Train / Test Split</a:t>
+              <a:rPr sz="2400" b="1">
+                <a:latin typeface="Calibri"/>
+              </a:rPr>
+              <a:t>Every ML Project Follows This Pipeline</a:t>
             </a:r>
           </a:p>
         </p:txBody>
       </p:sp>
       <p:pic>
         <p:nvPicPr>
-          <p:cNvPr id="3" name="Picture 2" descr="train_test.png"/>
+          <p:cNvPr id="3" name="Picture 2" descr="pipeline.png"/>
           <p:cNvPicPr>
             <a:picLocks noChangeAspect="1"/>
           </p:cNvPicPr>
@@ -8874,8 +9074,8 @@
         </p:blipFill>
         <p:spPr>
           <a:xfrm>
-            <a:off x="914400" y="1280160"/>
-            <a:ext cx="10332720" cy="3639030"/>
+            <a:off x="182880" y="1463040"/>
+            <a:ext cx="11795760" cy="3672071"/>
           </a:xfrm>
           <a:prstGeom prst="rect">
             <a:avLst/>
@@ -8916,14 +9116,17 @@
           <a:lstStyle/>
           <a:p>
             <a:r>
-              <a:t>EDA: Examine Data Before Training</a:t>
+              <a:rPr sz="2400" b="1">
+                <a:latin typeface="Calibri"/>
+              </a:rPr>
+              <a:t>The Train / Test Split</a:t>
             </a:r>
           </a:p>
         </p:txBody>
       </p:sp>
       <p:pic>
         <p:nvPicPr>
-          <p:cNvPr id="3" name="Picture 2" descr="eda_checklist.png"/>
+          <p:cNvPr id="3" name="Picture 2" descr="train_test.png"/>
           <p:cNvPicPr>
             <a:picLocks noChangeAspect="1"/>
           </p:cNvPicPr>
@@ -8937,8 +9140,8 @@
         </p:blipFill>
         <p:spPr>
           <a:xfrm>
-            <a:off x="914400" y="1188720"/>
-            <a:ext cx="10058400" cy="4007846"/>
+            <a:off x="914400" y="1280160"/>
+            <a:ext cx="10332720" cy="3430037"/>
           </a:xfrm>
           <a:prstGeom prst="rect">
             <a:avLst/>
@@ -8979,14 +9182,17 @@
           <a:lstStyle/>
           <a:p>
             <a:r>
-              <a:t>The Class Imbalance Problem</a:t>
+              <a:rPr sz="2400" b="1">
+                <a:latin typeface="Calibri"/>
+              </a:rPr>
+              <a:t>EDA: Examine Data Before Training</a:t>
             </a:r>
           </a:p>
         </p:txBody>
       </p:sp>
       <p:pic>
         <p:nvPicPr>
-          <p:cNvPr id="3" name="Picture 2" descr="class_imbalance.png"/>
+          <p:cNvPr id="3" name="Picture 2" descr="eda.png"/>
           <p:cNvPicPr>
             <a:picLocks noChangeAspect="1"/>
           </p:cNvPicPr>
@@ -9000,8 +9206,8 @@
         </p:blipFill>
         <p:spPr>
           <a:xfrm>
-            <a:off x="640080" y="1371600"/>
-            <a:ext cx="10972800" cy="3745424"/>
+            <a:off x="914400" y="1188720"/>
+            <a:ext cx="10058400" cy="3712275"/>
           </a:xfrm>
           <a:prstGeom prst="rect">
             <a:avLst/>
@@ -9028,12 +9234,12 @@
       <p:grpSpPr/>
       <p:sp>
         <p:nvSpPr>
-          <p:cNvPr id="2" name="Text Placeholder 1"/>
+          <p:cNvPr id="2" name="Title 1"/>
           <p:cNvSpPr>
             <a:spLocks noGrp="1"/>
           </p:cNvSpPr>
           <p:nvPr>
-            <p:ph type="body" idx="13" sz="quarter"/>
+            <p:ph type="title"/>
           </p:nvPr>
         </p:nvSpPr>
         <p:spPr/>
@@ -9042,37 +9248,38 @@
           <a:lstStyle/>
           <a:p>
             <a:r>
-              <a:t>Meet the Dataset:</a:t>
-            </a:r>
-          </a:p>
-          <a:p>
-            <a:r>
-              <a:t>Handwritten Digits</a:t>
+              <a:rPr sz="2400" b="1">
+                <a:latin typeface="Calibri"/>
+              </a:rPr>
+              <a:t>The Class Imbalance Problem</a:t>
             </a:r>
           </a:p>
         </p:txBody>
       </p:sp>
-      <p:sp>
-        <p:nvSpPr>
-          <p:cNvPr id="3" name="Text Placeholder 2"/>
-          <p:cNvSpPr>
-            <a:spLocks noGrp="1"/>
-          </p:cNvSpPr>
-          <p:nvPr>
-            <p:ph type="body" idx="16" sz="quarter"/>
-          </p:nvPr>
-        </p:nvSpPr>
-        <p:spPr/>
-        <p:txBody>
-          <a:bodyPr/>
-          <a:lstStyle/>
-          <a:p>
-            <a:r>
-              <a:t>05</a:t>
-            </a:r>
-          </a:p>
-        </p:txBody>
-      </p:sp>
+      <p:pic>
+        <p:nvPicPr>
+          <p:cNvPr id="3" name="Picture 2" descr="imbalance.png"/>
+          <p:cNvPicPr>
+            <a:picLocks noChangeAspect="1"/>
+          </p:cNvPicPr>
+          <p:nvPr/>
+        </p:nvPicPr>
+        <p:blipFill>
+          <a:blip r:embed="rId2"/>
+          <a:stretch>
+            <a:fillRect/>
+          </a:stretch>
+        </p:blipFill>
+        <p:spPr>
+          <a:xfrm>
+            <a:off x="640080" y="1371600"/>
+            <a:ext cx="10972800" cy="3800664"/>
+          </a:xfrm>
+          <a:prstGeom prst="rect">
+            <a:avLst/>
+          </a:prstGeom>
+        </p:spPr>
+      </p:pic>
     </p:spTree>
   </p:cSld>
   <p:clrMapOvr>
@@ -9093,12 +9300,12 @@
       <p:grpSpPr/>
       <p:sp>
         <p:nvSpPr>
-          <p:cNvPr id="2" name="Title 1"/>
+          <p:cNvPr id="2" name="Text Placeholder 1"/>
           <p:cNvSpPr>
             <a:spLocks noGrp="1"/>
           </p:cNvSpPr>
           <p:nvPr>
-            <p:ph type="title"/>
+            <p:ph type="body" idx="13" sz="quarter"/>
           </p:nvPr>
         </p:nvSpPr>
         <p:spPr/>
@@ -9106,36 +9313,57 @@
           <a:bodyPr/>
           <a:lstStyle/>
           <a:p>
-            <a:r>
-              <a:t>1,797 Images  -  10 Classes  -  64 Features Each</a:t>
+            <a:pPr>
+              <a:spcAft>
+                <a:spcPts val="400"/>
+              </a:spcAft>
+            </a:pPr>
+            <a:r>
+              <a:rPr sz="2800" b="1">
+                <a:latin typeface="Calibri"/>
+              </a:rPr>
+              <a:t>Meet the Dataset:</a:t>
+            </a:r>
+          </a:p>
+          <a:p>
+            <a:pPr>
+              <a:spcAft>
+                <a:spcPts val="400"/>
+              </a:spcAft>
+            </a:pPr>
+            <a:r>
+              <a:rPr sz="2800" b="1">
+                <a:latin typeface="Calibri"/>
+              </a:rPr>
+              <a:t>Handwritten Digits</a:t>
             </a:r>
           </a:p>
         </p:txBody>
       </p:sp>
-      <p:pic>
-        <p:nvPicPr>
-          <p:cNvPr id="3" name="Picture 2" descr="digit_samples.png"/>
-          <p:cNvPicPr>
-            <a:picLocks noChangeAspect="1"/>
-          </p:cNvPicPr>
-          <p:nvPr/>
-        </p:nvPicPr>
-        <p:blipFill>
-          <a:blip r:embed="rId2"/>
-          <a:stretch>
-            <a:fillRect/>
-          </a:stretch>
-        </p:blipFill>
-        <p:spPr>
-          <a:xfrm>
-            <a:off x="457200" y="1463040"/>
-            <a:ext cx="11247120" cy="2917908"/>
-          </a:xfrm>
-          <a:prstGeom prst="rect">
-            <a:avLst/>
-          </a:prstGeom>
-        </p:spPr>
-      </p:pic>
+      <p:sp>
+        <p:nvSpPr>
+          <p:cNvPr id="3" name="Text Placeholder 2"/>
+          <p:cNvSpPr>
+            <a:spLocks noGrp="1"/>
+          </p:cNvSpPr>
+          <p:nvPr>
+            <p:ph type="body" idx="16" sz="quarter"/>
+          </p:nvPr>
+        </p:nvSpPr>
+        <p:spPr/>
+        <p:txBody>
+          <a:bodyPr/>
+          <a:lstStyle/>
+          <a:p>
+            <a:r>
+              <a:rPr sz="4800" b="1">
+                <a:latin typeface="Calibri"/>
+              </a:rPr>
+              <a:t>05</a:t>
+            </a:r>
+          </a:p>
+        </p:txBody>
+      </p:sp>
     </p:spTree>
   </p:cSld>
   <p:clrMapOvr>
@@ -9169,38 +9397,98 @@
           <a:bodyPr/>
           <a:lstStyle/>
           <a:p>
-            <a:r>
-              <a:rPr sz="1600"/>
+            <a:pPr>
+              <a:spcAft>
+                <a:spcPts val="400"/>
+              </a:spcAft>
+            </a:pPr>
+            <a:r>
+              <a:rPr sz="1600" b="0">
+                <a:solidFill>
+                  <a:srgbClr val="1A1A2E"/>
+                </a:solidFill>
+                <a:latin typeface="Calibri"/>
+              </a:rPr>
               <a:t>Traditional programming vs machine learning</a:t>
             </a:r>
           </a:p>
           <a:p>
-            <a:r>
-              <a:rPr sz="1600"/>
+            <a:pPr>
+              <a:spcAft>
+                <a:spcPts val="400"/>
+              </a:spcAft>
+            </a:pPr>
+            <a:r>
+              <a:rPr sz="1600" b="0">
+                <a:solidFill>
+                  <a:srgbClr val="1A1A2E"/>
+                </a:solidFill>
+                <a:latin typeface="Calibri"/>
+              </a:rPr>
               <a:t>The three types of ML</a:t>
             </a:r>
           </a:p>
           <a:p>
-            <a:r>
-              <a:rPr sz="1600"/>
-              <a:t>How a model learns - the training loop</a:t>
-            </a:r>
-          </a:p>
-          <a:p>
-            <a:r>
-              <a:rPr sz="1600"/>
-              <a:t>The ML workflow and EDA</a:t>
-            </a:r>
-          </a:p>
-          <a:p>
-            <a:r>
-              <a:rPr sz="1600"/>
+            <a:pPr>
+              <a:spcAft>
+                <a:spcPts val="400"/>
+              </a:spcAft>
+            </a:pPr>
+            <a:r>
+              <a:rPr sz="1600" b="0">
+                <a:solidFill>
+                  <a:srgbClr val="1A1A2E"/>
+                </a:solidFill>
+                <a:latin typeface="Calibri"/>
+              </a:rPr>
+              <a:t>How a model learns — the training loop</a:t>
+            </a:r>
+          </a:p>
+          <a:p>
+            <a:pPr>
+              <a:spcAft>
+                <a:spcPts val="400"/>
+              </a:spcAft>
+            </a:pPr>
+            <a:r>
+              <a:rPr sz="1600" b="0">
+                <a:solidFill>
+                  <a:srgbClr val="1A1A2E"/>
+                </a:solidFill>
+                <a:latin typeface="Calibri"/>
+              </a:rPr>
+              <a:t>The ML workflow and exploratory data analysis</a:t>
+            </a:r>
+          </a:p>
+          <a:p>
+            <a:pPr>
+              <a:spcAft>
+                <a:spcPts val="400"/>
+              </a:spcAft>
+            </a:pPr>
+            <a:r>
+              <a:rPr sz="1600" b="0">
+                <a:solidFill>
+                  <a:srgbClr val="1A1A2E"/>
+                </a:solidFill>
+                <a:latin typeface="Calibri"/>
+              </a:rPr>
               <a:t>Meet the dataset: handwritten digits</a:t>
             </a:r>
           </a:p>
           <a:p>
-            <a:r>
-              <a:rPr sz="1600"/>
+            <a:pPr>
+              <a:spcAft>
+                <a:spcPts val="400"/>
+              </a:spcAft>
+            </a:pPr>
+            <a:r>
+              <a:rPr sz="1600" b="0">
+                <a:solidFill>
+                  <a:srgbClr val="1A1A2E"/>
+                </a:solidFill>
+                <a:latin typeface="Calibri"/>
+              </a:rPr>
               <a:t>Python tools and getting started</a:t>
             </a:r>
           </a:p>
@@ -9222,7 +9510,10 @@
           <a:lstStyle/>
           <a:p>
             <a:r>
-              <a:t>What We'll Cover</a:t>
+              <a:rPr sz="2800" b="1">
+                <a:latin typeface="Calibri"/>
+              </a:rPr>
+              <a:t>What We’ll Cover</a:t>
             </a:r>
           </a:p>
         </p:txBody>
@@ -9261,14 +9552,17 @@
           <a:lstStyle/>
           <a:p>
             <a:r>
-              <a:t>What the Model Actually Sees</a:t>
+              <a:rPr sz="2200" b="1">
+                <a:latin typeface="Calibri"/>
+              </a:rPr>
+              <a:t>1,797 Images  —  10 Classes  —  64 Features Each</a:t>
             </a:r>
           </a:p>
         </p:txBody>
       </p:sp>
       <p:pic>
         <p:nvPicPr>
-          <p:cNvPr id="3" name="Picture 2" descr="what_model_sees.png"/>
+          <p:cNvPr id="3" name="Picture 2" descr="digit_samples.png"/>
           <p:cNvPicPr>
             <a:picLocks noChangeAspect="1"/>
           </p:cNvPicPr>
@@ -9282,8 +9576,8 @@
         </p:blipFill>
         <p:spPr>
           <a:xfrm>
-            <a:off x="914400" y="1371600"/>
-            <a:ext cx="10058400" cy="4375436"/>
+            <a:off x="457200" y="1463040"/>
+            <a:ext cx="11247120" cy="2672447"/>
           </a:xfrm>
           <a:prstGeom prst="rect">
             <a:avLst/>
@@ -9324,14 +9618,17 @@
           <a:lstStyle/>
           <a:p>
             <a:r>
-              <a:t>Average Image per Class: The Learned Prototypes</a:t>
+              <a:rPr sz="2400" b="1">
+                <a:latin typeface="Calibri"/>
+              </a:rPr>
+              <a:t>What the Model Actually Sees</a:t>
             </a:r>
           </a:p>
         </p:txBody>
       </p:sp>
       <p:pic>
         <p:nvPicPr>
-          <p:cNvPr id="3" name="Picture 2" descr="avg_digits.png"/>
+          <p:cNvPr id="3" name="Picture 2" descr="pixel_grid.png"/>
           <p:cNvPicPr>
             <a:picLocks noChangeAspect="1"/>
           </p:cNvPicPr>
@@ -9345,8 +9642,8 @@
         </p:blipFill>
         <p:spPr>
           <a:xfrm>
-            <a:off x="457200" y="1828800"/>
-            <a:ext cx="11247120" cy="1322330"/>
+            <a:off x="914400" y="1371600"/>
+            <a:ext cx="10058400" cy="4648840"/>
           </a:xfrm>
           <a:prstGeom prst="rect">
             <a:avLst/>
@@ -9387,14 +9684,17 @@
           <a:lstStyle/>
           <a:p>
             <a:r>
-              <a:t>Features (X) and Labels (y): The Universal Structure</a:t>
+              <a:rPr sz="2200" b="1">
+                <a:latin typeface="Calibri"/>
+              </a:rPr>
+              <a:t>Average Image per Class: The Learned Prototypes</a:t>
             </a:r>
           </a:p>
         </p:txBody>
       </p:sp>
       <p:pic>
         <p:nvPicPr>
-          <p:cNvPr id="3" name="Picture 2" descr="features_labels.png"/>
+          <p:cNvPr id="3" name="Picture 2" descr="avg_digits.png"/>
           <p:cNvPicPr>
             <a:picLocks noChangeAspect="1"/>
           </p:cNvPicPr>
@@ -9408,8 +9708,8 @@
         </p:blipFill>
         <p:spPr>
           <a:xfrm>
-            <a:off x="640080" y="1188720"/>
-            <a:ext cx="10972800" cy="4001845"/>
+            <a:off x="457200" y="1828800"/>
+            <a:ext cx="11247120" cy="1596898"/>
           </a:xfrm>
           <a:prstGeom prst="rect">
             <a:avLst/>
@@ -9436,12 +9736,12 @@
       <p:grpSpPr/>
       <p:sp>
         <p:nvSpPr>
-          <p:cNvPr id="2" name="Text Placeholder 1"/>
+          <p:cNvPr id="2" name="Title 1"/>
           <p:cNvSpPr>
             <a:spLocks noGrp="1"/>
           </p:cNvSpPr>
           <p:nvPr>
-            <p:ph type="body" idx="13" sz="quarter"/>
+            <p:ph type="title"/>
           </p:nvPr>
         </p:nvSpPr>
         <p:spPr/>
@@ -9450,37 +9750,38 @@
           <a:lstStyle/>
           <a:p>
             <a:r>
-              <a:t>Python Tools</a:t>
-            </a:r>
-          </a:p>
-          <a:p>
-            <a:r>
-              <a:t>and Getting Started</a:t>
+              <a:rPr sz="2200" b="1">
+                <a:latin typeface="Calibri"/>
+              </a:rPr>
+              <a:t>Features (X) and Labels (y): The Universal Structure</a:t>
             </a:r>
           </a:p>
         </p:txBody>
       </p:sp>
-      <p:sp>
-        <p:nvSpPr>
-          <p:cNvPr id="3" name="Text Placeholder 2"/>
-          <p:cNvSpPr>
-            <a:spLocks noGrp="1"/>
-          </p:cNvSpPr>
-          <p:nvPr>
-            <p:ph type="body" idx="16" sz="quarter"/>
-          </p:nvPr>
-        </p:nvSpPr>
-        <p:spPr/>
-        <p:txBody>
-          <a:bodyPr/>
-          <a:lstStyle/>
-          <a:p>
-            <a:r>
-              <a:t>06</a:t>
-            </a:r>
-          </a:p>
-        </p:txBody>
-      </p:sp>
+      <p:pic>
+        <p:nvPicPr>
+          <p:cNvPr id="3" name="Picture 2" descr="features_labels.png"/>
+          <p:cNvPicPr>
+            <a:picLocks noChangeAspect="1"/>
+          </p:cNvPicPr>
+          <p:nvPr/>
+        </p:nvPicPr>
+        <p:blipFill>
+          <a:blip r:embed="rId2"/>
+          <a:stretch>
+            <a:fillRect/>
+          </a:stretch>
+        </p:blipFill>
+        <p:spPr>
+          <a:xfrm>
+            <a:off x="640080" y="1188720"/>
+            <a:ext cx="10972800" cy="3705908"/>
+          </a:xfrm>
+          <a:prstGeom prst="rect">
+            <a:avLst/>
+          </a:prstGeom>
+        </p:spPr>
+      </p:pic>
     </p:spTree>
   </p:cSld>
   <p:clrMapOvr>
@@ -9501,12 +9802,12 @@
       <p:grpSpPr/>
       <p:sp>
         <p:nvSpPr>
-          <p:cNvPr id="2" name="Title 1"/>
+          <p:cNvPr id="2" name="Text Placeholder 1"/>
           <p:cNvSpPr>
             <a:spLocks noGrp="1"/>
           </p:cNvSpPr>
           <p:nvPr>
-            <p:ph type="title"/>
+            <p:ph type="body" idx="13" sz="quarter"/>
           </p:nvPr>
         </p:nvSpPr>
         <p:spPr/>
@@ -9514,36 +9815,57 @@
           <a:bodyPr/>
           <a:lstStyle/>
           <a:p>
-            <a:r>
-              <a:t>Four Libraries You'll Use in Every Lesson</a:t>
+            <a:pPr>
+              <a:spcAft>
+                <a:spcPts val="400"/>
+              </a:spcAft>
+            </a:pPr>
+            <a:r>
+              <a:rPr sz="2800" b="1">
+                <a:latin typeface="Calibri"/>
+              </a:rPr>
+              <a:t>Python Tools</a:t>
+            </a:r>
+          </a:p>
+          <a:p>
+            <a:pPr>
+              <a:spcAft>
+                <a:spcPts val="400"/>
+              </a:spcAft>
+            </a:pPr>
+            <a:r>
+              <a:rPr sz="2800" b="1">
+                <a:latin typeface="Calibri"/>
+              </a:rPr>
+              <a:t>and Getting Started</a:t>
             </a:r>
           </a:p>
         </p:txBody>
       </p:sp>
-      <p:pic>
-        <p:nvPicPr>
-          <p:cNvPr id="3" name="Picture 2" descr="python_tools.png"/>
-          <p:cNvPicPr>
-            <a:picLocks noChangeAspect="1"/>
-          </p:cNvPicPr>
-          <p:nvPr/>
-        </p:nvPicPr>
-        <p:blipFill>
-          <a:blip r:embed="rId2"/>
-          <a:stretch>
-            <a:fillRect/>
-          </a:stretch>
-        </p:blipFill>
-        <p:spPr>
-          <a:xfrm>
-            <a:off x="640080" y="1645920"/>
-            <a:ext cx="10972800" cy="3072384"/>
-          </a:xfrm>
-          <a:prstGeom prst="rect">
-            <a:avLst/>
-          </a:prstGeom>
-        </p:spPr>
-      </p:pic>
+      <p:sp>
+        <p:nvSpPr>
+          <p:cNvPr id="3" name="Text Placeholder 2"/>
+          <p:cNvSpPr>
+            <a:spLocks noGrp="1"/>
+          </p:cNvSpPr>
+          <p:nvPr>
+            <p:ph type="body" idx="16" sz="quarter"/>
+          </p:nvPr>
+        </p:nvSpPr>
+        <p:spPr/>
+        <p:txBody>
+          <a:bodyPr/>
+          <a:lstStyle/>
+          <a:p>
+            <a:r>
+              <a:rPr sz="4800" b="1">
+                <a:latin typeface="Calibri"/>
+              </a:rPr>
+              <a:t>06</a:t>
+            </a:r>
+          </a:p>
+        </p:txBody>
+      </p:sp>
     </p:spTree>
   </p:cSld>
   <p:clrMapOvr>
@@ -9578,115 +9900,38 @@
           <a:lstStyle/>
           <a:p>
             <a:r>
-              <a:t>Key Vocabulary</a:t>
+              <a:rPr sz="2400" b="1">
+                <a:latin typeface="Calibri"/>
+              </a:rPr>
+              <a:t>Four Libraries You’ll Use in Every Lesson</a:t>
             </a:r>
           </a:p>
         </p:txBody>
       </p:sp>
-      <p:sp>
-        <p:nvSpPr>
-          <p:cNvPr id="3" name="Content Placeholder 2"/>
-          <p:cNvSpPr>
-            <a:spLocks noGrp="1"/>
-          </p:cNvSpPr>
-          <p:nvPr>
-            <p:ph idx="2" sz="half"/>
-          </p:nvPr>
-        </p:nvSpPr>
-        <p:spPr/>
-        <p:txBody>
-          <a:bodyPr/>
-          <a:lstStyle/>
-          <a:p>
-            <a:r>
-              <a:rPr sz="1400"/>
-              <a:t>Feature - one measurable input</a:t>
-            </a:r>
-          </a:p>
-          <a:p>
-            <a:r>
-              <a:rPr sz="1400"/>
-              <a:t>Label - the answer to predict</a:t>
-            </a:r>
-          </a:p>
-          <a:p>
-            <a:r>
-              <a:rPr sz="1400"/>
-              <a:t>Sample - one row of data</a:t>
-            </a:r>
-          </a:p>
-          <a:p>
-            <a:r>
-              <a:rPr sz="1400"/>
-              <a:t>Training set - data for learning</a:t>
-            </a:r>
-          </a:p>
-          <a:p>
-            <a:r>
-              <a:rPr sz="1400"/>
-              <a:t>Test set - data for evaluation</a:t>
-            </a:r>
-          </a:p>
-          <a:p>
-            <a:r>
-              <a:rPr sz="1400"/>
-              <a:t>Model - the learned function</a:t>
-            </a:r>
-          </a:p>
-        </p:txBody>
-      </p:sp>
-      <p:sp>
-        <p:nvSpPr>
-          <p:cNvPr id="4" name="Content Placeholder 3"/>
-          <p:cNvSpPr>
-            <a:spLocks noGrp="1"/>
-          </p:cNvSpPr>
-          <p:nvPr>
-            <p:ph idx="12" sz="half"/>
-          </p:nvPr>
-        </p:nvSpPr>
-        <p:spPr/>
-        <p:txBody>
-          <a:bodyPr/>
-          <a:lstStyle/>
-          <a:p>
-            <a:r>
-              <a:rPr sz="1400"/>
-              <a:t>Weights - adjustable parameters</a:t>
-            </a:r>
-          </a:p>
-          <a:p>
-            <a:r>
-              <a:rPr sz="1400"/>
-              <a:t>Loss - prediction error</a:t>
-            </a:r>
-          </a:p>
-          <a:p>
-            <a:r>
-              <a:rPr sz="1400"/>
-              <a:t>Epoch - one pass through data</a:t>
-            </a:r>
-          </a:p>
-          <a:p>
-            <a:r>
-              <a:rPr sz="1400"/>
-              <a:t>Overfitting - memorised, not learned</a:t>
-            </a:r>
-          </a:p>
-          <a:p>
-            <a:r>
-              <a:rPr sz="1400"/>
-              <a:t>Underfitting - too simple</a:t>
-            </a:r>
-          </a:p>
-          <a:p>
-            <a:r>
-              <a:rPr sz="1400"/>
-              <a:t>Class imbalance - skewed labels</a:t>
-            </a:r>
-          </a:p>
-        </p:txBody>
-      </p:sp>
+      <p:pic>
+        <p:nvPicPr>
+          <p:cNvPr id="3" name="Picture 2" descr="libraries.png"/>
+          <p:cNvPicPr>
+            <a:picLocks noChangeAspect="1"/>
+          </p:cNvPicPr>
+          <p:nvPr/>
+        </p:nvPicPr>
+        <p:blipFill>
+          <a:blip r:embed="rId2"/>
+          <a:stretch>
+            <a:fillRect/>
+          </a:stretch>
+        </p:blipFill>
+        <p:spPr>
+          <a:xfrm>
+            <a:off x="640080" y="1645920"/>
+            <a:ext cx="10972800" cy="3053751"/>
+          </a:xfrm>
+          <a:prstGeom prst="rect">
+            <a:avLst/>
+          </a:prstGeom>
+        </p:spPr>
+      </p:pic>
     </p:spTree>
   </p:cSld>
   <p:clrMapOvr>
@@ -9721,7 +9966,10 @@
           <a:lstStyle/>
           <a:p>
             <a:r>
-              <a:t>Workshop: 5 Hands-On Exercises</a:t>
+              <a:rPr sz="2400" b="1">
+                <a:latin typeface="Calibri"/>
+              </a:rPr>
+              <a:t>Key Vocabulary</a:t>
             </a:r>
           </a:p>
         </p:txBody>
@@ -9733,7 +9981,7 @@
             <a:spLocks noGrp="1"/>
           </p:cNvSpPr>
           <p:nvPr>
-            <p:ph idx="1"/>
+            <p:ph idx="2" sz="half"/>
           </p:nvPr>
         </p:nvSpPr>
         <p:spPr/>
@@ -9741,51 +9989,367 @@
           <a:bodyPr/>
           <a:lstStyle/>
           <a:p>
-            <a:r>
-              <a:rPr sz="1600"/>
-              <a:t>Exercise 1:  Load the digits dataset into a DataFrame</a:t>
-            </a:r>
-          </a:p>
-          <a:p>
-            <a:r>
-              <a:rPr sz="1600"/>
-              <a:t>Exercise 2:  Shape, statistics, and missing values</a:t>
-            </a:r>
-          </a:p>
-          <a:p>
-            <a:r>
-              <a:rPr sz="1600"/>
-              <a:t>Exercise 3:  Class balance and the accuracy trap</a:t>
-            </a:r>
-          </a:p>
-          <a:p>
-            <a:r>
-              <a:rPr sz="1600"/>
-              <a:t>Exercise 4:  Visualise samples and average prototypes</a:t>
-            </a:r>
-          </a:p>
-          <a:p>
-            <a:r>
-              <a:rPr sz="1600"/>
-              <a:t>Exercise 5:  What the model sees - numbers and correlations</a:t>
-            </a:r>
-          </a:p>
-          <a:p>
-            <a:r>
-              <a:rPr sz="1600"/>
-              <a:t/>
-            </a:r>
-          </a:p>
-          <a:p>
-            <a:r>
-              <a:rPr sz="1600"/>
-              <a:t>Each exercise: lecture.md (concept) + handson.md (build it yourself)</a:t>
-            </a:r>
-          </a:p>
-          <a:p>
-            <a:r>
-              <a:rPr sz="1600"/>
-              <a:t>Solution files provided to check your work</a:t>
+            <a:pPr>
+              <a:spcAft>
+                <a:spcPts val="400"/>
+              </a:spcAft>
+            </a:pPr>
+            <a:r>
+              <a:rPr sz="1400" b="1">
+                <a:solidFill>
+                  <a:srgbClr val="0F3460"/>
+                </a:solidFill>
+                <a:latin typeface="Calibri"/>
+              </a:rPr>
+              <a:t>Feature</a:t>
+            </a:r>
+          </a:p>
+          <a:p>
+            <a:pPr>
+              <a:spcAft>
+                <a:spcPts val="400"/>
+              </a:spcAft>
+            </a:pPr>
+            <a:r>
+              <a:rPr sz="1300" b="0">
+                <a:latin typeface="Calibri"/>
+              </a:rPr>
+              <a:t>  One measurable input value</a:t>
+            </a:r>
+          </a:p>
+          <a:p>
+            <a:pPr>
+              <a:spcAft>
+                <a:spcPts val="400"/>
+              </a:spcAft>
+            </a:pPr>
+            <a:r>
+              <a:rPr sz="1400" b="1">
+                <a:solidFill>
+                  <a:srgbClr val="0F3460"/>
+                </a:solidFill>
+                <a:latin typeface="Calibri"/>
+              </a:rPr>
+              <a:t>Label</a:t>
+            </a:r>
+          </a:p>
+          <a:p>
+            <a:pPr>
+              <a:spcAft>
+                <a:spcPts val="400"/>
+              </a:spcAft>
+            </a:pPr>
+            <a:r>
+              <a:rPr sz="1300" b="0">
+                <a:latin typeface="Calibri"/>
+              </a:rPr>
+              <a:t>  The answer to predict</a:t>
+            </a:r>
+          </a:p>
+          <a:p>
+            <a:pPr>
+              <a:spcAft>
+                <a:spcPts val="400"/>
+              </a:spcAft>
+            </a:pPr>
+            <a:r>
+              <a:rPr sz="1400" b="1">
+                <a:solidFill>
+                  <a:srgbClr val="0F3460"/>
+                </a:solidFill>
+                <a:latin typeface="Calibri"/>
+              </a:rPr>
+              <a:t>Sample</a:t>
+            </a:r>
+          </a:p>
+          <a:p>
+            <a:pPr>
+              <a:spcAft>
+                <a:spcPts val="400"/>
+              </a:spcAft>
+            </a:pPr>
+            <a:r>
+              <a:rPr sz="1300" b="0">
+                <a:latin typeface="Calibri"/>
+              </a:rPr>
+              <a:t>  One row of data</a:t>
+            </a:r>
+          </a:p>
+          <a:p>
+            <a:pPr>
+              <a:spcAft>
+                <a:spcPts val="400"/>
+              </a:spcAft>
+            </a:pPr>
+            <a:r>
+              <a:rPr sz="1400" b="1">
+                <a:solidFill>
+                  <a:srgbClr val="0F3460"/>
+                </a:solidFill>
+                <a:latin typeface="Calibri"/>
+              </a:rPr>
+              <a:t>Training set</a:t>
+            </a:r>
+          </a:p>
+          <a:p>
+            <a:pPr>
+              <a:spcAft>
+                <a:spcPts val="400"/>
+              </a:spcAft>
+            </a:pPr>
+            <a:r>
+              <a:rPr sz="1300" b="0">
+                <a:latin typeface="Calibri"/>
+              </a:rPr>
+              <a:t>  Data used for learning</a:t>
+            </a:r>
+          </a:p>
+          <a:p>
+            <a:pPr>
+              <a:spcAft>
+                <a:spcPts val="400"/>
+              </a:spcAft>
+            </a:pPr>
+            <a:r>
+              <a:rPr sz="1400" b="1">
+                <a:solidFill>
+                  <a:srgbClr val="0F3460"/>
+                </a:solidFill>
+                <a:latin typeface="Calibri"/>
+              </a:rPr>
+              <a:t>Test set</a:t>
+            </a:r>
+          </a:p>
+          <a:p>
+            <a:pPr>
+              <a:spcAft>
+                <a:spcPts val="400"/>
+              </a:spcAft>
+            </a:pPr>
+            <a:r>
+              <a:rPr sz="1300" b="0">
+                <a:latin typeface="Calibri"/>
+              </a:rPr>
+              <a:t>  Data reserved for evaluation</a:t>
+            </a:r>
+          </a:p>
+          <a:p>
+            <a:pPr>
+              <a:spcAft>
+                <a:spcPts val="400"/>
+              </a:spcAft>
+            </a:pPr>
+            <a:r>
+              <a:rPr sz="1400" b="1">
+                <a:solidFill>
+                  <a:srgbClr val="0F3460"/>
+                </a:solidFill>
+                <a:latin typeface="Calibri"/>
+              </a:rPr>
+              <a:t>Model</a:t>
+            </a:r>
+          </a:p>
+          <a:p>
+            <a:pPr>
+              <a:spcAft>
+                <a:spcPts val="400"/>
+              </a:spcAft>
+            </a:pPr>
+            <a:r>
+              <a:rPr sz="1300" b="0">
+                <a:latin typeface="Calibri"/>
+              </a:rPr>
+              <a:t>  The learned function f(X) → y</a:t>
+            </a:r>
+          </a:p>
+        </p:txBody>
+      </p:sp>
+      <p:sp>
+        <p:nvSpPr>
+          <p:cNvPr id="4" name="Content Placeholder 3"/>
+          <p:cNvSpPr>
+            <a:spLocks noGrp="1"/>
+          </p:cNvSpPr>
+          <p:nvPr>
+            <p:ph idx="12" sz="half"/>
+          </p:nvPr>
+        </p:nvSpPr>
+        <p:spPr/>
+        <p:txBody>
+          <a:bodyPr/>
+          <a:lstStyle/>
+          <a:p>
+            <a:pPr>
+              <a:spcAft>
+                <a:spcPts val="400"/>
+              </a:spcAft>
+            </a:pPr>
+            <a:r>
+              <a:rPr sz="1400" b="1">
+                <a:solidFill>
+                  <a:srgbClr val="E94560"/>
+                </a:solidFill>
+                <a:latin typeface="Calibri"/>
+              </a:rPr>
+              <a:t>Weights</a:t>
+            </a:r>
+          </a:p>
+          <a:p>
+            <a:pPr>
+              <a:spcAft>
+                <a:spcPts val="400"/>
+              </a:spcAft>
+            </a:pPr>
+            <a:r>
+              <a:rPr sz="1300" b="0">
+                <a:latin typeface="Calibri"/>
+              </a:rPr>
+              <a:t>  Adjustable internal parameters</a:t>
+            </a:r>
+          </a:p>
+          <a:p>
+            <a:pPr>
+              <a:spcAft>
+                <a:spcPts val="400"/>
+              </a:spcAft>
+            </a:pPr>
+            <a:r>
+              <a:rPr sz="1400" b="1">
+                <a:solidFill>
+                  <a:srgbClr val="E94560"/>
+                </a:solidFill>
+                <a:latin typeface="Calibri"/>
+              </a:rPr>
+              <a:t>Loss</a:t>
+            </a:r>
+          </a:p>
+          <a:p>
+            <a:pPr>
+              <a:spcAft>
+                <a:spcPts val="400"/>
+              </a:spcAft>
+            </a:pPr>
+            <a:r>
+              <a:rPr sz="1300" b="0">
+                <a:latin typeface="Calibri"/>
+              </a:rPr>
+              <a:t>  Prediction error (lower is better)</a:t>
+            </a:r>
+          </a:p>
+          <a:p>
+            <a:pPr>
+              <a:spcAft>
+                <a:spcPts val="400"/>
+              </a:spcAft>
+            </a:pPr>
+            <a:r>
+              <a:rPr sz="1400" b="1">
+                <a:solidFill>
+                  <a:srgbClr val="E94560"/>
+                </a:solidFill>
+                <a:latin typeface="Calibri"/>
+              </a:rPr>
+              <a:t>Epoch</a:t>
+            </a:r>
+          </a:p>
+          <a:p>
+            <a:pPr>
+              <a:spcAft>
+                <a:spcPts val="400"/>
+              </a:spcAft>
+            </a:pPr>
+            <a:r>
+              <a:rPr sz="1300" b="0">
+                <a:latin typeface="Calibri"/>
+              </a:rPr>
+              <a:t>  One complete pass through data</a:t>
+            </a:r>
+          </a:p>
+          <a:p>
+            <a:pPr>
+              <a:spcAft>
+                <a:spcPts val="400"/>
+              </a:spcAft>
+            </a:pPr>
+            <a:r>
+              <a:rPr sz="1400" b="1">
+                <a:solidFill>
+                  <a:srgbClr val="E94560"/>
+                </a:solidFill>
+                <a:latin typeface="Calibri"/>
+              </a:rPr>
+              <a:t>Overfitting</a:t>
+            </a:r>
+          </a:p>
+          <a:p>
+            <a:pPr>
+              <a:spcAft>
+                <a:spcPts val="400"/>
+              </a:spcAft>
+            </a:pPr>
+            <a:r>
+              <a:rPr sz="1300" b="0">
+                <a:latin typeface="Calibri"/>
+              </a:rPr>
+              <a:t>  Model memorised, didn’t learn</a:t>
+            </a:r>
+          </a:p>
+          <a:p>
+            <a:pPr>
+              <a:spcAft>
+                <a:spcPts val="400"/>
+              </a:spcAft>
+            </a:pPr>
+            <a:r>
+              <a:rPr sz="1400" b="1">
+                <a:solidFill>
+                  <a:srgbClr val="E94560"/>
+                </a:solidFill>
+                <a:latin typeface="Calibri"/>
+              </a:rPr>
+              <a:t>Underfitting</a:t>
+            </a:r>
+          </a:p>
+          <a:p>
+            <a:pPr>
+              <a:spcAft>
+                <a:spcPts val="400"/>
+              </a:spcAft>
+            </a:pPr>
+            <a:r>
+              <a:rPr sz="1300" b="0">
+                <a:latin typeface="Calibri"/>
+              </a:rPr>
+              <a:t>  Model too simple for the patterns</a:t>
+            </a:r>
+          </a:p>
+          <a:p>
+            <a:pPr>
+              <a:spcAft>
+                <a:spcPts val="400"/>
+              </a:spcAft>
+            </a:pPr>
+            <a:r>
+              <a:rPr sz="1400" b="1">
+                <a:solidFill>
+                  <a:srgbClr val="E94560"/>
+                </a:solidFill>
+                <a:latin typeface="Calibri"/>
+              </a:rPr>
+              <a:t>Class imbalance</a:t>
+            </a:r>
+          </a:p>
+          <a:p>
+            <a:pPr>
+              <a:spcAft>
+                <a:spcPts val="400"/>
+              </a:spcAft>
+            </a:pPr>
+            <a:r>
+              <a:rPr sz="1300" b="0">
+                <a:latin typeface="Calibri"/>
+              </a:rPr>
+              <a:t>  Labels are heavily skewed</a:t>
             </a:r>
           </a:p>
         </p:txBody>
@@ -9810,59 +10374,7 @@
       <p:grpSpPr/>
       <p:sp>
         <p:nvSpPr>
-          <p:cNvPr id="2" name="Text Placeholder 1"/>
-          <p:cNvSpPr>
-            <a:spLocks noGrp="1"/>
-          </p:cNvSpPr>
-          <p:nvPr>
-            <p:ph type="body" idx="12" sz="quarter"/>
-          </p:nvPr>
-        </p:nvSpPr>
-        <p:spPr/>
-        <p:txBody>
-          <a:bodyPr/>
-          <a:lstStyle/>
-          <a:p>
-            <a:r>
-              <a:rPr sz="1500"/>
-              <a:t>ML finds patterns from examples - no hand-crafted rules</a:t>
-            </a:r>
-          </a:p>
-          <a:p>
-            <a:r>
-              <a:rPr sz="1500"/>
-              <a:t>Supervised learning (X -&gt; y) is most common in security</a:t>
-            </a:r>
-          </a:p>
-          <a:p>
-            <a:r>
-              <a:rPr sz="1500"/>
-              <a:t>Training = adjusting weights to minimise loss over epochs</a:t>
-            </a:r>
-          </a:p>
-          <a:p>
-            <a:r>
-              <a:rPr sz="1500"/>
-              <a:t>Always: data -&gt; EDA -&gt; split -&gt; train -&gt; evaluate -&gt; tune</a:t>
-            </a:r>
-          </a:p>
-          <a:p>
-            <a:r>
-              <a:rPr sz="1500"/>
-              <a:t>Never evaluate on training data - it measures memorisation</a:t>
-            </a:r>
-          </a:p>
-          <a:p>
-            <a:r>
-              <a:rPr sz="1500"/>
-              <a:t>Class imbalance is everywhere in security - accuracy misleads</a:t>
-            </a:r>
-          </a:p>
-        </p:txBody>
-      </p:sp>
-      <p:sp>
-        <p:nvSpPr>
-          <p:cNvPr id="3" name="Title 2"/>
+          <p:cNvPr id="2" name="Title 1"/>
           <p:cNvSpPr>
             <a:spLocks noGrp="1"/>
           </p:cNvSpPr>
@@ -9876,12 +10388,136 @@
           <a:lstStyle/>
           <a:p>
             <a:r>
-              <a:t>Key</a:t>
-            </a:r>
-          </a:p>
-          <a:p>
-            <a:r>
-              <a:t>Takeaways</a:t>
+              <a:rPr sz="2400" b="1">
+                <a:latin typeface="Calibri"/>
+              </a:rPr>
+              <a:t>Workshop: 5 Hands-On Exercises</a:t>
+            </a:r>
+          </a:p>
+        </p:txBody>
+      </p:sp>
+      <p:sp>
+        <p:nvSpPr>
+          <p:cNvPr id="3" name="Content Placeholder 2"/>
+          <p:cNvSpPr>
+            <a:spLocks noGrp="1"/>
+          </p:cNvSpPr>
+          <p:nvPr>
+            <p:ph idx="1"/>
+          </p:nvPr>
+        </p:nvSpPr>
+        <p:spPr/>
+        <p:txBody>
+          <a:bodyPr/>
+          <a:lstStyle/>
+          <a:p>
+            <a:pPr>
+              <a:spcAft>
+                <a:spcPts val="400"/>
+              </a:spcAft>
+            </a:pPr>
+            <a:r>
+              <a:rPr sz="1500" b="0">
+                <a:latin typeface="Calibri"/>
+              </a:rPr>
+              <a:t>Exercise 1:  Load the digits dataset into a DataFrame</a:t>
+            </a:r>
+          </a:p>
+          <a:p>
+            <a:pPr>
+              <a:spcAft>
+                <a:spcPts val="400"/>
+              </a:spcAft>
+            </a:pPr>
+            <a:r>
+              <a:rPr sz="1500" b="0">
+                <a:latin typeface="Calibri"/>
+              </a:rPr>
+              <a:t>Exercise 2:  Shape, statistics, and missing values</a:t>
+            </a:r>
+          </a:p>
+          <a:p>
+            <a:pPr>
+              <a:spcAft>
+                <a:spcPts val="400"/>
+              </a:spcAft>
+            </a:pPr>
+            <a:r>
+              <a:rPr sz="1500" b="0">
+                <a:latin typeface="Calibri"/>
+              </a:rPr>
+              <a:t>Exercise 3:  Class balance and the accuracy trap</a:t>
+            </a:r>
+          </a:p>
+          <a:p>
+            <a:pPr>
+              <a:spcAft>
+                <a:spcPts val="400"/>
+              </a:spcAft>
+            </a:pPr>
+            <a:r>
+              <a:rPr sz="1500" b="0">
+                <a:latin typeface="Calibri"/>
+              </a:rPr>
+              <a:t>Exercise 4:  Visualise samples and average prototypes</a:t>
+            </a:r>
+          </a:p>
+          <a:p>
+            <a:pPr>
+              <a:spcAft>
+                <a:spcPts val="400"/>
+              </a:spcAft>
+            </a:pPr>
+            <a:r>
+              <a:rPr sz="1500" b="0">
+                <a:latin typeface="Calibri"/>
+              </a:rPr>
+              <a:t>Exercise 5:  What the model sees — numbers and correlations</a:t>
+            </a:r>
+          </a:p>
+          <a:p>
+            <a:pPr>
+              <a:spcAft>
+                <a:spcPts val="400"/>
+              </a:spcAft>
+            </a:pPr>
+            <a:r>
+              <a:rPr sz="800" b="0">
+                <a:latin typeface="Calibri"/>
+              </a:rPr>
+              <a:t/>
+            </a:r>
+          </a:p>
+          <a:p>
+            <a:pPr>
+              <a:spcAft>
+                <a:spcPts val="400"/>
+              </a:spcAft>
+            </a:pPr>
+            <a:r>
+              <a:rPr sz="1300" b="0">
+                <a:solidFill>
+                  <a:srgbClr val="666666"/>
+                </a:solidFill>
+                <a:latin typeface="Calibri"/>
+              </a:rPr>
+              <a:t>Each exercise:  lecture.md (concept)  +  handson.md (build it yourself)</a:t>
+            </a:r>
+          </a:p>
+          <a:p>
+            <a:pPr>
+              <a:spcAft>
+                <a:spcPts val="400"/>
+              </a:spcAft>
+            </a:pPr>
+            <a:r>
+              <a:rPr sz="1300" b="0">
+                <a:solidFill>
+                  <a:srgbClr val="666666"/>
+                </a:solidFill>
+                <a:latin typeface="Calibri"/>
+              </a:rPr>
+              <a:t>Solution files provided to check your work</a:t>
             </a:r>
           </a:p>
         </p:txBody>
@@ -9911,6 +10547,160 @@
             <a:spLocks noGrp="1"/>
           </p:cNvSpPr>
           <p:nvPr>
+            <p:ph type="body" idx="12" sz="quarter"/>
+          </p:nvPr>
+        </p:nvSpPr>
+        <p:spPr/>
+        <p:txBody>
+          <a:bodyPr/>
+          <a:lstStyle/>
+          <a:p>
+            <a:pPr>
+              <a:spcAft>
+                <a:spcPts val="400"/>
+              </a:spcAft>
+            </a:pPr>
+            <a:r>
+              <a:rPr sz="1500" b="0">
+                <a:latin typeface="Calibri"/>
+              </a:rPr>
+              <a:t>ML finds patterns from examples — no hand-crafted rules</a:t>
+            </a:r>
+          </a:p>
+          <a:p>
+            <a:pPr>
+              <a:spcAft>
+                <a:spcPts val="400"/>
+              </a:spcAft>
+            </a:pPr>
+            <a:r>
+              <a:rPr sz="1500" b="0">
+                <a:latin typeface="Calibri"/>
+              </a:rPr>
+              <a:t>Supervised learning (X → y) is the most common type in security</a:t>
+            </a:r>
+          </a:p>
+          <a:p>
+            <a:pPr>
+              <a:spcAft>
+                <a:spcPts val="400"/>
+              </a:spcAft>
+            </a:pPr>
+            <a:r>
+              <a:rPr sz="1500" b="0">
+                <a:latin typeface="Calibri"/>
+              </a:rPr>
+              <a:t>Training = adjusting weights to minimise loss over epochs</a:t>
+            </a:r>
+          </a:p>
+          <a:p>
+            <a:pPr>
+              <a:spcAft>
+                <a:spcPts val="400"/>
+              </a:spcAft>
+            </a:pPr>
+            <a:r>
+              <a:rPr sz="1500" b="0">
+                <a:latin typeface="Calibri"/>
+              </a:rPr>
+              <a:t>Always: collect → EDA → split → train → evaluate → tune</a:t>
+            </a:r>
+          </a:p>
+          <a:p>
+            <a:pPr>
+              <a:spcAft>
+                <a:spcPts val="400"/>
+              </a:spcAft>
+            </a:pPr>
+            <a:r>
+              <a:rPr sz="1500" b="0">
+                <a:latin typeface="Calibri"/>
+              </a:rPr>
+              <a:t>Never evaluate on training data — it measures memorisation</a:t>
+            </a:r>
+          </a:p>
+          <a:p>
+            <a:pPr>
+              <a:spcAft>
+                <a:spcPts val="400"/>
+              </a:spcAft>
+            </a:pPr>
+            <a:r>
+              <a:rPr sz="1500" b="0">
+                <a:latin typeface="Calibri"/>
+              </a:rPr>
+              <a:t>Class imbalance is everywhere in security — accuracy misleads</a:t>
+            </a:r>
+          </a:p>
+        </p:txBody>
+      </p:sp>
+      <p:sp>
+        <p:nvSpPr>
+          <p:cNvPr id="3" name="Title 2"/>
+          <p:cNvSpPr>
+            <a:spLocks noGrp="1"/>
+          </p:cNvSpPr>
+          <p:nvPr>
+            <p:ph type="title"/>
+          </p:nvPr>
+        </p:nvSpPr>
+        <p:spPr/>
+        <p:txBody>
+          <a:bodyPr/>
+          <a:lstStyle/>
+          <a:p>
+            <a:pPr>
+              <a:spcAft>
+                <a:spcPts val="400"/>
+              </a:spcAft>
+            </a:pPr>
+            <a:r>
+              <a:rPr sz="2800" b="1">
+                <a:latin typeface="Calibri"/>
+              </a:rPr>
+              <a:t>Key</a:t>
+            </a:r>
+          </a:p>
+          <a:p>
+            <a:pPr>
+              <a:spcAft>
+                <a:spcPts val="400"/>
+              </a:spcAft>
+            </a:pPr>
+            <a:r>
+              <a:rPr sz="2800" b="1">
+                <a:latin typeface="Calibri"/>
+              </a:rPr>
+              <a:t>Takeaways</a:t>
+            </a:r>
+          </a:p>
+        </p:txBody>
+      </p:sp>
+    </p:spTree>
+  </p:cSld>
+  <p:clrMapOvr>
+    <a:masterClrMapping/>
+  </p:clrMapOvr>
+</p:sld>
+</file>
+
+<file path=ppt/slides/slide29.xml><?xml version="1.0" encoding="utf-8"?>
+<p:sld xmlns:a="http://schemas.openxmlformats.org/drawingml/2006/main" xmlns:p="http://schemas.openxmlformats.org/presentationml/2006/main" xmlns:r="http://schemas.openxmlformats.org/officeDocument/2006/relationships">
+  <p:cSld>
+    <p:spTree>
+      <p:nvGrpSpPr>
+        <p:cNvPr id="1" name=""/>
+        <p:cNvGrpSpPr/>
+        <p:nvPr/>
+      </p:nvGrpSpPr>
+      <p:grpSpPr/>
+      <p:sp>
+        <p:nvSpPr>
+          <p:cNvPr id="2" name="Text Placeholder 1"/>
+          <p:cNvSpPr>
+            <a:spLocks noGrp="1"/>
+          </p:cNvSpPr>
+          <p:nvPr>
             <p:ph type="body" idx="13" sz="quarter"/>
           </p:nvPr>
         </p:nvSpPr>
@@ -9920,7 +10710,10 @@
           <a:lstStyle/>
           <a:p>
             <a:r>
-              <a:t>Next:  Lesson 1.2 - Linear Regression</a:t>
+              <a:rPr sz="1800">
+                <a:latin typeface="Calibri"/>
+              </a:rPr>
+              <a:t>Next:  Lesson 1.2 — Linear Regression</a:t>
             </a:r>
           </a:p>
         </p:txBody>
@@ -9941,6 +10734,9 @@
           <a:lstStyle/>
           <a:p>
             <a:r>
+              <a:rPr sz="3200" b="1">
+                <a:latin typeface="Calibri"/>
+              </a:rPr>
               <a:t>What is Machine Learning?</a:t>
             </a:r>
           </a:p>
@@ -9979,12 +10775,28 @@
           <a:bodyPr/>
           <a:lstStyle/>
           <a:p>
-            <a:r>
+            <a:pPr>
+              <a:spcAft>
+                <a:spcPts val="400"/>
+              </a:spcAft>
+            </a:pPr>
+            <a:r>
+              <a:rPr sz="2800" b="1">
+                <a:latin typeface="Calibri"/>
+              </a:rPr>
               <a:t>Traditional Programming</a:t>
             </a:r>
           </a:p>
           <a:p>
-            <a:r>
+            <a:pPr>
+              <a:spcAft>
+                <a:spcPts val="400"/>
+              </a:spcAft>
+            </a:pPr>
+            <a:r>
+              <a:rPr sz="2800" b="1">
+                <a:latin typeface="Calibri"/>
+              </a:rPr>
               <a:t>vs Machine Learning</a:t>
             </a:r>
           </a:p>
@@ -10006,6 +10818,9 @@
           <a:lstStyle/>
           <a:p>
             <a:r>
+              <a:rPr sz="4800" b="1">
+                <a:latin typeface="Calibri"/>
+              </a:rPr>
               <a:t>01</a:t>
             </a:r>
           </a:p>
@@ -10045,6 +10860,9 @@
           <a:lstStyle/>
           <a:p>
             <a:r>
+              <a:rPr sz="2400" b="1">
+                <a:latin typeface="Calibri"/>
+              </a:rPr>
               <a:t>Two Approaches to Problem Solving</a:t>
             </a:r>
           </a:p>
@@ -10065,63 +10883,145 @@
           <a:bodyPr/>
           <a:lstStyle/>
           <a:p>
-            <a:r>
-              <a:rPr sz="1400"/>
+            <a:pPr>
+              <a:spcAft>
+                <a:spcPts val="400"/>
+              </a:spcAft>
+            </a:pPr>
+            <a:r>
+              <a:rPr sz="1600" b="1">
+                <a:solidFill>
+                  <a:srgbClr val="E94560"/>
+                </a:solidFill>
+                <a:latin typeface="Calibri"/>
+              </a:rPr>
               <a:t>Traditional Programming</a:t>
             </a:r>
           </a:p>
           <a:p>
-            <a:r>
-              <a:rPr sz="1400"/>
+            <a:pPr>
+              <a:spcAft>
+                <a:spcPts val="400"/>
+              </a:spcAft>
+            </a:pPr>
+            <a:r>
+              <a:rPr sz="600" b="0">
+                <a:latin typeface="Calibri"/>
+              </a:rPr>
               <a:t/>
             </a:r>
           </a:p>
           <a:p>
-            <a:r>
-              <a:rPr sz="1400"/>
+            <a:pPr>
+              <a:spcAft>
+                <a:spcPts val="400"/>
+              </a:spcAft>
+            </a:pPr>
+            <a:r>
+              <a:rPr sz="1400" b="0">
+                <a:latin typeface="Calibri"/>
+              </a:rPr>
               <a:t>You write explicit rules:</a:t>
             </a:r>
           </a:p>
           <a:p>
-            <a:r>
-              <a:rPr sz="1400"/>
+            <a:pPr>
+              <a:spcAft>
+                <a:spcPts val="400"/>
+              </a:spcAft>
+            </a:pPr>
+            <a:r>
+              <a:rPr sz="1300" b="0">
+                <a:solidFill>
+                  <a:srgbClr val="555555"/>
+                </a:solidFill>
+                <a:latin typeface="Calibri"/>
+              </a:rPr>
               <a:t>  if "free money" in email: spam</a:t>
             </a:r>
           </a:p>
           <a:p>
-            <a:r>
-              <a:rPr sz="1400"/>
-              <a:t>  if sender unknown: spam</a:t>
-            </a:r>
-          </a:p>
-          <a:p>
-            <a:r>
-              <a:rPr sz="1400"/>
+            <a:pPr>
+              <a:spcAft>
+                <a:spcPts val="400"/>
+              </a:spcAft>
+            </a:pPr>
+            <a:r>
+              <a:rPr sz="1300" b="0">
+                <a:solidFill>
+                  <a:srgbClr val="555555"/>
+                </a:solidFill>
+                <a:latin typeface="Calibri"/>
+              </a:rPr>
+              <a:t>  if sender_unknown: spam</a:t>
+            </a:r>
+          </a:p>
+          <a:p>
+            <a:pPr>
+              <a:spcAft>
+                <a:spcPts val="400"/>
+              </a:spcAft>
+            </a:pPr>
+            <a:r>
+              <a:rPr sz="600" b="0">
+                <a:latin typeface="Calibri"/>
+              </a:rPr>
               <a:t/>
             </a:r>
           </a:p>
           <a:p>
-            <a:r>
-              <a:rPr sz="1400"/>
+            <a:pPr>
+              <a:spcAft>
+                <a:spcPts val="400"/>
+              </a:spcAft>
+            </a:pPr>
+            <a:r>
+              <a:rPr sz="1400" b="1">
+                <a:solidFill>
+                  <a:srgbClr val="1A1A2E"/>
+                </a:solidFill>
+                <a:latin typeface="Calibri"/>
+              </a:rPr>
               <a:t>Problem:</a:t>
             </a:r>
           </a:p>
           <a:p>
-            <a:r>
-              <a:rPr sz="1400"/>
+            <a:pPr>
+              <a:spcAft>
+                <a:spcPts val="400"/>
+              </a:spcAft>
+            </a:pPr>
+            <a:r>
+              <a:rPr sz="1300" b="0">
+                <a:latin typeface="Calibri"/>
+              </a:rPr>
               <a:t>  Attackers learn your rules</a:t>
             </a:r>
           </a:p>
           <a:p>
-            <a:r>
-              <a:rPr sz="1400"/>
+            <a:pPr>
+              <a:spcAft>
+                <a:spcPts val="400"/>
+              </a:spcAft>
+            </a:pPr>
+            <a:r>
+              <a:rPr sz="1300" b="0">
+                <a:latin typeface="Calibri"/>
+              </a:rPr>
               <a:t>  Change one word, bypass the filter</a:t>
             </a:r>
           </a:p>
           <a:p>
-            <a:r>
-              <a:rPr sz="1400"/>
-              <a:t>  Rules don't scale to millions of signals</a:t>
+            <a:pPr>
+              <a:spcAft>
+                <a:spcPts val="400"/>
+              </a:spcAft>
+            </a:pPr>
+            <a:r>
+              <a:rPr sz="1300" b="0">
+                <a:latin typeface="Calibri"/>
+              </a:rPr>
+              <a:t>  Rules don’t scale to millions of signals</a:t>
             </a:r>
           </a:p>
         </p:txBody>
@@ -10141,62 +11041,144 @@
           <a:bodyPr/>
           <a:lstStyle/>
           <a:p>
-            <a:r>
-              <a:rPr sz="1400"/>
+            <a:pPr>
+              <a:spcAft>
+                <a:spcPts val="400"/>
+              </a:spcAft>
+            </a:pPr>
+            <a:r>
+              <a:rPr sz="1600" b="1">
+                <a:solidFill>
+                  <a:srgbClr val="2D6A4F"/>
+                </a:solidFill>
+                <a:latin typeface="Calibri"/>
+              </a:rPr>
               <a:t>Machine Learning</a:t>
             </a:r>
           </a:p>
           <a:p>
-            <a:r>
-              <a:rPr sz="1400"/>
+            <a:pPr>
+              <a:spcAft>
+                <a:spcPts val="400"/>
+              </a:spcAft>
+            </a:pPr>
+            <a:r>
+              <a:rPr sz="600" b="0">
+                <a:latin typeface="Calibri"/>
+              </a:rPr>
               <a:t/>
             </a:r>
           </a:p>
           <a:p>
-            <a:r>
-              <a:rPr sz="1400"/>
+            <a:pPr>
+              <a:spcAft>
+                <a:spcPts val="400"/>
+              </a:spcAft>
+            </a:pPr>
+            <a:r>
+              <a:rPr sz="1400" b="0">
+                <a:latin typeface="Calibri"/>
+              </a:rPr>
               <a:t>You provide labelled examples:</a:t>
             </a:r>
           </a:p>
           <a:p>
-            <a:r>
-              <a:rPr sz="1400"/>
+            <a:pPr>
+              <a:spcAft>
+                <a:spcPts val="400"/>
+              </a:spcAft>
+            </a:pPr>
+            <a:r>
+              <a:rPr sz="1300" b="0">
+                <a:solidFill>
+                  <a:srgbClr val="555555"/>
+                </a:solidFill>
+                <a:latin typeface="Calibri"/>
+              </a:rPr>
               <a:t>  10,000 emails tagged spam / legit</a:t>
             </a:r>
           </a:p>
           <a:p>
-            <a:r>
-              <a:rPr sz="1400"/>
+            <a:pPr>
+              <a:spcAft>
+                <a:spcPts val="400"/>
+              </a:spcAft>
+            </a:pPr>
+            <a:r>
+              <a:rPr sz="1300" b="0">
+                <a:solidFill>
+                  <a:srgbClr val="555555"/>
+                </a:solidFill>
+                <a:latin typeface="Calibri"/>
+              </a:rPr>
               <a:t>  Model discovers the patterns itself</a:t>
             </a:r>
           </a:p>
           <a:p>
-            <a:r>
-              <a:rPr sz="1400"/>
+            <a:pPr>
+              <a:spcAft>
+                <a:spcPts val="400"/>
+              </a:spcAft>
+            </a:pPr>
+            <a:r>
+              <a:rPr sz="600" b="0">
+                <a:latin typeface="Calibri"/>
+              </a:rPr>
               <a:t/>
             </a:r>
           </a:p>
           <a:p>
-            <a:r>
-              <a:rPr sz="1400"/>
+            <a:pPr>
+              <a:spcAft>
+                <a:spcPts val="400"/>
+              </a:spcAft>
+            </a:pPr>
+            <a:r>
+              <a:rPr sz="1400" b="1">
+                <a:solidFill>
+                  <a:srgbClr val="1A1A2E"/>
+                </a:solidFill>
+                <a:latin typeface="Calibri"/>
+              </a:rPr>
               <a:t>Advantage:</a:t>
             </a:r>
           </a:p>
           <a:p>
-            <a:r>
-              <a:rPr sz="1400"/>
-              <a:t>  Catches subtle combinations</a:t>
-            </a:r>
-          </a:p>
-          <a:p>
-            <a:r>
-              <a:rPr sz="1400"/>
+            <a:pPr>
+              <a:spcAft>
+                <a:spcPts val="400"/>
+              </a:spcAft>
+            </a:pPr>
+            <a:r>
+              <a:rPr sz="1300" b="0">
+                <a:latin typeface="Calibri"/>
+              </a:rPr>
+              <a:t>  Catches subtle signal combinations</a:t>
+            </a:r>
+          </a:p>
+          <a:p>
+            <a:pPr>
+              <a:spcAft>
+                <a:spcPts val="400"/>
+              </a:spcAft>
+            </a:pPr>
+            <a:r>
+              <a:rPr sz="1300" b="0">
+                <a:latin typeface="Calibri"/>
+              </a:rPr>
               <a:t>  Adapts when new data arrives</a:t>
             </a:r>
           </a:p>
           <a:p>
-            <a:r>
-              <a:rPr sz="1400"/>
+            <a:pPr>
+              <a:spcAft>
+                <a:spcPts val="400"/>
+              </a:spcAft>
+            </a:pPr>
+            <a:r>
+              <a:rPr sz="1300" b="0">
+                <a:latin typeface="Calibri"/>
+              </a:rPr>
               <a:t>  Scales across entire organisations</a:t>
             </a:r>
           </a:p>
@@ -10236,6 +11218,9 @@
           <a:lstStyle/>
           <a:p>
             <a:r>
+              <a:rPr sz="2400" b="1">
+                <a:latin typeface="Calibri"/>
+              </a:rPr>
               <a:t>The Fundamental Difference</a:t>
             </a:r>
           </a:p>
@@ -10243,7 +11228,7 @@
       </p:sp>
       <p:pic>
         <p:nvPicPr>
-          <p:cNvPr id="3" name="Picture 2" descr="trad_vs_ml.png"/>
+          <p:cNvPr id="3" name="Picture 2" descr="fundamental_diff.png"/>
           <p:cNvPicPr>
             <a:picLocks noChangeAspect="1"/>
           </p:cNvPicPr>
@@ -10258,7 +11243,7 @@
         <p:spPr>
           <a:xfrm>
             <a:off x="640080" y="1371600"/>
-            <a:ext cx="10972800" cy="3728170"/>
+            <a:ext cx="10972800" cy="3519577"/>
           </a:xfrm>
           <a:prstGeom prst="rect">
             <a:avLst/>
@@ -10299,6 +11284,9 @@
           <a:lstStyle/>
           <a:p>
             <a:r>
+              <a:rPr sz="1000">
+                <a:latin typeface="Calibri"/>
+              </a:rPr>
               <a:t/>
             </a:r>
           </a:p>
@@ -10319,26 +11307,66 @@
           <a:bodyPr/>
           <a:lstStyle/>
           <a:p>
-            <a:r>
-              <a:rPr sz="1400"/>
+            <a:pPr>
+              <a:spcAft>
+                <a:spcPts val="400"/>
+              </a:spcAft>
+            </a:pPr>
+            <a:r>
+              <a:rPr sz="1300" b="0">
+                <a:solidFill>
+                  <a:srgbClr val="555555"/>
+                </a:solidFill>
+                <a:latin typeface="Calibri"/>
+              </a:rPr>
               <a:t>Attackers constantly change</a:t>
             </a:r>
           </a:p>
           <a:p>
-            <a:r>
-              <a:rPr sz="1400"/>
+            <a:pPr>
+              <a:spcAft>
+                <a:spcPts val="400"/>
+              </a:spcAft>
+            </a:pPr>
+            <a:r>
+              <a:rPr sz="1300" b="0">
+                <a:solidFill>
+                  <a:srgbClr val="555555"/>
+                </a:solidFill>
+                <a:latin typeface="Calibri"/>
+              </a:rPr>
               <a:t>tactics, but their statistical</a:t>
             </a:r>
           </a:p>
           <a:p>
-            <a:r>
-              <a:rPr sz="1400"/>
+            <a:pPr>
+              <a:spcAft>
+                <a:spcPts val="400"/>
+              </a:spcAft>
+            </a:pPr>
+            <a:r>
+              <a:rPr sz="1300" b="0">
+                <a:solidFill>
+                  <a:srgbClr val="555555"/>
+                </a:solidFill>
+                <a:latin typeface="Calibri"/>
+              </a:rPr>
               <a:t>patterns persist across</a:t>
             </a:r>
           </a:p>
           <a:p>
-            <a:r>
-              <a:rPr sz="1400"/>
+            <a:pPr>
+              <a:spcAft>
+                <a:spcPts val="400"/>
+              </a:spcAft>
+            </a:pPr>
+            <a:r>
+              <a:rPr sz="1300" b="0">
+                <a:solidFill>
+                  <a:srgbClr val="555555"/>
+                </a:solidFill>
+                <a:latin typeface="Calibri"/>
+              </a:rPr>
               <a:t>campaigns.</a:t>
             </a:r>
           </a:p>
@@ -10360,6 +11388,9 @@
           <a:lstStyle/>
           <a:p>
             <a:r>
+              <a:rPr sz="2400" b="1">
+                <a:latin typeface="Calibri"/>
+              </a:rPr>
               <a:t>Why This Matters for Security</a:t>
             </a:r>
           </a:p>
@@ -10380,50 +11411,115 @@
           <a:bodyPr/>
           <a:lstStyle/>
           <a:p>
-            <a:r>
-              <a:rPr sz="1400"/>
-              <a:t>Already in production:</a:t>
-            </a:r>
-          </a:p>
-          <a:p>
-            <a:r>
-              <a:rPr sz="1400"/>
-              <a:t>  Email filters (99.9% spam blocked)</a:t>
-            </a:r>
-          </a:p>
-          <a:p>
-            <a:r>
-              <a:rPr sz="1400"/>
-              <a:t>  Endpoint detection (behavioural)</a:t>
-            </a:r>
-          </a:p>
-          <a:p>
-            <a:r>
-              <a:rPr sz="1400"/>
-              <a:t>  SIEM (anomaly scoring)</a:t>
-            </a:r>
-          </a:p>
-          <a:p>
-            <a:r>
-              <a:rPr sz="1400"/>
-              <a:t>  Network IDS (traffic classification)</a:t>
-            </a:r>
-          </a:p>
-          <a:p>
-            <a:r>
-              <a:rPr sz="1400"/>
+            <a:pPr>
+              <a:spcAft>
+                <a:spcPts val="400"/>
+              </a:spcAft>
+            </a:pPr>
+            <a:r>
+              <a:rPr sz="1500" b="1">
+                <a:solidFill>
+                  <a:srgbClr val="1A1A2E"/>
+                </a:solidFill>
+                <a:latin typeface="Calibri"/>
+              </a:rPr>
+              <a:t>Already deployed in production:</a:t>
+            </a:r>
+          </a:p>
+          <a:p>
+            <a:pPr>
+              <a:spcAft>
+                <a:spcPts val="400"/>
+              </a:spcAft>
+            </a:pPr>
+            <a:r>
+              <a:rPr sz="1300" b="0">
+                <a:latin typeface="Calibri"/>
+              </a:rPr>
+              <a:t>  Email filters — 99.9% spam blocked before inbox</a:t>
+            </a:r>
+          </a:p>
+          <a:p>
+            <a:pPr>
+              <a:spcAft>
+                <a:spcPts val="400"/>
+              </a:spcAft>
+            </a:pPr>
+            <a:r>
+              <a:rPr sz="1300" b="0">
+                <a:latin typeface="Calibri"/>
+              </a:rPr>
+              <a:t>  Endpoint detection — behavioural analysis</a:t>
+            </a:r>
+          </a:p>
+          <a:p>
+            <a:pPr>
+              <a:spcAft>
+                <a:spcPts val="400"/>
+              </a:spcAft>
+            </a:pPr>
+            <a:r>
+              <a:rPr sz="1300" b="0">
+                <a:latin typeface="Calibri"/>
+              </a:rPr>
+              <a:t>  SIEM — anomaly scoring on log streams</a:t>
+            </a:r>
+          </a:p>
+          <a:p>
+            <a:pPr>
+              <a:spcAft>
+                <a:spcPts val="400"/>
+              </a:spcAft>
+            </a:pPr>
+            <a:r>
+              <a:rPr sz="1300" b="0">
+                <a:latin typeface="Calibri"/>
+              </a:rPr>
+              <a:t>  Network IDS — traffic classification</a:t>
+            </a:r>
+          </a:p>
+          <a:p>
+            <a:pPr>
+              <a:spcAft>
+                <a:spcPts val="400"/>
+              </a:spcAft>
+            </a:pPr>
+            <a:r>
+              <a:rPr sz="600" b="0">
+                <a:latin typeface="Calibri"/>
+              </a:rPr>
               <a:t/>
             </a:r>
           </a:p>
           <a:p>
-            <a:r>
-              <a:rPr sz="1400"/>
-              <a:t>Traditional rules are reactive;</a:t>
-            </a:r>
-          </a:p>
-          <a:p>
-            <a:r>
-              <a:rPr sz="1400"/>
+            <a:pPr>
+              <a:spcAft>
+                <a:spcPts val="400"/>
+              </a:spcAft>
+            </a:pPr>
+            <a:r>
+              <a:rPr sz="1400" b="1">
+                <a:solidFill>
+                  <a:srgbClr val="E94560"/>
+                </a:solidFill>
+                <a:latin typeface="Calibri"/>
+              </a:rPr>
+              <a:t>Traditional rules are reactive.</a:t>
+            </a:r>
+          </a:p>
+          <a:p>
+            <a:pPr>
+              <a:spcAft>
+                <a:spcPts val="400"/>
+              </a:spcAft>
+            </a:pPr>
+            <a:r>
+              <a:rPr sz="1400" b="1">
+                <a:solidFill>
+                  <a:srgbClr val="2D6A4F"/>
+                </a:solidFill>
+                <a:latin typeface="Calibri"/>
+              </a:rPr>
               <a:t>ML models are predictive.</a:t>
             </a:r>
           </a:p>
@@ -10438,6 +11534,72 @@
 </file>
 
 <file path=ppt/slides/slide7.xml><?xml version="1.0" encoding="utf-8"?>
+<p:sld xmlns:a="http://schemas.openxmlformats.org/drawingml/2006/main" xmlns:p="http://schemas.openxmlformats.org/presentationml/2006/main" xmlns:r="http://schemas.openxmlformats.org/officeDocument/2006/relationships">
+  <p:cSld>
+    <p:spTree>
+      <p:nvGrpSpPr>
+        <p:cNvPr id="1" name=""/>
+        <p:cNvGrpSpPr/>
+        <p:nvPr/>
+      </p:nvGrpSpPr>
+      <p:grpSpPr/>
+      <p:sp>
+        <p:nvSpPr>
+          <p:cNvPr id="2" name="Title 1"/>
+          <p:cNvSpPr>
+            <a:spLocks noGrp="1"/>
+          </p:cNvSpPr>
+          <p:nvPr>
+            <p:ph type="title"/>
+          </p:nvPr>
+        </p:nvSpPr>
+        <p:spPr/>
+        <p:txBody>
+          <a:bodyPr/>
+          <a:lstStyle/>
+          <a:p>
+            <a:r>
+              <a:rPr sz="2400" b="1">
+                <a:latin typeface="Calibri"/>
+              </a:rPr>
+              <a:t>Real-World Example: Phishing URL Detection</a:t>
+            </a:r>
+          </a:p>
+        </p:txBody>
+      </p:sp>
+      <p:pic>
+        <p:nvPicPr>
+          <p:cNvPr id="3" name="Picture 2" descr="phishing_pipeline.png"/>
+          <p:cNvPicPr>
+            <a:picLocks noChangeAspect="1"/>
+          </p:cNvPicPr>
+          <p:nvPr/>
+        </p:nvPicPr>
+        <p:blipFill>
+          <a:blip r:embed="rId2"/>
+          <a:stretch>
+            <a:fillRect/>
+          </a:stretch>
+        </p:blipFill>
+        <p:spPr>
+          <a:xfrm>
+            <a:off x="457200" y="1280160"/>
+            <a:ext cx="11247120" cy="4085039"/>
+          </a:xfrm>
+          <a:prstGeom prst="rect">
+            <a:avLst/>
+          </a:prstGeom>
+        </p:spPr>
+      </p:pic>
+    </p:spTree>
+  </p:cSld>
+  <p:clrMapOvr>
+    <a:masterClrMapping/>
+  </p:clrMapOvr>
+</p:sld>
+</file>
+
+<file path=ppt/slides/slide8.xml><?xml version="1.0" encoding="utf-8"?>
 <p:sld xmlns:a="http://schemas.openxmlformats.org/drawingml/2006/main" xmlns:p="http://schemas.openxmlformats.org/presentationml/2006/main" xmlns:r="http://schemas.openxmlformats.org/officeDocument/2006/relationships">
   <p:cSld>
     <p:spTree>
@@ -10462,12 +11624,28 @@
           <a:bodyPr/>
           <a:lstStyle/>
           <a:p>
-            <a:r>
+            <a:pPr>
+              <a:spcAft>
+                <a:spcPts val="400"/>
+              </a:spcAft>
+            </a:pPr>
+            <a:r>
+              <a:rPr sz="2800" b="1">
+                <a:latin typeface="Calibri"/>
+              </a:rPr>
               <a:t>The Three Types of</a:t>
             </a:r>
           </a:p>
           <a:p>
-            <a:r>
+            <a:pPr>
+              <a:spcAft>
+                <a:spcPts val="400"/>
+              </a:spcAft>
+            </a:pPr>
+            <a:r>
+              <a:rPr sz="2800" b="1">
+                <a:latin typeface="Calibri"/>
+              </a:rPr>
               <a:t>Machine Learning</a:t>
             </a:r>
           </a:p>
@@ -10489,6 +11667,9 @@
           <a:lstStyle/>
           <a:p>
             <a:r>
+              <a:rPr sz="4800" b="1">
+                <a:latin typeface="Calibri"/>
+              </a:rPr>
               <a:t>02</a:t>
             </a:r>
           </a:p>
@@ -10502,7 +11683,7 @@
 </p:sld>
 </file>
 
-<file path=ppt/slides/slide8.xml><?xml version="1.0" encoding="utf-8"?>
+<file path=ppt/slides/slide9.xml><?xml version="1.0" encoding="utf-8"?>
 <p:sld xmlns:a="http://schemas.openxmlformats.org/drawingml/2006/main" xmlns:p="http://schemas.openxmlformats.org/presentationml/2006/main" xmlns:r="http://schemas.openxmlformats.org/officeDocument/2006/relationships">
   <p:cSld>
     <p:spTree>
@@ -10528,6 +11709,9 @@
           <a:lstStyle/>
           <a:p>
             <a:r>
+              <a:rPr sz="2200" b="1">
+                <a:latin typeface="Calibri"/>
+              </a:rPr>
               <a:t>Supervised, Unsupervised, and Reinforcement Learning</a:t>
             </a:r>
           </a:p>
@@ -10535,7 +11719,7 @@
       </p:sp>
       <p:pic>
         <p:nvPicPr>
-          <p:cNvPr id="3" name="Picture 2" descr="three_types.png"/>
+          <p:cNvPr id="3" name="Picture 2" descr="ml_types.png"/>
           <p:cNvPicPr>
             <a:picLocks noChangeAspect="1"/>
           </p:cNvPicPr>
@@ -10550,78 +11734,13 @@
         <p:spPr>
           <a:xfrm>
             <a:off x="457200" y="1371600"/>
-            <a:ext cx="11247120" cy="3610789"/>
+            <a:ext cx="11247120" cy="3083888"/>
           </a:xfrm>
           <a:prstGeom prst="rect">
             <a:avLst/>
           </a:prstGeom>
         </p:spPr>
       </p:pic>
-    </p:spTree>
-  </p:cSld>
-  <p:clrMapOvr>
-    <a:masterClrMapping/>
-  </p:clrMapOvr>
-</p:sld>
-</file>
-
-<file path=ppt/slides/slide9.xml><?xml version="1.0" encoding="utf-8"?>
-<p:sld xmlns:a="http://schemas.openxmlformats.org/drawingml/2006/main" xmlns:p="http://schemas.openxmlformats.org/presentationml/2006/main" xmlns:r="http://schemas.openxmlformats.org/officeDocument/2006/relationships">
-  <p:cSld>
-    <p:spTree>
-      <p:nvGrpSpPr>
-        <p:cNvPr id="1" name=""/>
-        <p:cNvGrpSpPr/>
-        <p:nvPr/>
-      </p:nvGrpSpPr>
-      <p:grpSpPr/>
-      <p:sp>
-        <p:nvSpPr>
-          <p:cNvPr id="2" name="Text Placeholder 1"/>
-          <p:cNvSpPr>
-            <a:spLocks noGrp="1"/>
-          </p:cNvSpPr>
-          <p:nvPr>
-            <p:ph type="body" idx="13" sz="quarter"/>
-          </p:nvPr>
-        </p:nvSpPr>
-        <p:spPr/>
-        <p:txBody>
-          <a:bodyPr/>
-          <a:lstStyle/>
-          <a:p>
-            <a:r>
-              <a:t>How a Model</a:t>
-            </a:r>
-          </a:p>
-          <a:p>
-            <a:r>
-              <a:t>Actually Learns</a:t>
-            </a:r>
-          </a:p>
-        </p:txBody>
-      </p:sp>
-      <p:sp>
-        <p:nvSpPr>
-          <p:cNvPr id="3" name="Text Placeholder 2"/>
-          <p:cNvSpPr>
-            <a:spLocks noGrp="1"/>
-          </p:cNvSpPr>
-          <p:nvPr>
-            <p:ph type="body" idx="16" sz="quarter"/>
-          </p:nvPr>
-        </p:nvSpPr>
-        <p:spPr/>
-        <p:txBody>
-          <a:bodyPr/>
-          <a:lstStyle/>
-          <a:p>
-            <a:r>
-              <a:t>03</a:t>
-            </a:r>
-          </a:p>
-        </p:txBody>
-      </p:sp>
     </p:spTree>
   </p:cSld>
   <p:clrMapOvr>

</xml_diff>